<commit_message>
pitch: less text per slide (details in speaker notes), names on the cover (Elias, Isaak, Timo)
Co-Authored-By: Claude Opus 5.5 (1M context) <noreply@anthropic.com>
</commit_message>
<xml_diff>
--- a/docs/presentation/pitch.pptx
+++ b/docs/presentation/pitch.pptx
@@ -113,19 +113,19 @@
   <p:extLst>
     <p:ext uri="{521415D9-36F7-43E2-AB2F-B90AF26B5E84}">
       <p14:sectionLst xmlns:p14="http://schemas.microsoft.com/office/powerpoint/2010/main">
-        <p14:section name="Why" id="{c7459cde-8508-e15d-ff03-f5bbaa19765c}">
+        <p14:section name="Why" id="{3de4b236-e1e0-7c48-dae6-f7bc5f85186f}">
           <p14:sldIdLst>
             <p14:sldId id="256"/>
             <p14:sldId id="257"/>
           </p14:sldIdLst>
         </p14:section>
-        <p14:section name="How" id="{1f835d36-e4f5-bbcb-58e5-4b40560232da}">
+        <p14:section name="How" id="{7172eba6-0b57-1e86-863f-f5e4f7187830}">
           <p14:sldIdLst>
             <p14:sldId id="258"/>
             <p14:sldId id="259"/>
           </p14:sldIdLst>
         </p14:section>
-        <p14:section name="Proof" id="{da9b11c9-d24a-590c-d367-689da6a49bb7}">
+        <p14:section name="Proof" id="{dfa87173-28dc-2771-c1f1-80202cd8f669}">
           <p14:sldIdLst>
             <p14:sldId id="260"/>
             <p14:sldId id="261"/>
@@ -815,7 +815,7 @@
           <a:p>
             <a:r>
               <a:rPr lang="en-US" dirty="0"/>
-              <a:t>(0:00–0:15) Hi, we are [team]. Our harness gets a game it has never seen, only as a written spec, and has to hand back a strategy that wins. Alone, in a sandbox, on a fixed budget. In three minutes: the idea, how we built it, and what we measured.</a:t>
+              <a:t>(0:00–0:15) Hi, we are Elias, Isaak and Timo. Our harness gets a game it has never seen, only as a written spec, and has to hand back a strategy that wins. Alone, in a sandbox, on a fixed budget. In three minutes: the idea, how we built it, and what we measured.</a:t>
             </a:r>
             <a:endParaRPr lang="en-US" dirty="0"/>
           </a:p>
@@ -2886,7 +2886,7 @@
         <p:spPr>
           <a:xfrm>
             <a:off x="548640" y="4160520"/>
-            <a:ext cx="6035040" cy="914400"/>
+            <a:ext cx="6035040" cy="548640"/>
           </a:xfrm>
           <a:prstGeom prst="rect">
             <a:avLst/>
@@ -2910,7 +2910,7 @@
                 <a:ea typeface="Calibri" pitchFamily="34" charset="-122"/>
                 <a:cs typeface="Calibri" pitchFamily="34" charset="-120"/>
               </a:rPr>
-              <a:t>An agent harness that writes, verifies and evolves game strategies, for games it has never seen.</a:t>
+              <a:t>An agent harness for games it has never seen.</a:t>
             </a:r>
             <a:endParaRPr lang="en-US" sz="2000" dirty="0"/>
           </a:p>
@@ -2924,8 +2924,8 @@
         </p:nvSpPr>
         <p:spPr>
           <a:xfrm>
-            <a:off x="548640" y="6172200"/>
-            <a:ext cx="5486400" cy="320040"/>
+            <a:off x="548640" y="6035040"/>
+            <a:ext cx="5486400" cy="411480"/>
           </a:xfrm>
           <a:prstGeom prst="rect">
             <a:avLst/>
@@ -2941,17 +2941,17 @@
               <a:buNone/>
             </a:pPr>
             <a:r>
-              <a:rPr lang="en-US" sz="1400" dirty="0">
-                <a:solidFill>
-                  <a:srgbClr val="7D8694"/>
-                </a:solidFill>
-                <a:latin typeface="Calibri" pitchFamily="34" charset="0"/>
-                <a:ea typeface="Calibri" pitchFamily="34" charset="-122"/>
-                <a:cs typeface="Calibri" pitchFamily="34" charset="-120"/>
-              </a:rPr>
-              <a:t>[Team name] · [names]</a:t>
-            </a:r>
-            <a:endParaRPr lang="en-US" sz="1400" dirty="0"/>
+              <a:rPr lang="en-US" sz="1800" b="1" dirty="0">
+                <a:solidFill>
+                  <a:srgbClr val="AEB6C2"/>
+                </a:solidFill>
+                <a:latin typeface="Century Gothic" pitchFamily="34" charset="0"/>
+                <a:ea typeface="Century Gothic" pitchFamily="34" charset="-122"/>
+                <a:cs typeface="Century Gothic" pitchFamily="34" charset="-120"/>
+              </a:rPr>
+              <a:t>Elias  ·  Isaak  ·  Timo</a:t>
+            </a:r>
+            <a:endParaRPr lang="en-US" sz="1800" dirty="0"/>
           </a:p>
         </p:txBody>
       </p:sp>
@@ -3068,12 +3068,12 @@
         </p:nvSpPr>
         <p:spPr>
           <a:xfrm>
-            <a:off x="548640" y="1874520"/>
-            <a:ext cx="3520440" cy="3886200"/>
+            <a:off x="548640" y="2148840"/>
+            <a:ext cx="3520440" cy="3108960"/>
           </a:xfrm>
           <a:prstGeom prst="roundRect">
             <a:avLst>
-              <a:gd name="adj" fmla="val 3117"/>
+              <a:gd name="adj" fmla="val 3529"/>
             </a:avLst>
           </a:prstGeom>
           <a:solidFill>
@@ -3102,7 +3102,7 @@
         </p:nvSpPr>
         <p:spPr>
           <a:xfrm>
-            <a:off x="868680" y="2148840"/>
+            <a:off x="868680" y="2423160"/>
             <a:ext cx="2880360" cy="365760"/>
           </a:xfrm>
           <a:prstGeom prst="rect">
@@ -3141,46 +3141,85 @@
         </p:nvSpPr>
         <p:spPr>
           <a:xfrm>
-            <a:off x="868680" y="2606040"/>
-            <a:ext cx="2880360" cy="868680"/>
-          </a:xfrm>
-          <a:prstGeom prst="rect">
-            <a:avLst/>
-          </a:prstGeom>
-          <a:noFill/>
-          <a:ln/>
-        </p:spPr>
-        <p:txBody>
-          <a:bodyPr wrap="square" lIns="0" tIns="0" rIns="0" bIns="0" rtlCol="0" anchor="t"/>
-          <a:lstStyle/>
-          <a:p>
-            <a:pPr indent="0" marL="0">
-              <a:buNone/>
-            </a:pPr>
-            <a:r>
-              <a:rPr lang="en-US" sz="1600" dirty="0">
-                <a:solidFill>
-                  <a:srgbClr val="4A5260"/>
+            <a:off x="868680" y="3108960"/>
+            <a:ext cx="411480" cy="365760"/>
+          </a:xfrm>
+          <a:prstGeom prst="rect">
+            <a:avLst/>
+          </a:prstGeom>
+          <a:noFill/>
+          <a:ln/>
+        </p:spPr>
+        <p:txBody>
+          <a:bodyPr wrap="square" lIns="0" tIns="0" rIns="0" bIns="0" rtlCol="0" anchor="ctr"/>
+          <a:lstStyle/>
+          <a:p>
+            <a:pPr indent="0" marL="0">
+              <a:buNone/>
+            </a:pPr>
+            <a:r>
+              <a:rPr lang="en-US" sz="2000" b="1" dirty="0">
+                <a:solidFill>
+                  <a:srgbClr val="B44A12"/>
+                </a:solidFill>
+                <a:latin typeface="Consolas" pitchFamily="34" charset="0"/>
+                <a:ea typeface="Consolas" pitchFamily="34" charset="-122"/>
+                <a:cs typeface="Consolas" pitchFamily="34" charset="-120"/>
+              </a:rPr>
+              <a:t>A</a:t>
+            </a:r>
+            <a:endParaRPr lang="en-US" sz="2000" dirty="0"/>
+          </a:p>
+        </p:txBody>
+      </p:sp>
+      <p:sp>
+        <p:nvSpPr>
+          <p:cNvPr id="7" name="Text 5"/>
+          <p:cNvSpPr txBox="1"/>
+          <p:nvPr/>
+        </p:nvSpPr>
+        <p:spPr>
+          <a:xfrm>
+            <a:off x="1325880" y="3108960"/>
+            <a:ext cx="2423160" cy="411480"/>
+          </a:xfrm>
+          <a:prstGeom prst="rect">
+            <a:avLst/>
+          </a:prstGeom>
+          <a:noFill/>
+          <a:ln/>
+        </p:spPr>
+        <p:txBody>
+          <a:bodyPr wrap="square" lIns="0" tIns="0" rIns="0" bIns="0" rtlCol="0" anchor="ctr"/>
+          <a:lstStyle/>
+          <a:p>
+            <a:pPr indent="0" marL="0">
+              <a:buNone/>
+            </a:pPr>
+            <a:r>
+              <a:rPr lang="en-US" sz="2200" b="1" dirty="0">
+                <a:solidFill>
+                  <a:srgbClr val="14171C"/>
                 </a:solidFill>
                 <a:latin typeface="Calibri" pitchFamily="34" charset="0"/>
                 <a:ea typeface="Calibri" pitchFamily="34" charset="-122"/>
                 <a:cs typeface="Calibri" pitchFamily="34" charset="-120"/>
               </a:rPr>
-              <a:t>Read a game’s written spec, ship a strategy that wins. Unattended, in a sandbox.</a:t>
-            </a:r>
-            <a:endParaRPr lang="en-US" sz="1600" dirty="0"/>
-          </a:p>
-        </p:txBody>
-      </p:sp>
-      <p:sp>
-        <p:nvSpPr>
-          <p:cNvPr id="7" name="Text 5"/>
-          <p:cNvSpPr txBox="1"/>
-          <p:nvPr/>
-        </p:nvSpPr>
-        <p:spPr>
-          <a:xfrm>
-            <a:off x="868680" y="3657600"/>
+              <a:t>$0.03  ·  3 min</a:t>
+            </a:r>
+            <a:endParaRPr lang="en-US" sz="2200" dirty="0"/>
+          </a:p>
+        </p:txBody>
+      </p:sp>
+      <p:sp>
+        <p:nvSpPr>
+          <p:cNvPr id="8" name="Text 6"/>
+          <p:cNvSpPr txBox="1"/>
+          <p:nvPr/>
+        </p:nvSpPr>
+        <p:spPr>
+          <a:xfrm>
+            <a:off x="868680" y="3767328"/>
             <a:ext cx="411480" cy="365760"/>
           </a:xfrm>
           <a:prstGeom prst="rect">
@@ -3197,7 +3236,7 @@
               <a:buNone/>
             </a:pPr>
             <a:r>
-              <a:rPr lang="en-US" sz="1600" b="1" dirty="0">
+              <a:rPr lang="en-US" sz="2000" b="1" dirty="0">
                 <a:solidFill>
                   <a:srgbClr val="B44A12"/>
                 </a:solidFill>
@@ -3205,22 +3244,22 @@
                 <a:ea typeface="Consolas" pitchFamily="34" charset="-122"/>
                 <a:cs typeface="Consolas" pitchFamily="34" charset="-120"/>
               </a:rPr>
-              <a:t>A</a:t>
-            </a:r>
-            <a:endParaRPr lang="en-US" sz="1600" dirty="0"/>
-          </a:p>
-        </p:txBody>
-      </p:sp>
-      <p:sp>
-        <p:nvSpPr>
-          <p:cNvPr id="8" name="Text 6"/>
-          <p:cNvSpPr txBox="1"/>
-          <p:nvPr/>
-        </p:nvSpPr>
-        <p:spPr>
-          <a:xfrm>
-            <a:off x="1325880" y="3657600"/>
-            <a:ext cx="2423160" cy="365760"/>
+              <a:t>B</a:t>
+            </a:r>
+            <a:endParaRPr lang="en-US" sz="2000" dirty="0"/>
+          </a:p>
+        </p:txBody>
+      </p:sp>
+      <p:sp>
+        <p:nvSpPr>
+          <p:cNvPr id="9" name="Text 7"/>
+          <p:cNvSpPr txBox="1"/>
+          <p:nvPr/>
+        </p:nvSpPr>
+        <p:spPr>
+          <a:xfrm>
+            <a:off x="1325880" y="3767328"/>
+            <a:ext cx="2423160" cy="411480"/>
           </a:xfrm>
           <a:prstGeom prst="rect">
             <a:avLst/>
@@ -3236,7 +3275,7 @@
               <a:buNone/>
             </a:pPr>
             <a:r>
-              <a:rPr lang="en-US" sz="1800" b="1" dirty="0">
+              <a:rPr lang="en-US" sz="2200" b="1" dirty="0">
                 <a:solidFill>
                   <a:srgbClr val="14171C"/>
                 </a:solidFill>
@@ -3244,21 +3283,21 @@
                 <a:ea typeface="Calibri" pitchFamily="34" charset="-122"/>
                 <a:cs typeface="Calibri" pitchFamily="34" charset="-120"/>
               </a:rPr>
-              <a:t>$0.03  ·  3 min</a:t>
-            </a:r>
-            <a:endParaRPr lang="en-US" sz="1800" dirty="0"/>
-          </a:p>
-        </p:txBody>
-      </p:sp>
-      <p:sp>
-        <p:nvSpPr>
-          <p:cNvPr id="9" name="Text 7"/>
-          <p:cNvSpPr txBox="1"/>
-          <p:nvPr/>
-        </p:nvSpPr>
-        <p:spPr>
-          <a:xfrm>
-            <a:off x="868680" y="4133088"/>
+              <a:t>$0.50  ·  10 min</a:t>
+            </a:r>
+            <a:endParaRPr lang="en-US" sz="2200" dirty="0"/>
+          </a:p>
+        </p:txBody>
+      </p:sp>
+      <p:sp>
+        <p:nvSpPr>
+          <p:cNvPr id="10" name="Text 8"/>
+          <p:cNvSpPr txBox="1"/>
+          <p:nvPr/>
+        </p:nvSpPr>
+        <p:spPr>
+          <a:xfrm>
+            <a:off x="868680" y="4425696"/>
             <a:ext cx="411480" cy="365760"/>
           </a:xfrm>
           <a:prstGeom prst="rect">
@@ -3275,7 +3314,7 @@
               <a:buNone/>
             </a:pPr>
             <a:r>
-              <a:rPr lang="en-US" sz="1600" b="1" dirty="0">
+              <a:rPr lang="en-US" sz="2000" b="1" dirty="0">
                 <a:solidFill>
                   <a:srgbClr val="B44A12"/>
                 </a:solidFill>
@@ -3283,22 +3322,22 @@
                 <a:ea typeface="Consolas" pitchFamily="34" charset="-122"/>
                 <a:cs typeface="Consolas" pitchFamily="34" charset="-120"/>
               </a:rPr>
-              <a:t>B</a:t>
-            </a:r>
-            <a:endParaRPr lang="en-US" sz="1600" dirty="0"/>
-          </a:p>
-        </p:txBody>
-      </p:sp>
-      <p:sp>
-        <p:nvSpPr>
-          <p:cNvPr id="10" name="Text 8"/>
-          <p:cNvSpPr txBox="1"/>
-          <p:nvPr/>
-        </p:nvSpPr>
-        <p:spPr>
-          <a:xfrm>
-            <a:off x="1325880" y="4133088"/>
-            <a:ext cx="2423160" cy="365760"/>
+              <a:t>C</a:t>
+            </a:r>
+            <a:endParaRPr lang="en-US" sz="2000" dirty="0"/>
+          </a:p>
+        </p:txBody>
+      </p:sp>
+      <p:sp>
+        <p:nvSpPr>
+          <p:cNvPr id="11" name="Text 9"/>
+          <p:cNvSpPr txBox="1"/>
+          <p:nvPr/>
+        </p:nvSpPr>
+        <p:spPr>
+          <a:xfrm>
+            <a:off x="1325880" y="4425696"/>
+            <a:ext cx="2423160" cy="411480"/>
           </a:xfrm>
           <a:prstGeom prst="rect">
             <a:avLst/>
@@ -3314,7 +3353,7 @@
               <a:buNone/>
             </a:pPr>
             <a:r>
-              <a:rPr lang="en-US" sz="1800" b="1" dirty="0">
+              <a:rPr lang="en-US" sz="2200" b="1" dirty="0">
                 <a:solidFill>
                   <a:srgbClr val="14171C"/>
                 </a:solidFill>
@@ -3322,143 +3361,26 @@
                 <a:ea typeface="Calibri" pitchFamily="34" charset="-122"/>
                 <a:cs typeface="Calibri" pitchFamily="34" charset="-120"/>
               </a:rPr>
-              <a:t>$0.50  ·  10 min</a:t>
-            </a:r>
-            <a:endParaRPr lang="en-US" sz="1800" dirty="0"/>
-          </a:p>
-        </p:txBody>
-      </p:sp>
-      <p:sp>
-        <p:nvSpPr>
-          <p:cNvPr id="11" name="Text 9"/>
-          <p:cNvSpPr txBox="1"/>
-          <p:nvPr/>
-        </p:nvSpPr>
-        <p:spPr>
-          <a:xfrm>
-            <a:off x="868680" y="4608576"/>
-            <a:ext cx="411480" cy="365760"/>
-          </a:xfrm>
-          <a:prstGeom prst="rect">
-            <a:avLst/>
-          </a:prstGeom>
-          <a:noFill/>
-          <a:ln/>
-        </p:spPr>
-        <p:txBody>
-          <a:bodyPr wrap="square" lIns="0" tIns="0" rIns="0" bIns="0" rtlCol="0" anchor="ctr"/>
-          <a:lstStyle/>
-          <a:p>
-            <a:pPr indent="0" marL="0">
-              <a:buNone/>
-            </a:pPr>
-            <a:r>
-              <a:rPr lang="en-US" sz="1600" b="1" dirty="0">
-                <a:solidFill>
-                  <a:srgbClr val="B44A12"/>
-                </a:solidFill>
-                <a:latin typeface="Consolas" pitchFamily="34" charset="0"/>
-                <a:ea typeface="Consolas" pitchFamily="34" charset="-122"/>
-                <a:cs typeface="Consolas" pitchFamily="34" charset="-120"/>
-              </a:rPr>
-              <a:t>C</a:t>
-            </a:r>
-            <a:endParaRPr lang="en-US" sz="1600" dirty="0"/>
-          </a:p>
-        </p:txBody>
-      </p:sp>
-      <p:sp>
-        <p:nvSpPr>
-          <p:cNvPr id="12" name="Text 10"/>
-          <p:cNvSpPr txBox="1"/>
-          <p:nvPr/>
-        </p:nvSpPr>
-        <p:spPr>
-          <a:xfrm>
-            <a:off x="1325880" y="4608576"/>
-            <a:ext cx="2423160" cy="365760"/>
-          </a:xfrm>
-          <a:prstGeom prst="rect">
-            <a:avLst/>
-          </a:prstGeom>
-          <a:noFill/>
-          <a:ln/>
-        </p:spPr>
-        <p:txBody>
-          <a:bodyPr wrap="square" lIns="0" tIns="0" rIns="0" bIns="0" rtlCol="0" anchor="ctr"/>
-          <a:lstStyle/>
-          <a:p>
-            <a:pPr indent="0" marL="0">
-              <a:buNone/>
-            </a:pPr>
-            <a:r>
-              <a:rPr lang="en-US" sz="1800" b="1" dirty="0">
-                <a:solidFill>
-                  <a:srgbClr val="14171C"/>
-                </a:solidFill>
-                <a:latin typeface="Calibri" pitchFamily="34" charset="0"/>
-                <a:ea typeface="Calibri" pitchFamily="34" charset="-122"/>
-                <a:cs typeface="Calibri" pitchFamily="34" charset="-120"/>
-              </a:rPr>
               <a:t>$10  ·  30 min</a:t>
             </a:r>
-            <a:endParaRPr lang="en-US" sz="1800" dirty="0"/>
-          </a:p>
-        </p:txBody>
-      </p:sp>
-      <p:sp>
-        <p:nvSpPr>
-          <p:cNvPr id="13" name="Text 11"/>
-          <p:cNvSpPr txBox="1"/>
-          <p:nvPr/>
-        </p:nvSpPr>
-        <p:spPr>
-          <a:xfrm>
-            <a:off x="868680" y="5120640"/>
-            <a:ext cx="2880360" cy="457200"/>
-          </a:xfrm>
-          <a:prstGeom prst="rect">
-            <a:avLst/>
-          </a:prstGeom>
-          <a:noFill/>
-          <a:ln/>
-        </p:spPr>
-        <p:txBody>
-          <a:bodyPr wrap="square" lIns="0" tIns="0" rIns="0" bIns="0" rtlCol="0" anchor="t"/>
-          <a:lstStyle/>
-          <a:p>
-            <a:pPr indent="0" marL="0">
-              <a:buNone/>
-            </a:pPr>
-            <a:r>
-              <a:rPr lang="en-US" sz="1400" dirty="0">
-                <a:solidFill>
-                  <a:srgbClr val="4A5260"/>
-                </a:solidFill>
-                <a:latin typeface="Calibri" pitchFamily="34" charset="0"/>
-                <a:ea typeface="Calibri" pitchFamily="34" charset="-122"/>
-                <a:cs typeface="Calibri" pitchFamily="34" charset="-120"/>
-              </a:rPr>
-              <a:t>Scored on two unseen games: win +1, draw 0, loss −1.</a:t>
-            </a:r>
-            <a:endParaRPr lang="en-US" sz="1400" dirty="0"/>
-          </a:p>
-        </p:txBody>
-      </p:sp>
-      <p:sp>
-        <p:nvSpPr>
-          <p:cNvPr id="14" name="card research"/>
+            <a:endParaRPr lang="en-US" sz="2200" dirty="0"/>
+          </a:p>
+        </p:txBody>
+      </p:sp>
+      <p:sp>
+        <p:nvSpPr>
+          <p:cNvPr id="12" name="card research"/>
           <p:cNvSpPr/>
           <p:nvPr/>
         </p:nvSpPr>
         <p:spPr>
           <a:xfrm>
-            <a:off x="4343400" y="1874520"/>
-            <a:ext cx="3520440" cy="3886200"/>
+            <a:off x="4343400" y="2148840"/>
+            <a:ext cx="3520440" cy="3108960"/>
           </a:xfrm>
           <a:prstGeom prst="roundRect">
             <a:avLst>
-              <a:gd name="adj" fmla="val 3117"/>
+              <a:gd name="adj" fmla="val 3529"/>
             </a:avLst>
           </a:prstGeom>
           <a:solidFill>
@@ -3481,13 +3403,13 @@
       </p:sp>
       <p:sp>
         <p:nvSpPr>
-          <p:cNvPr id="15" name="Text 13"/>
-          <p:cNvSpPr txBox="1"/>
-          <p:nvPr/>
-        </p:nvSpPr>
-        <p:spPr>
-          <a:xfrm>
-            <a:off x="4663440" y="2148840"/>
+          <p:cNvPr id="13" name="Text 11"/>
+          <p:cNvSpPr txBox="1"/>
+          <p:nvPr/>
+        </p:nvSpPr>
+        <p:spPr>
+          <a:xfrm>
+            <a:off x="4663440" y="2423160"/>
             <a:ext cx="2880360" cy="365760"/>
           </a:xfrm>
           <a:prstGeom prst="rect">
@@ -3520,13 +3442,13 @@
       </p:sp>
       <p:sp>
         <p:nvSpPr>
-          <p:cNvPr id="16" name="Text 14"/>
-          <p:cNvSpPr txBox="1"/>
-          <p:nvPr/>
-        </p:nvSpPr>
-        <p:spPr>
-          <a:xfrm>
-            <a:off x="4663440" y="2743200"/>
+          <p:cNvPr id="14" name="Text 12"/>
+          <p:cNvSpPr txBox="1"/>
+          <p:nvPr/>
+        </p:nvSpPr>
+        <p:spPr>
+          <a:xfrm>
+            <a:off x="4663440" y="3017520"/>
             <a:ext cx="2880360" cy="822960"/>
           </a:xfrm>
           <a:prstGeom prst="rect">
@@ -3587,14 +3509,14 @@
       </p:sp>
       <p:sp>
         <p:nvSpPr>
-          <p:cNvPr id="17" name="Text 15"/>
-          <p:cNvSpPr txBox="1"/>
-          <p:nvPr/>
-        </p:nvSpPr>
-        <p:spPr>
-          <a:xfrm>
-            <a:off x="4663440" y="3703320"/>
-            <a:ext cx="2880360" cy="1188720"/>
+          <p:cNvPr id="15" name="Text 13"/>
+          <p:cNvSpPr txBox="1"/>
+          <p:nvPr/>
+        </p:nvSpPr>
+        <p:spPr>
+          <a:xfrm>
+            <a:off x="4663440" y="3977640"/>
+            <a:ext cx="2880360" cy="457200"/>
           </a:xfrm>
           <a:prstGeom prst="rect">
             <a:avLst/>
@@ -3618,7 +3540,7 @@
                 <a:ea typeface="Calibri" pitchFamily="34" charset="-122"/>
                 <a:cs typeface="Calibri" pitchFamily="34" charset="-120"/>
               </a:rPr>
-              <a:t>Win rate when the LLM writes a simulator plus search code, versus the LLM playing move by move.</a:t>
+              <a:t>LLM writes code  vs.  LLM plays</a:t>
             </a:r>
             <a:endParaRPr lang="en-US" sz="1600" dirty="0"/>
           </a:p>
@@ -3626,13 +3548,13 @@
       </p:sp>
       <p:sp>
         <p:nvSpPr>
-          <p:cNvPr id="18" name="Text 16"/>
-          <p:cNvSpPr txBox="1"/>
-          <p:nvPr/>
-        </p:nvSpPr>
-        <p:spPr>
-          <a:xfrm>
-            <a:off x="4663440" y="5120640"/>
+          <p:cNvPr id="16" name="Text 14"/>
+          <p:cNvSpPr txBox="1"/>
+          <p:nvPr/>
+        </p:nvSpPr>
+        <p:spPr>
+          <a:xfrm>
+            <a:off x="4663440" y="4663440"/>
             <a:ext cx="2880360" cy="457200"/>
           </a:xfrm>
           <a:prstGeom prst="rect">
@@ -3665,18 +3587,18 @@
       </p:sp>
       <p:sp>
         <p:nvSpPr>
-          <p:cNvPr id="19" name="card insight"/>
+          <p:cNvPr id="17" name="card insight"/>
           <p:cNvSpPr/>
           <p:nvPr/>
         </p:nvSpPr>
         <p:spPr>
           <a:xfrm>
-            <a:off x="8138160" y="1874520"/>
-            <a:ext cx="3520440" cy="3886200"/>
+            <a:off x="8138160" y="2148840"/>
+            <a:ext cx="3520440" cy="3108960"/>
           </a:xfrm>
           <a:prstGeom prst="roundRect">
             <a:avLst>
-              <a:gd name="adj" fmla="val 3117"/>
+              <a:gd name="adj" fmla="val 3529"/>
             </a:avLst>
           </a:prstGeom>
           <a:solidFill>
@@ -3699,13 +3621,13 @@
       </p:sp>
       <p:sp>
         <p:nvSpPr>
-          <p:cNvPr id="20" name="Text 18"/>
-          <p:cNvSpPr txBox="1"/>
-          <p:nvPr/>
-        </p:nvSpPr>
-        <p:spPr>
-          <a:xfrm>
-            <a:off x="8458200" y="2148840"/>
+          <p:cNvPr id="18" name="Text 16"/>
+          <p:cNvSpPr txBox="1"/>
+          <p:nvPr/>
+        </p:nvSpPr>
+        <p:spPr>
+          <a:xfrm>
+            <a:off x="8458200" y="2423160"/>
             <a:ext cx="2880360" cy="365760"/>
           </a:xfrm>
           <a:prstGeom prst="rect">
@@ -3738,14 +3660,14 @@
       </p:sp>
       <p:sp>
         <p:nvSpPr>
-          <p:cNvPr id="21" name="Text 19"/>
-          <p:cNvSpPr txBox="1"/>
-          <p:nvPr/>
-        </p:nvSpPr>
-        <p:spPr>
-          <a:xfrm>
-            <a:off x="8458200" y="2697480"/>
-            <a:ext cx="2880360" cy="1463040"/>
+          <p:cNvPr id="19" name="Text 17"/>
+          <p:cNvSpPr txBox="1"/>
+          <p:nvPr/>
+        </p:nvSpPr>
+        <p:spPr>
+          <a:xfrm>
+            <a:off x="8458200" y="3017520"/>
+            <a:ext cx="2880360" cy="2194560"/>
           </a:xfrm>
           <a:prstGeom prst="rect">
             <a:avLst/>
@@ -3761,7 +3683,7 @@
               <a:buNone/>
             </a:pPr>
             <a:r>
-              <a:rPr lang="en-US" sz="2600" b="1" dirty="0">
+              <a:rPr lang="en-US" sz="3000" b="1" dirty="0">
                 <a:solidFill>
                   <a:srgbClr val="F3F0E8"/>
                 </a:solidFill>
@@ -3769,54 +3691,15 @@
                 <a:ea typeface="Century Gothic" pitchFamily="34" charset="-122"/>
                 <a:cs typeface="Century Gothic" pitchFamily="34" charset="-120"/>
               </a:rPr>
-              <a:t>Make the LLM the programmer, not the player.</a:t>
-            </a:r>
-            <a:endParaRPr lang="en-US" sz="2600" dirty="0"/>
-          </a:p>
-        </p:txBody>
-      </p:sp>
-      <p:sp>
-        <p:nvSpPr>
-          <p:cNvPr id="22" name="Text 20"/>
-          <p:cNvSpPr txBox="1"/>
-          <p:nvPr/>
-        </p:nvSpPr>
-        <p:spPr>
-          <a:xfrm>
-            <a:off x="8458200" y="4389120"/>
-            <a:ext cx="2880360" cy="914400"/>
-          </a:xfrm>
-          <a:prstGeom prst="rect">
-            <a:avLst/>
-          </a:prstGeom>
-          <a:noFill/>
-          <a:ln/>
-        </p:spPr>
-        <p:txBody>
-          <a:bodyPr wrap="square" lIns="0" tIns="0" rIns="0" bIns="0" rtlCol="0" anchor="t"/>
-          <a:lstStyle/>
-          <a:p>
-            <a:pPr indent="0" marL="0">
-              <a:buNone/>
-            </a:pPr>
-            <a:r>
-              <a:rPr lang="en-US" sz="1800" dirty="0">
-                <a:solidFill>
-                  <a:srgbClr val="AEB6C2"/>
-                </a:solidFill>
-                <a:latin typeface="Calibri" pitchFamily="34" charset="0"/>
-                <a:ea typeface="Calibri" pitchFamily="34" charset="-122"/>
-                <a:cs typeface="Calibri" pitchFamily="34" charset="-120"/>
-              </a:rPr>
-              <a:t>And never trust its code before it is verified.</a:t>
-            </a:r>
-            <a:endParaRPr lang="en-US" sz="1800" dirty="0"/>
-          </a:p>
-        </p:txBody>
-      </p:sp>
-      <p:sp>
-        <p:nvSpPr>
-          <p:cNvPr id="23" name="Text 21"/>
+              <a:t>The LLM is the programmer, not the player.</a:t>
+            </a:r>
+            <a:endParaRPr lang="en-US" sz="3000" dirty="0"/>
+          </a:p>
+        </p:txBody>
+      </p:sp>
+      <p:sp>
+        <p:nvSpPr>
+          <p:cNvPr id="20" name="Text 18"/>
           <p:cNvSpPr txBox="1"/>
           <p:nvPr/>
         </p:nvSpPr>
@@ -4014,12 +3897,12 @@
         </p:nvSpPr>
         <p:spPr>
           <a:xfrm>
-            <a:off x="548640" y="1965960"/>
-            <a:ext cx="1938528" cy="2331720"/>
+            <a:off x="548640" y="2697480"/>
+            <a:ext cx="1938528" cy="1828800"/>
           </a:xfrm>
           <a:prstGeom prst="roundRect">
             <a:avLst>
-              <a:gd name="adj" fmla="val 4717"/>
+              <a:gd name="adj" fmla="val 5000"/>
             </a:avLst>
           </a:prstGeom>
           <a:solidFill>
@@ -4041,7 +3924,7 @@
         </p:nvSpPr>
         <p:spPr>
           <a:xfrm>
-            <a:off x="731520" y="2167128"/>
+            <a:off x="731520" y="2898648"/>
             <a:ext cx="457200" cy="320040"/>
           </a:xfrm>
           <a:prstGeom prst="rect">
@@ -4080,7 +3963,7 @@
         </p:nvSpPr>
         <p:spPr>
           <a:xfrm>
-            <a:off x="731520" y="2532888"/>
+            <a:off x="731520" y="3264408"/>
             <a:ext cx="1572768" cy="411480"/>
           </a:xfrm>
           <a:prstGeom prst="rect">
@@ -4119,8 +4002,8 @@
         </p:nvSpPr>
         <p:spPr>
           <a:xfrm>
-            <a:off x="731520" y="3017520"/>
-            <a:ext cx="1618488" cy="1600200"/>
+            <a:off x="731520" y="3794760"/>
+            <a:ext cx="1618488" cy="640080"/>
           </a:xfrm>
           <a:prstGeom prst="rect">
             <a:avLst/>
@@ -4136,7 +4019,7 @@
               <a:buNone/>
             </a:pPr>
             <a:r>
-              <a:rPr lang="en-US" sz="1400" dirty="0">
+              <a:rPr lang="en-US" sz="1600" dirty="0">
                 <a:solidFill>
                   <a:srgbClr val="AEB6C2"/>
                 </a:solidFill>
@@ -4144,9 +4027,9 @@
                 <a:ea typeface="Calibri" pitchFamily="34" charset="-122"/>
                 <a:cs typeface="Calibri" pitchFamily="34" charset="-120"/>
               </a:rPr>
-              <a:t>3–4 strategy drafts with different personas, and a simulator, in parallel</a:t>
-            </a:r>
-            <a:endParaRPr lang="en-US" sz="1400" dirty="0"/>
+              <a:t>drafts + a simulator</a:t>
+            </a:r>
+            <a:endParaRPr lang="en-US" sz="1600" dirty="0"/>
           </a:p>
         </p:txBody>
       </p:sp>
@@ -4158,7 +4041,7 @@
         </p:nvSpPr>
         <p:spPr>
           <a:xfrm>
-            <a:off x="2560320" y="3022092"/>
+            <a:off x="2560320" y="3502152"/>
             <a:ext cx="210312" cy="219456"/>
           </a:xfrm>
           <a:prstGeom prst="rightArrow">
@@ -4183,12 +4066,12 @@
         </p:nvSpPr>
         <p:spPr>
           <a:xfrm>
-            <a:off x="2843784" y="1965960"/>
-            <a:ext cx="1938528" cy="2331720"/>
+            <a:off x="2843784" y="2697480"/>
+            <a:ext cx="1938528" cy="1828800"/>
           </a:xfrm>
           <a:prstGeom prst="roundRect">
             <a:avLst>
-              <a:gd name="adj" fmla="val 4717"/>
+              <a:gd name="adj" fmla="val 5000"/>
             </a:avLst>
           </a:prstGeom>
           <a:solidFill>
@@ -4210,7 +4093,7 @@
         </p:nvSpPr>
         <p:spPr>
           <a:xfrm>
-            <a:off x="3026664" y="2167128"/>
+            <a:off x="3026664" y="2898648"/>
             <a:ext cx="457200" cy="320040"/>
           </a:xfrm>
           <a:prstGeom prst="rect">
@@ -4249,7 +4132,7 @@
         </p:nvSpPr>
         <p:spPr>
           <a:xfrm>
-            <a:off x="3026664" y="2532888"/>
+            <a:off x="3026664" y="3264408"/>
             <a:ext cx="1572768" cy="411480"/>
           </a:xfrm>
           <a:prstGeom prst="rect">
@@ -4288,8 +4171,8 @@
         </p:nvSpPr>
         <p:spPr>
           <a:xfrm>
-            <a:off x="3026664" y="3017520"/>
-            <a:ext cx="1618488" cy="1600200"/>
+            <a:off x="3026664" y="3794760"/>
+            <a:ext cx="1618488" cy="640080"/>
           </a:xfrm>
           <a:prstGeom prst="rect">
             <a:avLst/>
@@ -4305,7 +4188,7 @@
               <a:buNone/>
             </a:pPr>
             <a:r>
-              <a:rPr lang="en-US" sz="1400" dirty="0">
+              <a:rPr lang="en-US" sz="1600" dirty="0">
                 <a:solidFill>
                   <a:srgbClr val="AEB6C2"/>
                 </a:solidFill>
@@ -4313,9 +4196,9 @@
                 <a:ea typeface="Calibri" pitchFamily="34" charset="-122"/>
                 <a:cs typeface="Calibri" pitchFamily="34" charset="-120"/>
               </a:rPr>
-              <a:t>The simulator must reproduce the spec’s worked examples; drafts are probed and repaired</a:t>
-            </a:r>
-            <a:endParaRPr lang="en-US" sz="1400" dirty="0"/>
+              <a:t>against the spec</a:t>
+            </a:r>
+            <a:endParaRPr lang="en-US" sz="1600" dirty="0"/>
           </a:p>
         </p:txBody>
       </p:sp>
@@ -4327,7 +4210,7 @@
         </p:nvSpPr>
         <p:spPr>
           <a:xfrm>
-            <a:off x="4855464" y="3022092"/>
+            <a:off x="4855464" y="3502152"/>
             <a:ext cx="210312" cy="219456"/>
           </a:xfrm>
           <a:prstGeom prst="rightArrow">
@@ -4352,12 +4235,12 @@
         </p:nvSpPr>
         <p:spPr>
           <a:xfrm>
-            <a:off x="5138928" y="1965960"/>
-            <a:ext cx="1938528" cy="2331720"/>
+            <a:off x="5138928" y="2697480"/>
+            <a:ext cx="1938528" cy="1828800"/>
           </a:xfrm>
           <a:prstGeom prst="roundRect">
             <a:avLst>
-              <a:gd name="adj" fmla="val 4717"/>
+              <a:gd name="adj" fmla="val 5000"/>
             </a:avLst>
           </a:prstGeom>
           <a:solidFill>
@@ -4379,7 +4262,7 @@
         </p:nvSpPr>
         <p:spPr>
           <a:xfrm>
-            <a:off x="5321808" y="2167128"/>
+            <a:off x="5321808" y="2898648"/>
             <a:ext cx="457200" cy="320040"/>
           </a:xfrm>
           <a:prstGeom prst="rect">
@@ -4418,7 +4301,7 @@
         </p:nvSpPr>
         <p:spPr>
           <a:xfrm>
-            <a:off x="5321808" y="2532888"/>
+            <a:off x="5321808" y="3264408"/>
             <a:ext cx="1572768" cy="411480"/>
           </a:xfrm>
           <a:prstGeom prst="rect">
@@ -4457,8 +4340,8 @@
         </p:nvSpPr>
         <p:spPr>
           <a:xfrm>
-            <a:off x="5321808" y="3017520"/>
-            <a:ext cx="1618488" cy="1600200"/>
+            <a:off x="5321808" y="3794760"/>
+            <a:ext cx="1618488" cy="640080"/>
           </a:xfrm>
           <a:prstGeom prst="rect">
             <a:avLst/>
@@ -4474,7 +4357,7 @@
               <a:buNone/>
             </a:pPr>
             <a:r>
-              <a:rPr lang="en-US" sz="1400" dirty="0">
+              <a:rPr lang="en-US" sz="1600" dirty="0">
                 <a:solidFill>
                   <a:srgbClr val="AEB6C2"/>
                 </a:solidFill>
@@ -4482,9 +4365,9 @@
                 <a:ea typeface="Calibri" pitchFamily="34" charset="-122"/>
                 <a:cs typeface="Calibri" pitchFamily="34" charset="-120"/>
               </a:rPr>
-              <a:t>Round robin on the simulator: both seats, many seeds, real time limits</a:t>
-            </a:r>
-            <a:endParaRPr lang="en-US" sz="1400" dirty="0"/>
+              <a:t>real tournament rules</a:t>
+            </a:r>
+            <a:endParaRPr lang="en-US" sz="1600" dirty="0"/>
           </a:p>
         </p:txBody>
       </p:sp>
@@ -4496,7 +4379,7 @@
         </p:nvSpPr>
         <p:spPr>
           <a:xfrm>
-            <a:off x="7150608" y="3022092"/>
+            <a:off x="7150608" y="3502152"/>
             <a:ext cx="210312" cy="219456"/>
           </a:xfrm>
           <a:prstGeom prst="rightArrow">
@@ -4521,12 +4404,12 @@
         </p:nvSpPr>
         <p:spPr>
           <a:xfrm>
-            <a:off x="7434072" y="1965960"/>
-            <a:ext cx="1938528" cy="2331720"/>
+            <a:off x="7434072" y="2697480"/>
+            <a:ext cx="1938528" cy="1828800"/>
           </a:xfrm>
           <a:prstGeom prst="roundRect">
             <a:avLst>
-              <a:gd name="adj" fmla="val 4717"/>
+              <a:gd name="adj" fmla="val 5000"/>
             </a:avLst>
           </a:prstGeom>
           <a:solidFill>
@@ -4548,7 +4431,7 @@
         </p:nvSpPr>
         <p:spPr>
           <a:xfrm>
-            <a:off x="7616952" y="2167128"/>
+            <a:off x="7616952" y="2898648"/>
             <a:ext cx="457200" cy="320040"/>
           </a:xfrm>
           <a:prstGeom prst="rect">
@@ -4587,7 +4470,7 @@
         </p:nvSpPr>
         <p:spPr>
           <a:xfrm>
-            <a:off x="7616952" y="2532888"/>
+            <a:off x="7616952" y="3264408"/>
             <a:ext cx="1572768" cy="411480"/>
           </a:xfrm>
           <a:prstGeom prst="rect">
@@ -4626,8 +4509,8 @@
         </p:nvSpPr>
         <p:spPr>
           <a:xfrm>
-            <a:off x="7616952" y="3017520"/>
-            <a:ext cx="1618488" cy="1600200"/>
+            <a:off x="7616952" y="3794760"/>
+            <a:ext cx="1618488" cy="640080"/>
           </a:xfrm>
           <a:prstGeom prst="rect">
             <a:avLst/>
@@ -4643,7 +4526,7 @@
               <a:buNone/>
             </a:pPr>
             <a:r>
-              <a:rPr lang="en-US" sz="1400" dirty="0">
+              <a:rPr lang="en-US" sz="1600" dirty="0">
                 <a:solidFill>
                   <a:srgbClr val="AEB6C2"/>
                 </a:solidFill>
@@ -4651,9 +4534,9 @@
                 <a:ea typeface="Calibri" pitchFamily="34" charset="-122"/>
                 <a:cs typeface="Calibri" pitchFamily="34" charset="-120"/>
               </a:rPr>
-              <a:t>The strongest model writes challengers against the champion’s weak spots</a:t>
-            </a:r>
-            <a:endParaRPr lang="en-US" sz="1400" dirty="0"/>
+              <a:t>challengers vs. champion</a:t>
+            </a:r>
+            <a:endParaRPr lang="en-US" sz="1600" dirty="0"/>
           </a:p>
         </p:txBody>
       </p:sp>
@@ -4665,7 +4548,7 @@
         </p:nvSpPr>
         <p:spPr>
           <a:xfrm>
-            <a:off x="9445752" y="3022092"/>
+            <a:off x="9445752" y="3502152"/>
             <a:ext cx="210312" cy="219456"/>
           </a:xfrm>
           <a:prstGeom prst="rightArrow">
@@ -4690,12 +4573,12 @@
         </p:nvSpPr>
         <p:spPr>
           <a:xfrm>
-            <a:off x="9729216" y="1965960"/>
-            <a:ext cx="1938528" cy="2331720"/>
+            <a:off x="9729216" y="2697480"/>
+            <a:ext cx="1938528" cy="1828800"/>
           </a:xfrm>
           <a:prstGeom prst="roundRect">
             <a:avLst>
-              <a:gd name="adj" fmla="val 4717"/>
+              <a:gd name="adj" fmla="val 5000"/>
             </a:avLst>
           </a:prstGeom>
           <a:solidFill>
@@ -4717,7 +4600,7 @@
         </p:nvSpPr>
         <p:spPr>
           <a:xfrm>
-            <a:off x="9912096" y="2167128"/>
+            <a:off x="9912096" y="2898648"/>
             <a:ext cx="457200" cy="320040"/>
           </a:xfrm>
           <a:prstGeom prst="rect">
@@ -4756,7 +4639,7 @@
         </p:nvSpPr>
         <p:spPr>
           <a:xfrm>
-            <a:off x="9912096" y="2532888"/>
+            <a:off x="9912096" y="3264408"/>
             <a:ext cx="1572768" cy="411480"/>
           </a:xfrm>
           <a:prstGeom prst="rect">
@@ -4795,8 +4678,8 @@
         </p:nvSpPr>
         <p:spPr>
           <a:xfrm>
-            <a:off x="9912096" y="3017520"/>
-            <a:ext cx="1618488" cy="1600200"/>
+            <a:off x="9912096" y="3794760"/>
+            <a:ext cx="1618488" cy="640080"/>
           </a:xfrm>
           <a:prstGeom prst="rect">
             <a:avLst/>
@@ -4812,7 +4695,7 @@
               <a:buNone/>
             </a:pPr>
             <a:r>
-              <a:rPr lang="en-US" sz="1400" dirty="0">
+              <a:rPr lang="en-US" sz="1600" dirty="0">
                 <a:solidFill>
                   <a:srgbClr val="AEB6C2"/>
                 </a:solidFill>
@@ -4820,9 +4703,9 @@
                 <a:ea typeface="Calibri" pitchFamily="34" charset="-122"/>
                 <a:cs typeface="Calibri" pitchFamily="34" charset="-120"/>
               </a:rPr>
-              <a:t>Hard timer, fallback strategy, output check: a forfeit is impossible</a:t>
-            </a:r>
-            <a:endParaRPr lang="en-US" sz="1400" dirty="0"/>
+              <a:t>never a forfeit</a:t>
+            </a:r>
+            <a:endParaRPr lang="en-US" sz="1600" dirty="0"/>
           </a:p>
         </p:txBody>
       </p:sp>
@@ -4834,7 +4717,7 @@
         </p:nvSpPr>
         <p:spPr>
           <a:xfrm>
-            <a:off x="5321808" y="4498848"/>
+            <a:off x="5321808" y="4727448"/>
             <a:ext cx="3867912" cy="384048"/>
           </a:xfrm>
           <a:prstGeom prst="roundRect">
@@ -4861,7 +4744,7 @@
         </p:nvSpPr>
         <p:spPr>
           <a:xfrm>
-            <a:off x="5321808" y="4498848"/>
+            <a:off x="5321808" y="4727448"/>
             <a:ext cx="3867912" cy="384048"/>
           </a:xfrm>
           <a:prstGeom prst="rect">
@@ -4900,7 +4783,7 @@
         </p:nvSpPr>
         <p:spPr>
           <a:xfrm>
-            <a:off x="548640" y="1572768"/>
+            <a:off x="548640" y="2304288"/>
             <a:ext cx="2286000" cy="274320"/>
           </a:xfrm>
           <a:prstGeom prst="rect">
@@ -4939,7 +4822,7 @@
         </p:nvSpPr>
         <p:spPr>
           <a:xfrm>
-            <a:off x="9357055" y="1572768"/>
+            <a:off x="9357055" y="2304288"/>
             <a:ext cx="2286000" cy="274320"/>
           </a:xfrm>
           <a:prstGeom prst="rect">
@@ -4967,112 +4850,6 @@
               <a:t>strategy.py out</a:t>
             </a:r>
             <a:endParaRPr lang="en-US" sz="1200" dirty="0"/>
-          </a:p>
-        </p:txBody>
-      </p:sp>
-      <p:sp>
-        <p:nvSpPr>
-          <p:cNvPr id="32" name="Text 30"/>
-          <p:cNvSpPr txBox="1"/>
-          <p:nvPr/>
-        </p:nvSpPr>
-        <p:spPr>
-          <a:xfrm>
-            <a:off x="548640" y="5349240"/>
-            <a:ext cx="5394960" cy="594360"/>
-          </a:xfrm>
-          <a:prstGeom prst="rect">
-            <a:avLst/>
-          </a:prstGeom>
-          <a:noFill/>
-          <a:ln/>
-        </p:spPr>
-        <p:txBody>
-          <a:bodyPr wrap="square" lIns="0" tIns="0" rIns="0" bIns="0" rtlCol="0" anchor="t"/>
-          <a:lstStyle/>
-          <a:p>
-            <a:pPr indent="0" marL="0">
-              <a:buNone/>
-            </a:pPr>
-            <a:r>
-              <a:rPr lang="en-US" sz="1400" b="1" dirty="0">
-                <a:solidFill>
-                  <a:srgbClr val="F3F0E8"/>
-                </a:solidFill>
-                <a:latin typeface="Calibri" pitchFamily="34" charset="0"/>
-                <a:ea typeface="Calibri" pitchFamily="34" charset="-122"/>
-                <a:cs typeface="Calibri" pitchFamily="34" charset="-120"/>
-              </a:rPr>
-              <a:t>Budget  </a:t>
-            </a:r>
-            <a:pPr indent="0" marL="0">
-              <a:buNone/>
-            </a:pPr>
-            <a:r>
-              <a:rPr lang="en-US" sz="1400" dirty="0">
-                <a:solidFill>
-                  <a:srgbClr val="AEB6C2"/>
-                </a:solidFill>
-                <a:latin typeface="Calibri" pitchFamily="34" charset="0"/>
-                <a:ea typeface="Calibri" pitchFamily="34" charset="-122"/>
-                <a:cs typeface="Calibri" pitchFamily="34" charset="-120"/>
-              </a:rPr>
-              <a:t>Every call reserves its worst-case cost before it is sent: it cannot overspend.</a:t>
-            </a:r>
-            <a:endParaRPr lang="en-US" sz="1400" dirty="0"/>
-          </a:p>
-        </p:txBody>
-      </p:sp>
-      <p:sp>
-        <p:nvSpPr>
-          <p:cNvPr id="33" name="Text 31"/>
-          <p:cNvSpPr txBox="1"/>
-          <p:nvPr/>
-        </p:nvSpPr>
-        <p:spPr>
-          <a:xfrm>
-            <a:off x="6217920" y="5349240"/>
-            <a:ext cx="5394960" cy="594360"/>
-          </a:xfrm>
-          <a:prstGeom prst="rect">
-            <a:avLst/>
-          </a:prstGeom>
-          <a:noFill/>
-          <a:ln/>
-        </p:spPr>
-        <p:txBody>
-          <a:bodyPr wrap="square" lIns="0" tIns="0" rIns="0" bIns="0" rtlCol="0" anchor="t"/>
-          <a:lstStyle/>
-          <a:p>
-            <a:pPr indent="0" marL="0">
-              <a:buNone/>
-            </a:pPr>
-            <a:r>
-              <a:rPr lang="en-US" sz="1400" b="1" dirty="0">
-                <a:solidFill>
-                  <a:srgbClr val="F3F0E8"/>
-                </a:solidFill>
-                <a:latin typeface="Calibri" pitchFamily="34" charset="0"/>
-                <a:ea typeface="Calibri" pitchFamily="34" charset="-122"/>
-                <a:cs typeface="Calibri" pitchFamily="34" charset="-120"/>
-              </a:rPr>
-              <a:t>Deadline  </a:t>
-            </a:r>
-            <a:pPr indent="0" marL="0">
-              <a:buNone/>
-            </a:pPr>
-            <a:r>
-              <a:rPr lang="en-US" sz="1400" dirty="0">
-                <a:solidFill>
-                  <a:srgbClr val="AEB6C2"/>
-                </a:solidFill>
-                <a:latin typeface="Calibri" pitchFamily="34" charset="0"/>
-                <a:ea typeface="Calibri" pitchFamily="34" charset="-122"/>
-                <a:cs typeface="Calibri" pitchFamily="34" charset="-120"/>
-              </a:rPr>
-              <a:t>The clock counts from container start; the file on disk is valid at every second.</a:t>
-            </a:r>
-            <a:endParaRPr lang="en-US" sz="1400" dirty="0"/>
           </a:p>
         </p:txBody>
       </p:sp>
@@ -5301,7 +5078,7 @@
                 <a:ea typeface="Calibri" pitchFamily="34" charset="-122"/>
                 <a:cs typeface="Calibri" pitchFamily="34" charset="-120"/>
               </a:rPr>
-              <a:t>games: 2 dev, 6 our own, 2 of them held out</a:t>
+              <a:t>games, 2 held out</a:t>
             </a:r>
             <a:endParaRPr lang="en-US" sz="1400" dirty="0"/>
           </a:p>
@@ -5379,7 +5156,7 @@
                 <a:ea typeface="Calibri" pitchFamily="34" charset="-122"/>
                 <a:cs typeface="Calibri" pitchFamily="34" charset="-120"/>
               </a:rPr>
-              <a:t>harness runs, every one measured</a:t>
+              <a:t>measured runs</a:t>
             </a:r>
             <a:endParaRPr lang="en-US" sz="1400" dirty="0"/>
           </a:p>
@@ -5457,7 +5234,7 @@
                 <a:ea typeface="Calibri" pitchFamily="34" charset="-122"/>
                 <a:cs typeface="Calibri" pitchFamily="34" charset="-120"/>
               </a:rPr>
-              <a:t>API cost in total</a:t>
+              <a:t>API cost</a:t>
             </a:r>
             <a:endParaRPr lang="en-US" sz="1400" dirty="0"/>
           </a:p>
@@ -5496,7 +5273,7 @@
                 <a:ea typeface="Calibri" pitchFamily="34" charset="-122"/>
                 <a:cs typeface="Calibri" pitchFamily="34" charset="-120"/>
               </a:rPr>
-              <a:t>Claude Code as the engineering team: parallel agents wrote and reviewed every module, held to 216 automated tests.</a:t>
+              <a:t>Built with Claude Code  ·  216 automated tests</a:t>
             </a:r>
             <a:endParaRPr lang="en-US" sz="1600" dirty="0"/>
           </a:p>
@@ -5608,7 +5385,7 @@
                 <a:ea typeface="Century Gothic" pitchFamily="34" charset="-122"/>
                 <a:cs typeface="Century Gothic" pitchFamily="34" charset="-120"/>
               </a:rPr>
-              <a:t>Ablation · 24 runs</a:t>
+              <a:t>Ablation</a:t>
             </a:r>
             <a:endParaRPr lang="en-US" sz="1800" dirty="0"/>
           </a:p>
@@ -5647,7 +5424,7 @@
                 <a:ea typeface="Calibri" pitchFamily="34" charset="-122"/>
                 <a:cs typeface="Calibri" pitchFamily="34" charset="-120"/>
               </a:rPr>
-              <a:t>Pipeline ≫ one-shot. Improvement rounds: the biggest gain. The sparring draft hurt selection: removed.</a:t>
+              <a:t>kept only what wins</a:t>
             </a:r>
             <a:endParaRPr lang="en-US" sz="1400" dirty="0"/>
           </a:p>
@@ -5759,7 +5536,7 @@
                 <a:ea typeface="Century Gothic" pitchFamily="34" charset="-122"/>
                 <a:cs typeface="Century Gothic" pitchFamily="34" charset="-120"/>
               </a:rPr>
-              <a:t>Tournament conditions · 18 runs</a:t>
+              <a:t>Tournament conditions</a:t>
             </a:r>
             <a:endParaRPr lang="en-US" sz="1800" dirty="0"/>
           </a:p>
@@ -5798,7 +5575,7 @@
                 <a:ea typeface="Calibri" pitchFamily="34" charset="-122"/>
                 <a:cs typeface="Calibri" pitchFamily="34" charset="-120"/>
               </a:rPr>
-              <a:t>Self-play now runs with the real time limits. Spare-time seeds and medium-effort improvement: kept.</a:t>
+              <a:t>selection = reality</a:t>
             </a:r>
             <a:endParaRPr lang="en-US" sz="1400" dirty="0"/>
           </a:p>
@@ -5910,7 +5687,7 @@
                 <a:ea typeface="Century Gothic" pitchFamily="34" charset="-122"/>
                 <a:cs typeface="Century Gothic" pitchFamily="34" charset="-120"/>
               </a:rPr>
-              <a:t>Failure mining · every log</a:t>
+              <a:t>Failure mining</a:t>
             </a:r>
             <a:endParaRPr lang="en-US" sz="1800" dirty="0"/>
           </a:p>
@@ -5949,7 +5726,7 @@
                 <a:ea typeface="Calibri" pitchFamily="34" charset="-122"/>
                 <a:cs typeface="Calibri" pitchFamily="34" charset="-120"/>
               </a:rPr>
-              <a:t>Two agents mined all runs: 3 defects fixed, 6 ideas queued, each to pass a with/without test.</a:t>
+              <a:t>3 defects fixed</a:t>
             </a:r>
             <a:endParaRPr lang="en-US" sz="1400" dirty="0"/>
           </a:p>
@@ -6230,7 +6007,7 @@
                 <a:ea typeface="Calibri" pitchFamily="34" charset="-122"/>
                 <a:cs typeface="Calibri" pitchFamily="34" charset="-120"/>
               </a:rPr>
-              <a:t>pipeline vs one-shot, head-to-head on beta (gamma: 46–1–1)</a:t>
+              <a:t>vs. one-shot, head-to-head</a:t>
             </a:r>
             <a:endParaRPr lang="en-US" sz="1400" dirty="0"/>
           </a:p>
@@ -6238,48 +6015,14 @@
       </p:sp>
       <p:sp>
         <p:nvSpPr>
-          <p:cNvPr id="8" name="callout 2"/>
-          <p:cNvSpPr/>
-          <p:nvPr/>
-        </p:nvSpPr>
-        <p:spPr>
-          <a:xfrm>
-            <a:off x="8549640" y="3886200"/>
-            <a:ext cx="3093415" cy="1783080"/>
-          </a:xfrm>
-          <a:prstGeom prst="roundRect">
-            <a:avLst>
-              <a:gd name="adj" fmla="val 5128"/>
-            </a:avLst>
-          </a:prstGeom>
-          <a:solidFill>
-            <a:srgbClr val="FFFFFF"/>
-          </a:solidFill>
-          <a:ln w="9525">
-            <a:solidFill>
-              <a:srgbClr val="D9DDE3"/>
-            </a:solidFill>
-            <a:prstDash val="solid"/>
-          </a:ln>
-          <a:effectLst>
-            <a:outerShdw sx="100000" sy="100000" kx="0" ky="0" algn="bl" rotWithShape="0" blurRad="101600" dist="25400" dir="5400000">
-              <a:srgbClr val="000000">
-                <a:alpha val="8000"/>
-              </a:srgbClr>
-            </a:outerShdw>
-          </a:effectLst>
-        </p:spPr>
-      </p:sp>
-      <p:sp>
-        <p:nvSpPr>
-          <p:cNvPr id="9" name="Text 6"/>
-          <p:cNvSpPr txBox="1"/>
-          <p:nvPr/>
-        </p:nvSpPr>
-        <p:spPr>
-          <a:xfrm>
-            <a:off x="8823960" y="4114800"/>
-            <a:ext cx="2544775" cy="640080"/>
+          <p:cNvPr id="8" name="Text 5"/>
+          <p:cNvSpPr txBox="1"/>
+          <p:nvPr/>
+        </p:nvSpPr>
+        <p:spPr>
+          <a:xfrm>
+            <a:off x="548640" y="6035040"/>
+            <a:ext cx="10424160" cy="320040"/>
           </a:xfrm>
           <a:prstGeom prst="rect">
             <a:avLst/>
@@ -6295,93 +6038,15 @@
               <a:buNone/>
             </a:pPr>
             <a:r>
-              <a:rPr lang="en-US" sz="3200" b="1" dirty="0">
-                <a:solidFill>
-                  <a:srgbClr val="14171C"/>
-                </a:solidFill>
-                <a:latin typeface="Century Gothic" pitchFamily="34" charset="0"/>
-                <a:ea typeface="Century Gothic" pitchFamily="34" charset="-122"/>
-                <a:cs typeface="Century Gothic" pitchFamily="34" charset="-120"/>
-              </a:rPr>
-              <a:t>2 of 3</a:t>
-            </a:r>
-            <a:endParaRPr lang="en-US" sz="3200" dirty="0"/>
-          </a:p>
-        </p:txBody>
-      </p:sp>
-      <p:sp>
-        <p:nvSpPr>
-          <p:cNvPr id="10" name="Text 7"/>
-          <p:cNvSpPr txBox="1"/>
-          <p:nvPr/>
-        </p:nvSpPr>
-        <p:spPr>
-          <a:xfrm>
-            <a:off x="8823960" y="4800600"/>
-            <a:ext cx="2544775" cy="731520"/>
-          </a:xfrm>
-          <a:prstGeom prst="rect">
-            <a:avLst/>
-          </a:prstGeom>
-          <a:noFill/>
-          <a:ln/>
-        </p:spPr>
-        <p:txBody>
-          <a:bodyPr wrap="square" lIns="0" tIns="0" rIns="0" bIns="0" rtlCol="0" anchor="t"/>
-          <a:lstStyle/>
-          <a:p>
-            <a:pPr indent="0" marL="0">
-              <a:buNone/>
-            </a:pPr>
-            <a:r>
-              <a:rPr lang="en-US" sz="1400" dirty="0">
-                <a:solidFill>
-                  <a:srgbClr val="4A5260"/>
+              <a:rPr lang="en-US" sz="1100" dirty="0">
+                <a:solidFill>
+                  <a:srgbClr val="6B7380"/>
                 </a:solidFill>
                 <a:latin typeface="Calibri" pitchFamily="34" charset="0"/>
                 <a:ea typeface="Calibri" pitchFamily="34" charset="-122"/>
                 <a:cs typeface="Calibri" pitchFamily="34" charset="-120"/>
               </a:rPr>
-              <a:t>games lost by each feature we tried to remove in epoch 2</a:t>
-            </a:r>
-            <a:endParaRPr lang="en-US" sz="1400" dirty="0"/>
-          </a:p>
-        </p:txBody>
-      </p:sp>
-      <p:sp>
-        <p:nvSpPr>
-          <p:cNvPr id="11" name="Text 8"/>
-          <p:cNvSpPr txBox="1"/>
-          <p:nvPr/>
-        </p:nvSpPr>
-        <p:spPr>
-          <a:xfrm>
-            <a:off x="548640" y="6035040"/>
-            <a:ext cx="10424160" cy="320040"/>
-          </a:xfrm>
-          <a:prstGeom prst="rect">
-            <a:avLst/>
-          </a:prstGeom>
-          <a:noFill/>
-          <a:ln/>
-        </p:spPr>
-        <p:txBody>
-          <a:bodyPr wrap="square" lIns="0" tIns="0" rIns="0" bIns="0" rtlCol="0" anchor="ctr"/>
-          <a:lstStyle/>
-          <a:p>
-            <a:pPr indent="0" marL="0">
-              <a:buNone/>
-            </a:pPr>
-            <a:r>
-              <a:rPr lang="en-US" sz="1100" dirty="0">
-                <a:solidFill>
-                  <a:srgbClr val="6B7380"/>
-                </a:solidFill>
-                <a:latin typeface="Calibri" pitchFamily="34" charset="0"/>
-                <a:ea typeface="Calibri" pitchFamily="34" charset="-122"/>
-                <a:cs typeface="Calibri" pitchFamily="34" charset="-120"/>
-              </a:rPr>
-              <a:t>Net points per strategy (win +1, draw 0, loss −1 per match), summed over 3 games: cross-tournament of the variants, both seats, 6 seeds.</a:t>
+              <a:t>Net points, 3 games, +1 / 0 / −1 per match</a:t>
             </a:r>
             <a:endParaRPr lang="en-US" sz="1100" dirty="0"/>
           </a:p>
@@ -6548,7 +6213,7 @@
         </p:nvSpPr>
         <p:spPr>
           <a:xfrm>
-            <a:off x="548640" y="2331720"/>
+            <a:off x="548640" y="2743200"/>
             <a:ext cx="3520440" cy="1097280"/>
           </a:xfrm>
           <a:prstGeom prst="rect">
@@ -6587,7 +6252,7 @@
         </p:nvSpPr>
         <p:spPr>
           <a:xfrm>
-            <a:off x="548640" y="3611880"/>
+            <a:off x="548640" y="4023360"/>
             <a:ext cx="1097280" cy="0"/>
           </a:xfrm>
           <a:prstGeom prst="line">
@@ -6610,8 +6275,8 @@
         </p:nvSpPr>
         <p:spPr>
           <a:xfrm>
-            <a:off x="548640" y="3840480"/>
-            <a:ext cx="3337560" cy="1188720"/>
+            <a:off x="548640" y="4251960"/>
+            <a:ext cx="3337560" cy="548640"/>
           </a:xfrm>
           <a:prstGeom prst="rect">
             <a:avLst/>
@@ -6627,7 +6292,7 @@
               <a:buNone/>
             </a:pPr>
             <a:r>
-              <a:rPr lang="en-US" sz="1800" dirty="0">
+              <a:rPr lang="en-US" sz="2200" dirty="0">
                 <a:solidFill>
                   <a:srgbClr val="2A1408"/>
                 </a:solidFill>
@@ -6635,9 +6300,9 @@
                 <a:ea typeface="Calibri" pitchFamily="34" charset="-122"/>
                 <a:cs typeface="Calibri" pitchFamily="34" charset="-120"/>
               </a:rPr>
-              <a:t>vs one-shot on a held-out game with hidden demand, random surges and typed units</a:t>
-            </a:r>
-            <a:endParaRPr lang="en-US" sz="1800" dirty="0"/>
+              <a:t>held-out game 1</a:t>
+            </a:r>
+            <a:endParaRPr lang="en-US" sz="2200" dirty="0"/>
           </a:p>
         </p:txBody>
       </p:sp>
@@ -6649,7 +6314,7 @@
         </p:nvSpPr>
         <p:spPr>
           <a:xfrm>
-            <a:off x="4343400" y="2331720"/>
+            <a:off x="4343400" y="2743200"/>
             <a:ext cx="3520440" cy="1097280"/>
           </a:xfrm>
           <a:prstGeom prst="rect">
@@ -6688,7 +6353,7 @@
         </p:nvSpPr>
         <p:spPr>
           <a:xfrm>
-            <a:off x="4343400" y="3611880"/>
+            <a:off x="4343400" y="4023360"/>
             <a:ext cx="1097280" cy="0"/>
           </a:xfrm>
           <a:prstGeom prst="line">
@@ -6711,8 +6376,8 @@
         </p:nvSpPr>
         <p:spPr>
           <a:xfrm>
-            <a:off x="4343400" y="3840480"/>
-            <a:ext cx="3337560" cy="1188720"/>
+            <a:off x="4343400" y="4251960"/>
+            <a:ext cx="3337560" cy="548640"/>
           </a:xfrm>
           <a:prstGeom prst="rect">
             <a:avLst/>
@@ -6728,7 +6393,7 @@
               <a:buNone/>
             </a:pPr>
             <a:r>
-              <a:rPr lang="en-US" sz="1800" dirty="0">
+              <a:rPr lang="en-US" sz="2200" dirty="0">
                 <a:solidFill>
                   <a:srgbClr val="2A1408"/>
                 </a:solidFill>
@@ -6736,9 +6401,9 @@
                 <a:ea typeface="Calibri" pitchFamily="34" charset="-122"/>
                 <a:cs typeface="Calibri" pitchFamily="34" charset="-120"/>
               </a:rPr>
-              <a:t>on a held-out game with renamed fields and nested-dict actions</a:t>
-            </a:r>
-            <a:endParaRPr lang="en-US" sz="1800" dirty="0"/>
+              <a:t>held-out game 2</a:t>
+            </a:r>
+            <a:endParaRPr lang="en-US" sz="2200" dirty="0"/>
           </a:p>
         </p:txBody>
       </p:sp>
@@ -6750,7 +6415,7 @@
         </p:nvSpPr>
         <p:spPr>
           <a:xfrm>
-            <a:off x="8138160" y="2331720"/>
+            <a:off x="8138160" y="2743200"/>
             <a:ext cx="3520440" cy="1097280"/>
           </a:xfrm>
           <a:prstGeom prst="rect">
@@ -6789,7 +6454,7 @@
         </p:nvSpPr>
         <p:spPr>
           <a:xfrm>
-            <a:off x="8138160" y="3611880"/>
+            <a:off x="8138160" y="4023360"/>
             <a:ext cx="1097280" cy="0"/>
           </a:xfrm>
           <a:prstGeom prst="line">
@@ -6812,8 +6477,8 @@
         </p:nvSpPr>
         <p:spPr>
           <a:xfrm>
-            <a:off x="8138160" y="3840480"/>
-            <a:ext cx="3337560" cy="1188720"/>
+            <a:off x="8138160" y="4251960"/>
+            <a:ext cx="3337560" cy="548640"/>
           </a:xfrm>
           <a:prstGeom prst="rect">
             <a:avLst/>
@@ -6829,7 +6494,7 @@
               <a:buNone/>
             </a:pPr>
             <a:r>
-              <a:rPr lang="en-US" sz="1800" dirty="0">
+              <a:rPr lang="en-US" sz="2200" dirty="0">
                 <a:solidFill>
                   <a:srgbClr val="2A1408"/>
                 </a:solidFill>
@@ -6837,48 +6502,9 @@
                 <a:ea typeface="Calibri" pitchFamily="34" charset="-122"/>
                 <a:cs typeface="Calibri" pitchFamily="34" charset="-120"/>
               </a:rPr>
-              <a:t>delivered strategies pass the arena conformance check: zero forfeits</a:t>
-            </a:r>
-            <a:endParaRPr lang="en-US" sz="1800" dirty="0"/>
-          </a:p>
-        </p:txBody>
-      </p:sp>
-      <p:sp>
-        <p:nvSpPr>
-          <p:cNvPr id="13" name="Text 11"/>
-          <p:cNvSpPr txBox="1"/>
-          <p:nvPr/>
-        </p:nvSpPr>
-        <p:spPr>
-          <a:xfrm>
-            <a:off x="548640" y="5760720"/>
-            <a:ext cx="10515600" cy="365760"/>
-          </a:xfrm>
-          <a:prstGeom prst="rect">
-            <a:avLst/>
-          </a:prstGeom>
-          <a:noFill/>
-          <a:ln/>
-        </p:spPr>
-        <p:txBody>
-          <a:bodyPr wrap="square" lIns="0" tIns="0" rIns="0" bIns="0" rtlCol="0" anchor="ctr"/>
-          <a:lstStyle/>
-          <a:p>
-            <a:pPr indent="0" marL="0">
-              <a:buNone/>
-            </a:pPr>
-            <a:r>
-              <a:rPr lang="en-US" sz="1400" dirty="0">
-                <a:solidFill>
-                  <a:srgbClr val="2A1408"/>
-                </a:solidFill>
-                <a:latin typeface="Calibri" pitchFamily="34" charset="0"/>
-                <a:ea typeface="Calibri" pitchFamily="34" charset="-122"/>
-                <a:cs typeface="Calibri" pitchFamily="34" charset="-120"/>
-              </a:rPr>
-              <a:t>Task C check (sol + astra, 15 min): 100% of matches won against the baselines.</a:t>
-            </a:r>
-            <a:endParaRPr lang="en-US" sz="1400" dirty="0"/>
+              <a:t>zero forfeits</a:t>
+            </a:r>
+            <a:endParaRPr lang="en-US" sz="2200" dirty="0"/>
           </a:p>
         </p:txBody>
       </p:sp>
@@ -7264,7 +6890,7 @@
                 <a:ea typeface="Calibri" pitchFamily="34" charset="-122"/>
                 <a:cs typeface="Calibri" pitchFamily="34" charset="-120"/>
               </a:rPr>
-              <a:t>First valid draft takes the lead</a:t>
+              <a:t>first draft leads</a:t>
             </a:r>
             <a:endParaRPr lang="en-US" sz="1400" dirty="0"/>
           </a:p>
@@ -7367,7 +6993,7 @@
                 <a:ea typeface="Calibri" pitchFamily="34" charset="-122"/>
                 <a:cs typeface="Calibri" pitchFamily="34" charset="-120"/>
               </a:rPr>
-              <a:t>Simulator fails a worked example</a:t>
+              <a:t>simulator fails a check</a:t>
             </a:r>
             <a:endParaRPr lang="en-US" sz="1400" dirty="0"/>
           </a:p>
@@ -7470,7 +7096,7 @@
                 <a:ea typeface="Calibri" pitchFamily="34" charset="-122"/>
                 <a:cs typeface="Calibri" pitchFamily="34" charset="-120"/>
               </a:rPr>
-              <a:t>Repaired simulator passes every check</a:t>
+              <a:t>simulator repaired</a:t>
             </a:r>
             <a:endParaRPr lang="en-US" sz="1400" dirty="0"/>
           </a:p>
@@ -7573,7 +7199,7 @@
                 <a:ea typeface="Calibri" pitchFamily="34" charset="-122"/>
                 <a:cs typeface="Calibri" pitchFamily="34" charset="-120"/>
               </a:rPr>
-              <a:t>Self-play ranks 3 drafts, both seats</a:t>
+              <a:t>self-play ranking</a:t>
             </a:r>
             <a:endParaRPr lang="en-US" sz="1400" dirty="0"/>
           </a:p>
@@ -7676,7 +7302,7 @@
                 <a:ea typeface="Calibri" pitchFamily="34" charset="-122"/>
                 <a:cs typeface="Calibri" pitchFamily="34" charset="-120"/>
               </a:rPr>
-              <a:t>Improvement round: a challenger joins</a:t>
+              <a:t>a challenger joins</a:t>
             </a:r>
             <a:endParaRPr lang="en-US" sz="1400" dirty="0"/>
           </a:p>
@@ -7779,7 +7405,7 @@
                 <a:ea typeface="Calibri" pitchFamily="34" charset="-122"/>
                 <a:cs typeface="Calibri" pitchFamily="34" charset="-120"/>
               </a:rPr>
-              <a:t>Final probe passed: strategy.py out</a:t>
+              <a:t>strategy delivered</a:t>
             </a:r>
             <a:endParaRPr lang="en-US" sz="1400" dirty="0"/>
           </a:p>
@@ -7821,45 +7447,6 @@
               <a:t>Spec in. Strategy out. Never a forfeit.</a:t>
             </a:r>
             <a:endParaRPr lang="en-US" sz="2600" dirty="0"/>
-          </a:p>
-        </p:txBody>
-      </p:sp>
-      <p:sp>
-        <p:nvSpPr>
-          <p:cNvPr id="27" name="Text 25"/>
-          <p:cNvSpPr txBox="1"/>
-          <p:nvPr/>
-        </p:nvSpPr>
-        <p:spPr>
-          <a:xfrm>
-            <a:off x="548640" y="6053328"/>
-            <a:ext cx="7772400" cy="320040"/>
-          </a:xfrm>
-          <a:prstGeom prst="rect">
-            <a:avLst/>
-          </a:prstGeom>
-          <a:noFill/>
-          <a:ln/>
-        </p:spPr>
-        <p:txBody>
-          <a:bodyPr wrap="square" lIns="0" tIns="0" rIns="0" bIns="0" rtlCol="0" anchor="ctr"/>
-          <a:lstStyle/>
-          <a:p>
-            <a:pPr indent="0" marL="0">
-              <a:buNone/>
-            </a:pPr>
-            <a:r>
-              <a:rPr lang="en-US" sz="1400" dirty="0">
-                <a:solidFill>
-                  <a:srgbClr val="AEB6C2"/>
-                </a:solidFill>
-                <a:latin typeface="Calibri" pitchFamily="34" charset="0"/>
-                <a:ea typeface="Calibri" pitchFamily="34" charset="-122"/>
-                <a:cs typeface="Calibri" pitchFamily="34" charset="-120"/>
-              </a:rPr>
-              <a:t>Task A profile in the evaluation’s Docker container: $0.018 of $0.03.</a:t>
-            </a:r>
-            <a:endParaRPr lang="en-US" sz="1400" dirty="0"/>
           </a:p>
         </p:txBody>
       </p:sp>

</xml_diff>

<commit_message>
pitch: label the result numbers (wins - draws - losses vs the one-shot baseline); demo slide says it is one run from spec to strategy.py
Co-Authored-By: Claude Opus 5.5 (1M context) <noreply@anthropic.com>
</commit_message>
<xml_diff>
--- a/docs/presentation/pitch.pptx
+++ b/docs/presentation/pitch.pptx
@@ -113,19 +113,19 @@
   <p:extLst>
     <p:ext uri="{521415D9-36F7-43E2-AB2F-B90AF26B5E84}">
       <p14:sectionLst xmlns:p14="http://schemas.microsoft.com/office/powerpoint/2010/main">
-        <p14:section name="Why" id="{3de4b236-e1e0-7c48-dae6-f7bc5f85186f}">
+        <p14:section name="Why" id="{70469b1c-d6e6-c36e-b3b8-84a52f11fd2f}">
           <p14:sldIdLst>
             <p14:sldId id="256"/>
             <p14:sldId id="257"/>
           </p14:sldIdLst>
         </p14:section>
-        <p14:section name="How" id="{7172eba6-0b57-1e86-863f-f5e4f7187830}">
+        <p14:section name="How" id="{ef0001cb-4fe7-6e90-c84c-ac0268334ee0}">
           <p14:sldIdLst>
             <p14:sldId id="258"/>
             <p14:sldId id="259"/>
           </p14:sldIdLst>
         </p14:section>
-        <p14:section name="Proof" id="{dfa87173-28dc-2771-c1f1-80202cd8f669}">
+        <p14:section name="Proof" id="{e4ef69ee-acf3-16af-733b-a9f96b3bd180}">
           <p14:sldIdLst>
             <p14:sldId id="260"/>
             <p14:sldId id="261"/>
@@ -6007,7 +6007,7 @@
                 <a:ea typeface="Calibri" pitchFamily="34" charset="-122"/>
                 <a:cs typeface="Calibri" pitchFamily="34" charset="-120"/>
               </a:rPr>
-              <a:t>vs. one-shot, head-to-head</a:t>
+              <a:t>wins – draws – losses against the one-shot baseline</a:t>
             </a:r>
             <a:endParaRPr lang="en-US" sz="1400" dirty="0"/>
           </a:p>
@@ -6213,6 +6213,45 @@
         </p:nvSpPr>
         <p:spPr>
           <a:xfrm>
+            <a:off x="548640" y="1600200"/>
+            <a:ext cx="10515600" cy="411480"/>
+          </a:xfrm>
+          <a:prstGeom prst="rect">
+            <a:avLst/>
+          </a:prstGeom>
+          <a:noFill/>
+          <a:ln/>
+        </p:spPr>
+        <p:txBody>
+          <a:bodyPr wrap="square" lIns="0" tIns="0" rIns="0" bIns="0" rtlCol="0" anchor="ctr"/>
+          <a:lstStyle/>
+          <a:p>
+            <a:pPr indent="0" marL="0">
+              <a:buNone/>
+            </a:pPr>
+            <a:r>
+              <a:rPr lang="en-US" sz="2000" dirty="0">
+                <a:solidFill>
+                  <a:srgbClr val="2A1408"/>
+                </a:solidFill>
+                <a:latin typeface="Calibri" pitchFamily="34" charset="0"/>
+                <a:ea typeface="Calibri" pitchFamily="34" charset="-122"/>
+                <a:cs typeface="Calibri" pitchFamily="34" charset="-120"/>
+              </a:rPr>
+              <a:t>Wins – draws – losses against the one-shot baseline, on 2 games never used for tuning</a:t>
+            </a:r>
+            <a:endParaRPr lang="en-US" sz="2000" dirty="0"/>
+          </a:p>
+        </p:txBody>
+      </p:sp>
+      <p:sp>
+        <p:nvSpPr>
+          <p:cNvPr id="5" name="Text 3"/>
+          <p:cNvSpPr txBox="1"/>
+          <p:nvPr/>
+        </p:nvSpPr>
+        <p:spPr>
+          <a:xfrm>
             <a:off x="548640" y="2743200"/>
             <a:ext cx="3520440" cy="1097280"/>
           </a:xfrm>
@@ -6246,7 +6285,7 @@
       </p:sp>
       <p:sp>
         <p:nvSpPr>
-          <p:cNvPr id="5" name="Shape 3"/>
+          <p:cNvPr id="6" name="Shape 4"/>
           <p:cNvSpPr/>
           <p:nvPr/>
         </p:nvSpPr>
@@ -6269,7 +6308,7 @@
       </p:sp>
       <p:sp>
         <p:nvSpPr>
-          <p:cNvPr id="6" name="Text 4"/>
+          <p:cNvPr id="7" name="Text 5"/>
           <p:cNvSpPr txBox="1"/>
           <p:nvPr/>
         </p:nvSpPr>
@@ -6308,7 +6347,7 @@
       </p:sp>
       <p:sp>
         <p:nvSpPr>
-          <p:cNvPr id="7" name="Text 5"/>
+          <p:cNvPr id="8" name="Text 6"/>
           <p:cNvSpPr txBox="1"/>
           <p:nvPr/>
         </p:nvSpPr>
@@ -6347,7 +6386,7 @@
       </p:sp>
       <p:sp>
         <p:nvSpPr>
-          <p:cNvPr id="8" name="Shape 6"/>
+          <p:cNvPr id="9" name="Shape 7"/>
           <p:cNvSpPr/>
           <p:nvPr/>
         </p:nvSpPr>
@@ -6370,7 +6409,7 @@
       </p:sp>
       <p:sp>
         <p:nvSpPr>
-          <p:cNvPr id="9" name="Text 7"/>
+          <p:cNvPr id="10" name="Text 8"/>
           <p:cNvSpPr txBox="1"/>
           <p:nvPr/>
         </p:nvSpPr>
@@ -6409,7 +6448,7 @@
       </p:sp>
       <p:sp>
         <p:nvSpPr>
-          <p:cNvPr id="10" name="Text 8"/>
+          <p:cNvPr id="11" name="Text 9"/>
           <p:cNvSpPr txBox="1"/>
           <p:nvPr/>
         </p:nvSpPr>
@@ -6448,7 +6487,7 @@
       </p:sp>
       <p:sp>
         <p:nvSpPr>
-          <p:cNvPr id="11" name="Shape 9"/>
+          <p:cNvPr id="12" name="Shape 10"/>
           <p:cNvSpPr/>
           <p:nvPr/>
         </p:nvSpPr>
@@ -6471,7 +6510,7 @@
       </p:sp>
       <p:sp>
         <p:nvSpPr>
-          <p:cNvPr id="12" name="Text 10"/>
+          <p:cNvPr id="13" name="Text 11"/>
           <p:cNvSpPr txBox="1"/>
           <p:nvPr/>
         </p:nvSpPr>
@@ -6502,7 +6541,7 @@
                 <a:ea typeface="Calibri" pitchFamily="34" charset="-122"/>
                 <a:cs typeface="Calibri" pitchFamily="34" charset="-120"/>
               </a:rPr>
-              <a:t>zero forfeits</a:t>
+              <a:t>strategies passed, zero forfeits</a:t>
             </a:r>
             <a:endParaRPr lang="en-US" sz="2200" dirty="0"/>
           </a:p>
@@ -6614,7 +6653,7 @@
                 <a:ea typeface="Consolas" pitchFamily="34" charset="-122"/>
                 <a:cs typeface="Consolas" pitchFamily="34" charset="-120"/>
               </a:rPr>
-              <a:t>DEMO · ONE REAL RUN</a:t>
+              <a:t>DEMO · ONE REAL RUN, FROM SPEC TO STRATEGY.PY</a:t>
             </a:r>
             <a:endParaRPr lang="en-US" sz="1200" dirty="0"/>
           </a:p>

</xml_diff>

<commit_message>
pitch: final numbers (10 games, 120+ runs, ~$45, 416 tests), midpoint evaluation slide replaces the ablation and exam slides, research claim as stated in the paper
Co-Authored-By: Claude Opus 5.5 (1M context) <noreply@anthropic.com>
</commit_message>
<xml_diff>
--- a/docs/presentation/pitch.pptx
+++ b/docs/presentation/pitch.pptx
@@ -11,10 +11,9 @@
     <p:sldId id="259" r:id="rId5"/>
     <p:sldId id="260" r:id="rId6"/>
     <p:sldId id="261" r:id="rId7"/>
-    <p:sldId id="262" r:id="rId8"/>
   </p:sldIdLst>
   <p:notesMasterIdLst>
-    <p:notesMasterId r:id="rId9"/>
+    <p:notesMasterId r:id="rId8"/>
   </p:notesMasterIdLst>
   <p:sldSz cx="12192000" cy="6858000"/>
   <p:notesSz cx="6858000" cy="12192000"/>
@@ -113,23 +112,22 @@
   <p:extLst>
     <p:ext uri="{521415D9-36F7-43E2-AB2F-B90AF26B5E84}">
       <p14:sectionLst xmlns:p14="http://schemas.microsoft.com/office/powerpoint/2010/main">
-        <p14:section name="Why" id="{70469b1c-d6e6-c36e-b3b8-84a52f11fd2f}">
+        <p14:section name="Why" id="{5f3eb38d-ef0c-7841-1ca6-405cfc8d5649}">
           <p14:sldIdLst>
             <p14:sldId id="256"/>
             <p14:sldId id="257"/>
           </p14:sldIdLst>
         </p14:section>
-        <p14:section name="How" id="{ef0001cb-4fe7-6e90-c84c-ac0268334ee0}">
+        <p14:section name="How" id="{77a9d6fd-a493-1b2d-d131-ca8aef5e91e3}">
           <p14:sldIdLst>
             <p14:sldId id="258"/>
             <p14:sldId id="259"/>
           </p14:sldIdLst>
         </p14:section>
-        <p14:section name="Proof" id="{e4ef69ee-acf3-16af-733b-a9f96b3bd180}">
+        <p14:section name="Proof" id="{740777e5-093f-14b2-95f8-007a0fcc4ea9}">
           <p14:sldIdLst>
             <p14:sldId id="260"/>
             <p14:sldId id="261"/>
-            <p14:sldId id="262"/>
           </p14:sldIdLst>
         </p14:section>
       </p14:sectionLst>
@@ -139,285 +137,6 @@
     </p:ext>
   </p:extLst>
 </p:presentation>
-</file>
-
-<file path=ppt/charts/chart1.xml><?xml version="1.0" encoding="utf-8"?>
-<c:chartSpace xmlns:c="http://schemas.openxmlformats.org/drawingml/2006/chart" xmlns:a="http://schemas.openxmlformats.org/drawingml/2006/main" xmlns:r="http://schemas.openxmlformats.org/officeDocument/2006/relationships">
-  <c:date1904 val="0"/>
-  <c:roundedCorners val="1"/>
-  <c:chart>
-    <c:autoTitleDeleted val="1"/>
-    <c:plotArea>
-      <c:layout/>
-      <c:barChart>
-        <c:barDir val="bar"/>
-        <c:grouping val="clustered"/>
-        <c:varyColors val="0"/>
-        <c:ser>
-          <c:idx val="0"/>
-          <c:order val="0"/>
-          <c:tx>
-            <c:strRef>
-              <c:f>Sheet1!$B$1</c:f>
-              <c:strCache>
-                <c:ptCount val="1"/>
-                <c:pt idx="0">
-                  <c:v>Net points per strategy</c:v>
-                </c:pt>
-              </c:strCache>
-            </c:strRef>
-          </c:tx>
-          <c:spPr>
-            <a:solidFill>
-              <a:srgbClr val="B44A12"/>
-            </a:solidFill>
-            <a:effectLst/>
-          </c:spPr>
-          <c:invertIfNegative val="0"/>
-          <c:dLbls>
-            <c:numFmt formatCode="+0.0;−0.0;0" sourceLinked="0"/>
-            <c:txPr>
-              <a:bodyPr/>
-              <a:lstStyle/>
-              <a:p>
-                <a:pPr>
-                  <a:defRPr b="0" i="0" strike="noStrike" sz="1400" u="none">
-                    <a:solidFill>
-                      <a:srgbClr val="14171C"/>
-                    </a:solidFill>
-                    <a:latin typeface="+mn-lt"/>
-                  </a:defRPr>
-                </a:pPr>
-              </a:p>
-            </c:txPr>
-            <c:showLegendKey val="0"/>
-            <c:showVal val="1"/>
-            <c:showCatName val="0"/>
-            <c:showSerName val="0"/>
-            <c:showPercent val="0"/>
-            <c:showBubbleSize val="0"/>
-            <c:showLeaderLines val="0"/>
-          </c:dLbls>
-          <c:dPt>
-            <c:idx val="0"/>
-            <c:invertIfNegative val="0"/>
-            <c:bubble3D val="0"/>
-            <c:spPr>
-              <a:solidFill>
-                <a:srgbClr val="B44A12"/>
-              </a:solidFill>
-              <a:effectLst/>
-            </c:spPr>
-          </c:dPt>
-          <c:dPt>
-            <c:idx val="1"/>
-            <c:invertIfNegative val="0"/>
-            <c:bubble3D val="0"/>
-            <c:spPr>
-              <a:solidFill>
-                <a:srgbClr val="B44A12"/>
-              </a:solidFill>
-              <a:effectLst/>
-            </c:spPr>
-          </c:dPt>
-          <c:dPt>
-            <c:idx val="2"/>
-            <c:invertIfNegative val="0"/>
-            <c:bubble3D val="0"/>
-            <c:spPr>
-              <a:solidFill>
-                <a:srgbClr val="9AA3B2"/>
-              </a:solidFill>
-              <a:effectLst/>
-            </c:spPr>
-          </c:dPt>
-          <c:dPt>
-            <c:idx val="3"/>
-            <c:invertIfNegative val="0"/>
-            <c:bubble3D val="0"/>
-            <c:spPr>
-              <a:solidFill>
-                <a:srgbClr val="9AA3B2"/>
-              </a:solidFill>
-              <a:effectLst/>
-            </c:spPr>
-          </c:dPt>
-          <c:cat>
-            <c:multiLvlStrRef>
-              <c:f>Sheet1!$A$2:$A$5</c:f>
-              <c:multiLvlStrCache>
-                <c:ptCount val="4"/>
-                <c:lvl>
-                  <c:pt idx="0">
-                    <c:v>Final pipeline</c:v>
-                  </c:pt>
-                  <c:pt idx="1">
-                    <c:v>With the sparring draft</c:v>
-                  </c:pt>
-                  <c:pt idx="2">
-                    <c:v>Without improvement rounds</c:v>
-                  </c:pt>
-                  <c:pt idx="3">
-                    <c:v>One-shot baseline</c:v>
-                  </c:pt>
-                </c:lvl>
-              </c:multiLvlStrCache>
-            </c:multiLvlStrRef>
-          </c:cat>
-          <c:val>
-            <c:numRef>
-              <c:f>Sheet1!$B$2:$B$5</c:f>
-              <c:numCache>
-                <c:formatCode>General</c:formatCode>
-                <c:ptCount val="4"/>
-                <c:pt idx="0">
-                  <c:v>113</c:v>
-                </c:pt>
-                <c:pt idx="1">
-                  <c:v>63.5</c:v>
-                </c:pt>
-                <c:pt idx="2">
-                  <c:v>-61</c:v>
-                </c:pt>
-                <c:pt idx="3">
-                  <c:v>-115.5</c:v>
-                </c:pt>
-              </c:numCache>
-            </c:numRef>
-          </c:val>
-        </c:ser>
-        <c:dLbls>
-          <c:numFmt formatCode="+0.0;−0.0;0" sourceLinked="0"/>
-          <c:txPr>
-            <a:bodyPr/>
-            <a:lstStyle/>
-            <a:p>
-              <a:pPr>
-                <a:defRPr b="0" i="0" strike="noStrike" sz="1400" u="none">
-                  <a:solidFill>
-                    <a:srgbClr val="14171C"/>
-                  </a:solidFill>
-                  <a:latin typeface="+mn-lt"/>
-                </a:defRPr>
-              </a:pPr>
-            </a:p>
-          </c:txPr>
-          <c:showLegendKey val="0"/>
-          <c:showVal val="1"/>
-          <c:showCatName val="0"/>
-          <c:showSerName val="0"/>
-          <c:showPercent val="0"/>
-          <c:showBubbleSize val="0"/>
-          <c:showLeaderLines val="0"/>
-        </c:dLbls>
-        <c:gapWidth val="55"/>
-        <c:overlap val="0"/>
-        <c:axId val="2094734554"/>
-        <c:axId val="2094734552"/>
-        <c:axId val="2094734556"/>
-      </c:barChart>
-      <c:catAx>
-        <c:axId val="2094734554"/>
-        <c:scaling>
-          <c:orientation val="maxMin"/>
-        </c:scaling>
-        <c:delete val="0"/>
-        <c:axPos val="l"/>
-        <c:numFmt formatCode="General" sourceLinked="1"/>
-        <c:majorTickMark val="out"/>
-        <c:minorTickMark val="none"/>
-        <c:tickLblPos val="low"/>
-        <c:spPr>
-          <a:ln w="12700" cap="flat">
-            <a:noFill/>
-            <a:prstDash val="solid"/>
-            <a:round/>
-          </a:ln>
-        </c:spPr>
-        <c:txPr>
-          <a:bodyPr/>
-          <a:lstStyle/>
-          <a:p>
-            <a:pPr>
-              <a:defRPr sz="1400" b="0" i="0" u="none" strike="noStrike">
-                <a:solidFill>
-                  <a:srgbClr val="14171C"/>
-                </a:solidFill>
-                <a:latin typeface="+mn-lt"/>
-              </a:defRPr>
-            </a:pPr>
-            <a:endParaRPr lang="en-US"/>
-          </a:p>
-        </c:txPr>
-        <c:crossAx val="2094734552"/>
-        <c:crosses val="autoZero"/>
-        <c:auto val="1"/>
-        <c:lblAlgn val="ctr"/>
-        <c:noMultiLvlLbl val="1"/>
-      </c:catAx>
-      <c:valAx>
-        <c:axId val="2094734552"/>
-        <c:scaling>
-          <c:orientation val="minMax"/>
-          <c:max val="150"/>
-          <c:min val="-150"/>
-        </c:scaling>
-        <c:delete val="1"/>
-        <c:axPos val="b"/>
-        <c:numFmt formatCode="General" sourceLinked="0"/>
-        <c:majorTickMark val="out"/>
-        <c:minorTickMark val="none"/>
-        <c:tickLblPos val="low"/>
-        <c:spPr>
-          <a:ln w="12700" cap="flat">
-            <a:solidFill>
-              <a:srgbClr val="888888"/>
-            </a:solidFill>
-            <a:prstDash val="solid"/>
-            <a:round/>
-          </a:ln>
-        </c:spPr>
-        <c:txPr>
-          <a:bodyPr/>
-          <a:lstStyle/>
-          <a:p>
-            <a:pPr>
-              <a:defRPr sz="1200" b="0" i="0" u="none" strike="noStrike">
-                <a:solidFill>
-                  <a:srgbClr val="000000"/>
-                </a:solidFill>
-                <a:latin typeface="Arial"/>
-              </a:defRPr>
-            </a:pPr>
-            <a:endParaRPr lang="en-US"/>
-          </a:p>
-        </c:txPr>
-        <c:crossAx val="2094734554"/>
-        <c:crosses val="autoZero"/>
-        <c:crossBetween val="between"/>
-      </c:valAx>
-      <c:spPr>
-        <a:noFill/>
-        <a:ln>
-          <a:noFill/>
-        </a:ln>
-        <a:effectLst/>
-      </c:spPr>
-    </c:plotArea>
-    <c:plotVisOnly val="1"/>
-    <c:dispBlanksAs val="span"/>
-  </c:chart>
-  <c:spPr>
-    <a:noFill/>
-    <a:ln>
-      <a:noFill/>
-    </a:ln>
-    <a:effectLst/>
-  </c:spPr>
-  <c:externalData r:id="rId1">
-    <c:autoUpdate val="0"/>
-  </c:externalData>
-</c:chartSpace>
 </file>
 
 <file path=ppt/notesMasters/notesMaster1.xml><?xml version="1.0" encoding="utf-8"?>
@@ -903,7 +622,7 @@
           <a:p>
             <a:r>
               <a:rPr lang="en-US" dirty="0"/>
-              <a:t>(0:15–0:40) The task: a written game spec in, a strategy file out, unattended, on three budgets from three cents and three minutes up to ten dollars and thirty minutes. Only wins count. We started with research: Google DeepMind’s Code World Models show that an LLM writing a simulator and search code wins about 85% of games, against about 30% when it plays move by move. So our insight: the LLM is the programmer, not the player, and nothing it writes is trusted before it is verified.</a:t>
+              <a:t>(0:15–0:40) The task: a written game spec in, a strategy file out, unattended, on three budgets from three cents and three minutes up to ten dollars and thirty minutes. Only wins count. We started with research: Google DeepMind’s Code World Models: an LLM that writes a simulator plus search code matches or beats Gemini 2.5 Pro playing directly in 9 of 10 games. So our insight: the LLM is the programmer, not the player, and nothing it writes is trusted before it is verified.</a:t>
             </a:r>
             <a:endParaRPr lang="en-US" dirty="0"/>
           </a:p>
@@ -1079,7 +798,7 @@
           <a:p>
             <a:r>
               <a:rPr lang="en-US" dirty="0"/>
-              <a:t>(1:15–1:45) We built the harness the way it works itself. Claude Code was our engineering team: parallel agents wrote and reviewed every module, held to 216 tests. Then we ran loops. Besides the two dev games we built six games of our own with new mechanics, and kept two of them out of all tuning, as an honest exam. Each epoch: switch features off one at a time, measure, keep only what wins. 58 runs, about 21 dollars in total.</a:t>
+              <a:t>(1:15–1:45) We built the harness the way it works itself. Claude Code was our engineering team: parallel agents wrote and reviewed every module, held to 416 tests. Then we ran loops. Besides the two dev games we built eight games of our own with new mechanics, and kept four of them out of all tuning, as an honest exam. Each epoch: switch features off one at a time, measure, keep only what wins. More than 120 measured runs, about 45 dollars in total.</a:t>
             </a:r>
             <a:endParaRPr lang="en-US" dirty="0"/>
           </a:p>
@@ -1167,7 +886,7 @@
           <a:p>
             <a:r>
               <a:rPr lang="en-US" dirty="0"/>
-              <a:t>(1:45–2:15) This is what the loops told us. Each bar is a variant of our harness in a tournament against the others, scored like the real event. The one-shot baseline, one draft, which is what a typical harness ships, comes last. Without improvement rounds we lose. The sparring draft we believed in made selection worse, so the data removed it. The final pipeline wins: 48 to 0 head-to-head against the one-shot baseline on beta. In epoch 2, every feature we tried to remove again lost on two of three games.</a:t>
+              <a:t>(1:45–2:30) Real evidence from outside: the organisers’ midpoint evaluation, task B, four teams, five runs each, on beta and a hidden game. On the hidden game our best strategy was number one of all twenty, winning 94.8% of its matches; overall we placed second of four. Not one of our strategies ever forfeited: 112 delivered strategies, all pass the official conformance check. Two of our five runs were weak, and we traced that to our own simulator check, which rejected correct simulators of games with hidden information; it is fixed. And on two brand-new games nobody tuned on, the final harness beats the one-shot baseline 36 to 0 to 12 and 48 to 0 to 0. (Wins–draws–losses; one-shot = one LLM draft, what a typical harness ships.)</a:t>
             </a:r>
             <a:endParaRPr lang="en-US" dirty="0"/>
           </a:p>
@@ -1255,7 +974,8 @@
           <a:p>
             <a:r>
               <a:rPr lang="en-US" dirty="0"/>
-              <a:t>(2:15–2:35) The real question is unseen games. Two of our games never touched tuning. On them, the full pipeline beats the one-shot baseline 44 to 1 to 3 and 32 to 0 to 16. And robustness: all 53 strategies from our experiments pass the official conformance check. Zero forfeits.</a:t>
+              <a:t>(2:30–3:00) Finally, one real run, recorded in the evaluation’s Docker container on the task-A budget. After 24 seconds the first valid draft leads. At 35 seconds the simulator fails a worked example from the spec, at 68 it is repaired and passes. Self-play ranks the drafts, an improvement round adds a challenger, and at 141 seconds the champion is delivered, for 1.8 cents. Spec in, strategy out, never a forfeit. Thank you.
+LIVE DEMO OPTION: start `./run.sh tasks/beta-A` on a second screen when the pitch begins (about 2.5 minutes, about $0.02); on this slide show its last lines (exit code 0) and `arena check ... PASSED`. If anything goes wrong, this slide is the recorded run.</a:t>
             </a:r>
             <a:endParaRPr lang="en-US" dirty="0"/>
           </a:p>
@@ -1279,95 +999,6 @@
             <a:fld id="{F7021451-1387-4CA6-816F-3879F97B5CBC}" type="slidenum">
               <a:rPr lang="en-US"/>
               <a:t>6</a:t>
-            </a:fld>
-            <a:endParaRPr lang="en-US"/>
-          </a:p>
-        </p:txBody>
-      </p:sp>
-    </p:spTree>
-    <p:extLst>
-      <p:ext uri="{BB962C8B-B14F-4D97-AF65-F5344CB8AC3E}">
-        <p14:creationId xmlns:p14="http://schemas.microsoft.com/office/powerpoint/2010/main" val="1024086991"/>
-      </p:ext>
-    </p:extLst>
-  </p:cSld>
-  <p:clrMapOvr>
-    <a:masterClrMapping/>
-  </p:clrMapOvr>
-</p:notes>
-</file>
-
-<file path=ppt/notesSlides/notesSlide7.xml><?xml version="1.0" encoding="utf-8"?>
-<p:notes xmlns:a="http://schemas.openxmlformats.org/drawingml/2006/main" xmlns:r="http://schemas.openxmlformats.org/officeDocument/2006/relationships" xmlns:p="http://schemas.openxmlformats.org/presentationml/2006/main">
-  <p:cSld>
-    <p:spTree>
-      <p:nvGrpSpPr>
-        <p:cNvPr id="1" name=""/>
-        <p:cNvGrpSpPr/>
-        <p:nvPr/>
-      </p:nvGrpSpPr>
-      <p:grpSpPr>
-        <a:xfrm>
-          <a:off x="0" y="0"/>
-          <a:ext cx="0" cy="0"/>
-          <a:chOff x="0" y="0"/>
-          <a:chExt cx="0" cy="0"/>
-        </a:xfrm>
-      </p:grpSpPr>
-      <p:sp>
-        <p:nvSpPr>
-          <p:cNvPr id="2" name="Slide Image Placeholder 1"/>
-          <p:cNvSpPr>
-            <a:spLocks noGrp="1" noRot="1" noChangeAspect="1"/>
-          </p:cNvSpPr>
-          <p:nvPr>
-            <p:ph type="sldImg"/>
-          </p:nvPr>
-        </p:nvSpPr>
-        <p:spPr/>
-      </p:sp>
-      <p:sp>
-        <p:nvSpPr>
-          <p:cNvPr id="3" name="Notes Placeholder 2"/>
-          <p:cNvSpPr>
-            <a:spLocks noGrp="1"/>
-          </p:cNvSpPr>
-          <p:nvPr>
-            <p:ph type="body" idx="1"/>
-          </p:nvPr>
-        </p:nvSpPr>
-        <p:spPr/>
-        <p:txBody>
-          <a:bodyPr/>
-          <a:lstStyle/>
-          <a:p>
-            <a:r>
-              <a:rPr lang="en-US" dirty="0"/>
-              <a:t>(2:35–3:00) Finally, one real run, recorded in the evaluation’s Docker container on the task-A budget. After 24 seconds the first valid draft leads. At 35 seconds the simulator fails a worked example from the spec, at 68 it is repaired and passes. Self-play ranks the drafts, an improvement round adds a challenger, and at 141 seconds the champion is delivered, for 1.8 cents. Spec in, strategy out, never a forfeit. Thank you.
-LIVE DEMO OPTION: start `./run.sh tasks/beta-A` on a second screen when the pitch begins (about 2.5 minutes, about $0.02); on this slide show its last lines (exit code 0) and `arena check ... PASSED`. If anything goes wrong, this slide is the recorded run.</a:t>
-            </a:r>
-            <a:endParaRPr lang="en-US" dirty="0"/>
-          </a:p>
-        </p:txBody>
-      </p:sp>
-      <p:sp>
-        <p:nvSpPr>
-          <p:cNvPr id="4" name="Slide Number Placeholder 3"/>
-          <p:cNvSpPr>
-            <a:spLocks noGrp="1"/>
-          </p:cNvSpPr>
-          <p:nvPr>
-            <p:ph type="sldNum" sz="quarter" idx="10"/>
-          </p:nvPr>
-        </p:nvSpPr>
-        <p:spPr/>
-        <p:txBody>
-          <a:bodyPr/>
-          <a:lstStyle/>
-          <a:p>
-            <a:fld id="{F7021451-1387-4CA6-816F-3879F97B5CBC}" type="slidenum">
-              <a:rPr lang="en-US"/>
-              <a:t>7</a:t>
             </a:fld>
             <a:endParaRPr lang="en-US"/>
           </a:p>
@@ -3473,35 +3104,21 @@
                 <a:ea typeface="Century Gothic" pitchFamily="34" charset="-122"/>
                 <a:cs typeface="Century Gothic" pitchFamily="34" charset="-120"/>
               </a:rPr>
-              <a:t>85%</a:t>
-            </a:r>
-            <a:pPr indent="0" marL="0">
-              <a:buNone/>
-            </a:pPr>
-            <a:r>
-              <a:rPr lang="en-US" sz="2400" b="1" dirty="0">
-                <a:solidFill>
-                  <a:srgbClr val="4A5260"/>
+              <a:t>9</a:t>
+            </a:r>
+            <a:pPr indent="0" marL="0">
+              <a:buNone/>
+            </a:pPr>
+            <a:r>
+              <a:rPr lang="en-US" sz="4400" b="1" dirty="0">
+                <a:solidFill>
+                  <a:srgbClr val="9AA3B2"/>
                 </a:solidFill>
                 <a:latin typeface="Century Gothic" pitchFamily="34" charset="0"/>
                 <a:ea typeface="Century Gothic" pitchFamily="34" charset="-122"/>
                 <a:cs typeface="Century Gothic" pitchFamily="34" charset="-120"/>
               </a:rPr>
-              <a:t>  vs  </a:t>
-            </a:r>
-            <a:pPr indent="0" marL="0">
-              <a:buNone/>
-            </a:pPr>
-            <a:r>
-              <a:rPr lang="en-US" sz="4400" b="1" dirty="0">
-                <a:solidFill>
-                  <a:srgbClr val="9AA3B2"/>
-                </a:solidFill>
-                <a:latin typeface="Century Gothic" pitchFamily="34" charset="0"/>
-                <a:ea typeface="Century Gothic" pitchFamily="34" charset="-122"/>
-                <a:cs typeface="Century Gothic" pitchFamily="34" charset="-120"/>
-              </a:rPr>
-              <a:t>30%</a:t>
+              <a:t> / 10</a:t>
             </a:r>
             <a:endParaRPr lang="en-US" sz="4400" dirty="0"/>
           </a:p>
@@ -3515,8 +3132,8 @@
         </p:nvSpPr>
         <p:spPr>
           <a:xfrm>
-            <a:off x="4663440" y="3977640"/>
-            <a:ext cx="2880360" cy="457200"/>
+            <a:off x="4663440" y="3931920"/>
+            <a:ext cx="2880360" cy="685800"/>
           </a:xfrm>
           <a:prstGeom prst="rect">
             <a:avLst/>
@@ -3540,7 +3157,7 @@
                 <a:ea typeface="Calibri" pitchFamily="34" charset="-122"/>
                 <a:cs typeface="Calibri" pitchFamily="34" charset="-120"/>
               </a:rPr>
-              <a:t>LLM writes code  vs.  LLM plays</a:t>
+              <a:t>games where LLM-written code + search matches or beats a top LLM playing directly</a:t>
             </a:r>
             <a:endParaRPr lang="en-US" sz="1600" dirty="0"/>
           </a:p>
@@ -3554,7 +3171,7 @@
         </p:nvSpPr>
         <p:spPr>
           <a:xfrm>
-            <a:off x="4663440" y="4663440"/>
+            <a:off x="4663440" y="4846320"/>
             <a:ext cx="2880360" cy="457200"/>
           </a:xfrm>
           <a:prstGeom prst="rect">
@@ -5039,7 +4656,7 @@
                 <a:ea typeface="Century Gothic" pitchFamily="34" charset="-122"/>
                 <a:cs typeface="Century Gothic" pitchFamily="34" charset="-120"/>
               </a:rPr>
-              <a:t>8</a:t>
+              <a:t>10</a:t>
             </a:r>
             <a:endParaRPr lang="en-US" sz="4000" dirty="0"/>
           </a:p>
@@ -5078,7 +4695,7 @@
                 <a:ea typeface="Calibri" pitchFamily="34" charset="-122"/>
                 <a:cs typeface="Calibri" pitchFamily="34" charset="-120"/>
               </a:rPr>
-              <a:t>games, 2 held out</a:t>
+              <a:t>games, 4 never tuned on</a:t>
             </a:r>
             <a:endParaRPr lang="en-US" sz="1400" dirty="0"/>
           </a:p>
@@ -5117,7 +4734,7 @@
                 <a:ea typeface="Century Gothic" pitchFamily="34" charset="-122"/>
                 <a:cs typeface="Century Gothic" pitchFamily="34" charset="-120"/>
               </a:rPr>
-              <a:t>58</a:t>
+              <a:t>120+</a:t>
             </a:r>
             <a:endParaRPr lang="en-US" sz="4000" dirty="0"/>
           </a:p>
@@ -5195,7 +4812,7 @@
                 <a:ea typeface="Century Gothic" pitchFamily="34" charset="-122"/>
                 <a:cs typeface="Century Gothic" pitchFamily="34" charset="-120"/>
               </a:rPr>
-              <a:t>≈ $21</a:t>
+              <a:t>≈ $45</a:t>
             </a:r>
             <a:endParaRPr lang="en-US" sz="4000" dirty="0"/>
           </a:p>
@@ -5273,7 +4890,7 @@
                 <a:ea typeface="Calibri" pitchFamily="34" charset="-122"/>
                 <a:cs typeface="Calibri" pitchFamily="34" charset="-120"/>
               </a:rPr>
-              <a:t>Built with Claude Code  ·  216 automated tests</a:t>
+              <a:t>Built with Claude Code  ·  416 automated tests</a:t>
             </a:r>
             <a:endParaRPr lang="en-US" sz="1600" dirty="0"/>
           </a:p>
@@ -5687,7 +5304,7 @@
                 <a:ea typeface="Century Gothic" pitchFamily="34" charset="-122"/>
                 <a:cs typeface="Century Gothic" pitchFamily="34" charset="-120"/>
               </a:rPr>
-              <a:t>Failure mining</a:t>
+              <a:t>Midpoint feedback</a:t>
             </a:r>
             <a:endParaRPr lang="en-US" sz="1800" dirty="0"/>
           </a:p>
@@ -5726,7 +5343,7 @@
                 <a:ea typeface="Calibri" pitchFamily="34" charset="-122"/>
                 <a:cs typeface="Calibri" pitchFamily="34" charset="-120"/>
               </a:rPr>
-              <a:t>3 defects fixed</a:t>
+              <a:t>weak runs traced and fixed</a:t>
             </a:r>
             <a:endParaRPr lang="en-US" sz="1400" dirty="0"/>
           </a:p>
@@ -5832,13 +5449,13 @@
             <a:r>
               <a:rPr lang="en-US" sz="1200" b="1" spc="300" kern="0" dirty="0">
                 <a:solidFill>
-                  <a:srgbClr val="B44A12"/>
+                  <a:srgbClr val="3A2010"/>
                 </a:solidFill>
                 <a:latin typeface="Consolas" pitchFamily="34" charset="0"/>
                 <a:ea typeface="Consolas" pitchFamily="34" charset="-122"/>
                 <a:cs typeface="Consolas" pitchFamily="34" charset="-120"/>
               </a:rPr>
-              <a:t>EPOCH 1 · RESULT</a:t>
+              <a:t>THE ORGANISERS’ MIDPOINT EVALUATION</a:t>
             </a:r>
             <a:endParaRPr lang="en-US" sz="1200" dirty="0"/>
           </a:p>
@@ -5873,78 +5490,129 @@
             <a:r>
               <a:rPr lang="en-US" sz="3400" b="1" dirty="0">
                 <a:solidFill>
-                  <a:srgbClr val="14171C"/>
+                  <a:srgbClr val="0F1218"/>
                 </a:solidFill>
                 <a:latin typeface="Century Gothic" pitchFamily="34" charset="0"/>
                 <a:ea typeface="Century Gothic" pitchFamily="34" charset="-122"/>
                 <a:cs typeface="Century Gothic" pitchFamily="34" charset="-120"/>
               </a:rPr>
-              <a:t>Every feature had to earn its place</a:t>
+              <a:t>Our best strategy topped the hidden game</a:t>
             </a:r>
             <a:endParaRPr lang="en-US" sz="3400" dirty="0"/>
           </a:p>
         </p:txBody>
       </p:sp>
-      <p:graphicFrame>
-        <p:nvGraphicFramePr>
-          <p:cNvPr id="4" name="ablation chart" descr=""/>
-          <p:cNvGraphicFramePr/>
-          <p:nvPr/>
-        </p:nvGraphicFramePr>
-        <p:xfrm>
-          <a:off x="548640" y="1783080"/>
-          <a:ext cx="7589520" cy="4160520"/>
-        </p:xfrm>
-        <a:graphic xmlns:a="http://schemas.openxmlformats.org/drawingml/2006/main">
-          <a:graphicData uri="http://schemas.openxmlformats.org/drawingml/2006/chart">
-            <c:chart xmlns:c="http://schemas.openxmlformats.org/drawingml/2006/chart" r:id="rId1"/>
-          </a:graphicData>
-        </a:graphic>
-      </p:graphicFrame>
-      <p:sp>
-        <p:nvSpPr>
-          <p:cNvPr id="5" name="callout 1"/>
+      <p:sp>
+        <p:nvSpPr>
+          <p:cNvPr id="4" name="Text 2"/>
+          <p:cNvSpPr txBox="1"/>
+          <p:nvPr/>
+        </p:nvSpPr>
+        <p:spPr>
+          <a:xfrm>
+            <a:off x="548640" y="2377440"/>
+            <a:ext cx="3520440" cy="1097280"/>
+          </a:xfrm>
+          <a:prstGeom prst="rect">
+            <a:avLst/>
+          </a:prstGeom>
+          <a:noFill/>
+          <a:ln/>
+        </p:spPr>
+        <p:txBody>
+          <a:bodyPr wrap="square" lIns="0" tIns="0" rIns="0" bIns="0" rtlCol="0" anchor="ctr"/>
+          <a:lstStyle/>
+          <a:p>
+            <a:pPr indent="0" marL="0">
+              <a:buNone/>
+            </a:pPr>
+            <a:r>
+              <a:rPr lang="en-US" sz="5600" b="1" dirty="0">
+                <a:solidFill>
+                  <a:srgbClr val="0F1218"/>
+                </a:solidFill>
+                <a:latin typeface="Century Gothic" pitchFamily="34" charset="0"/>
+                <a:ea typeface="Century Gothic" pitchFamily="34" charset="-122"/>
+                <a:cs typeface="Century Gothic" pitchFamily="34" charset="-120"/>
+              </a:rPr>
+              <a:t>#1 of 20</a:t>
+            </a:r>
+            <a:endParaRPr lang="en-US" sz="5600" dirty="0"/>
+          </a:p>
+        </p:txBody>
+      </p:sp>
+      <p:sp>
+        <p:nvSpPr>
+          <p:cNvPr id="5" name="Shape 3"/>
           <p:cNvSpPr/>
           <p:nvPr/>
         </p:nvSpPr>
         <p:spPr>
           <a:xfrm>
-            <a:off x="8549640" y="1874520"/>
-            <a:ext cx="3093415" cy="1783080"/>
-          </a:xfrm>
-          <a:prstGeom prst="roundRect">
-            <a:avLst>
-              <a:gd name="adj" fmla="val 5128"/>
-            </a:avLst>
-          </a:prstGeom>
-          <a:solidFill>
-            <a:srgbClr val="FFFFFF"/>
-          </a:solidFill>
-          <a:ln w="9525">
+            <a:off x="548640" y="3657600"/>
+            <a:ext cx="1097280" cy="0"/>
+          </a:xfrm>
+          <a:prstGeom prst="line">
+            <a:avLst/>
+          </a:prstGeom>
+          <a:noFill/>
+          <a:ln w="25400">
             <a:solidFill>
-              <a:srgbClr val="D9DDE3"/>
+              <a:srgbClr val="0F1218"/>
             </a:solidFill>
             <a:prstDash val="solid"/>
           </a:ln>
-          <a:effectLst>
-            <a:outerShdw sx="100000" sy="100000" kx="0" ky="0" algn="bl" rotWithShape="0" blurRad="101600" dist="25400" dir="5400000">
-              <a:srgbClr val="000000">
-                <a:alpha val="8000"/>
-              </a:srgbClr>
-            </a:outerShdw>
-          </a:effectLst>
-        </p:spPr>
-      </p:sp>
-      <p:sp>
-        <p:nvSpPr>
-          <p:cNvPr id="6" name="Text 3"/>
-          <p:cNvSpPr txBox="1"/>
-          <p:nvPr/>
-        </p:nvSpPr>
-        <p:spPr>
-          <a:xfrm>
-            <a:off x="8823960" y="2103120"/>
-            <a:ext cx="2544775" cy="640080"/>
+        </p:spPr>
+      </p:sp>
+      <p:sp>
+        <p:nvSpPr>
+          <p:cNvPr id="6" name="Text 4"/>
+          <p:cNvSpPr txBox="1"/>
+          <p:nvPr/>
+        </p:nvSpPr>
+        <p:spPr>
+          <a:xfrm>
+            <a:off x="548640" y="3886200"/>
+            <a:ext cx="3337560" cy="822960"/>
+          </a:xfrm>
+          <a:prstGeom prst="rect">
+            <a:avLst/>
+          </a:prstGeom>
+          <a:noFill/>
+          <a:ln/>
+        </p:spPr>
+        <p:txBody>
+          <a:bodyPr wrap="square" lIns="0" tIns="0" rIns="0" bIns="0" rtlCol="0" anchor="t"/>
+          <a:lstStyle/>
+          <a:p>
+            <a:pPr indent="0" marL="0">
+              <a:buNone/>
+            </a:pPr>
+            <a:r>
+              <a:rPr lang="en-US" sz="2000" dirty="0">
+                <a:solidFill>
+                  <a:srgbClr val="2A1408"/>
+                </a:solidFill>
+                <a:latin typeface="Calibri" pitchFamily="34" charset="0"/>
+                <a:ea typeface="Calibri" pitchFamily="34" charset="-122"/>
+                <a:cs typeface="Calibri" pitchFamily="34" charset="-120"/>
+              </a:rPr>
+              <a:t>strategies on the hidden game (94.8% won)</a:t>
+            </a:r>
+            <a:endParaRPr lang="en-US" sz="2000" dirty="0"/>
+          </a:p>
+        </p:txBody>
+      </p:sp>
+      <p:sp>
+        <p:nvSpPr>
+          <p:cNvPr id="7" name="Text 5"/>
+          <p:cNvSpPr txBox="1"/>
+          <p:nvPr/>
+        </p:nvSpPr>
+        <p:spPr>
+          <a:xfrm>
+            <a:off x="4343400" y="2377440"/>
+            <a:ext cx="3520440" cy="1097280"/>
           </a:xfrm>
           <a:prstGeom prst="rect">
             <a:avLst/>
@@ -5960,30 +5628,53 @@
               <a:buNone/>
             </a:pPr>
             <a:r>
-              <a:rPr lang="en-US" sz="3200" b="1" dirty="0">
-                <a:solidFill>
-                  <a:srgbClr val="14171C"/>
+              <a:rPr lang="en-US" sz="5600" b="1" dirty="0">
+                <a:solidFill>
+                  <a:srgbClr val="0F1218"/>
                 </a:solidFill>
                 <a:latin typeface="Century Gothic" pitchFamily="34" charset="0"/>
                 <a:ea typeface="Century Gothic" pitchFamily="34" charset="-122"/>
                 <a:cs typeface="Century Gothic" pitchFamily="34" charset="-120"/>
               </a:rPr>
-              <a:t>48–0–0</a:t>
-            </a:r>
-            <a:endParaRPr lang="en-US" sz="3200" dirty="0"/>
-          </a:p>
-        </p:txBody>
-      </p:sp>
-      <p:sp>
-        <p:nvSpPr>
-          <p:cNvPr id="7" name="Text 4"/>
-          <p:cNvSpPr txBox="1"/>
-          <p:nvPr/>
-        </p:nvSpPr>
-        <p:spPr>
-          <a:xfrm>
-            <a:off x="8823960" y="2788920"/>
-            <a:ext cx="2544775" cy="731520"/>
+              <a:t>2nd of 4</a:t>
+            </a:r>
+            <a:endParaRPr lang="en-US" sz="5600" dirty="0"/>
+          </a:p>
+        </p:txBody>
+      </p:sp>
+      <p:sp>
+        <p:nvSpPr>
+          <p:cNvPr id="8" name="Shape 6"/>
+          <p:cNvSpPr/>
+          <p:nvPr/>
+        </p:nvSpPr>
+        <p:spPr>
+          <a:xfrm>
+            <a:off x="4343400" y="3657600"/>
+            <a:ext cx="1097280" cy="0"/>
+          </a:xfrm>
+          <a:prstGeom prst="line">
+            <a:avLst/>
+          </a:prstGeom>
+          <a:noFill/>
+          <a:ln w="25400">
+            <a:solidFill>
+              <a:srgbClr val="0F1218"/>
+            </a:solidFill>
+            <a:prstDash val="solid"/>
+          </a:ln>
+        </p:spPr>
+      </p:sp>
+      <p:sp>
+        <p:nvSpPr>
+          <p:cNvPr id="9" name="Text 7"/>
+          <p:cNvSpPr txBox="1"/>
+          <p:nvPr/>
+        </p:nvSpPr>
+        <p:spPr>
+          <a:xfrm>
+            <a:off x="4343400" y="3886200"/>
+            <a:ext cx="3337560" cy="822960"/>
           </a:xfrm>
           <a:prstGeom prst="rect">
             <a:avLst/>
@@ -5999,30 +5690,30 @@
               <a:buNone/>
             </a:pPr>
             <a:r>
-              <a:rPr lang="en-US" sz="1400" dirty="0">
-                <a:solidFill>
-                  <a:srgbClr val="4A5260"/>
+              <a:rPr lang="en-US" sz="2000" dirty="0">
+                <a:solidFill>
+                  <a:srgbClr val="2A1408"/>
                 </a:solidFill>
                 <a:latin typeface="Calibri" pitchFamily="34" charset="0"/>
                 <a:ea typeface="Calibri" pitchFamily="34" charset="-122"/>
                 <a:cs typeface="Calibri" pitchFamily="34" charset="-120"/>
               </a:rPr>
-              <a:t>wins – draws – losses against the one-shot baseline</a:t>
-            </a:r>
-            <a:endParaRPr lang="en-US" sz="1400" dirty="0"/>
-          </a:p>
-        </p:txBody>
-      </p:sp>
-      <p:sp>
-        <p:nvSpPr>
-          <p:cNvPr id="8" name="Text 5"/>
-          <p:cNvSpPr txBox="1"/>
-          <p:nvPr/>
-        </p:nvSpPr>
-        <p:spPr>
-          <a:xfrm>
-            <a:off x="548640" y="6035040"/>
-            <a:ext cx="10424160" cy="320040"/>
+              <a:t>teams overall, task B</a:t>
+            </a:r>
+            <a:endParaRPr lang="en-US" sz="2000" dirty="0"/>
+          </a:p>
+        </p:txBody>
+      </p:sp>
+      <p:sp>
+        <p:nvSpPr>
+          <p:cNvPr id="10" name="Text 8"/>
+          <p:cNvSpPr txBox="1"/>
+          <p:nvPr/>
+        </p:nvSpPr>
+        <p:spPr>
+          <a:xfrm>
+            <a:off x="8138160" y="2377440"/>
+            <a:ext cx="3520440" cy="1097280"/>
           </a:xfrm>
           <a:prstGeom prst="rect">
             <a:avLst/>
@@ -6038,17 +5729,118 @@
               <a:buNone/>
             </a:pPr>
             <a:r>
-              <a:rPr lang="en-US" sz="1100" dirty="0">
-                <a:solidFill>
-                  <a:srgbClr val="6B7380"/>
+              <a:rPr lang="en-US" sz="5600" b="1" dirty="0">
+                <a:solidFill>
+                  <a:srgbClr val="0F1218"/>
+                </a:solidFill>
+                <a:latin typeface="Century Gothic" pitchFamily="34" charset="0"/>
+                <a:ea typeface="Century Gothic" pitchFamily="34" charset="-122"/>
+                <a:cs typeface="Century Gothic" pitchFamily="34" charset="-120"/>
+              </a:rPr>
+              <a:t>0</a:t>
+            </a:r>
+            <a:endParaRPr lang="en-US" sz="5600" dirty="0"/>
+          </a:p>
+        </p:txBody>
+      </p:sp>
+      <p:sp>
+        <p:nvSpPr>
+          <p:cNvPr id="11" name="Shape 9"/>
+          <p:cNvSpPr/>
+          <p:nvPr/>
+        </p:nvSpPr>
+        <p:spPr>
+          <a:xfrm>
+            <a:off x="8138160" y="3657600"/>
+            <a:ext cx="1097280" cy="0"/>
+          </a:xfrm>
+          <a:prstGeom prst="line">
+            <a:avLst/>
+          </a:prstGeom>
+          <a:noFill/>
+          <a:ln w="25400">
+            <a:solidFill>
+              <a:srgbClr val="0F1218"/>
+            </a:solidFill>
+            <a:prstDash val="solid"/>
+          </a:ln>
+        </p:spPr>
+      </p:sp>
+      <p:sp>
+        <p:nvSpPr>
+          <p:cNvPr id="12" name="Text 10"/>
+          <p:cNvSpPr txBox="1"/>
+          <p:nvPr/>
+        </p:nvSpPr>
+        <p:spPr>
+          <a:xfrm>
+            <a:off x="8138160" y="3886200"/>
+            <a:ext cx="3337560" cy="822960"/>
+          </a:xfrm>
+          <a:prstGeom prst="rect">
+            <a:avLst/>
+          </a:prstGeom>
+          <a:noFill/>
+          <a:ln/>
+        </p:spPr>
+        <p:txBody>
+          <a:bodyPr wrap="square" lIns="0" tIns="0" rIns="0" bIns="0" rtlCol="0" anchor="t"/>
+          <a:lstStyle/>
+          <a:p>
+            <a:pPr indent="0" marL="0">
+              <a:buNone/>
+            </a:pPr>
+            <a:r>
+              <a:rPr lang="en-US" sz="2000" dirty="0">
+                <a:solidFill>
+                  <a:srgbClr val="2A1408"/>
                 </a:solidFill>
                 <a:latin typeface="Calibri" pitchFamily="34" charset="0"/>
                 <a:ea typeface="Calibri" pitchFamily="34" charset="-122"/>
                 <a:cs typeface="Calibri" pitchFamily="34" charset="-120"/>
               </a:rPr>
-              <a:t>Net points, 3 games, +1 / 0 / −1 per match</a:t>
-            </a:r>
-            <a:endParaRPr lang="en-US" sz="1100" dirty="0"/>
+              <a:t>forfeits in 112 delivered strategies</a:t>
+            </a:r>
+            <a:endParaRPr lang="en-US" sz="2000" dirty="0"/>
+          </a:p>
+        </p:txBody>
+      </p:sp>
+      <p:sp>
+        <p:nvSpPr>
+          <p:cNvPr id="13" name="Text 11"/>
+          <p:cNvSpPr txBox="1"/>
+          <p:nvPr/>
+        </p:nvSpPr>
+        <p:spPr>
+          <a:xfrm>
+            <a:off x="548640" y="5349240"/>
+            <a:ext cx="10881360" cy="685800"/>
+          </a:xfrm>
+          <a:prstGeom prst="rect">
+            <a:avLst/>
+          </a:prstGeom>
+          <a:noFill/>
+          <a:ln/>
+        </p:spPr>
+        <p:txBody>
+          <a:bodyPr wrap="square" lIns="0" tIns="0" rIns="0" bIns="0" rtlCol="0" anchor="t"/>
+          <a:lstStyle/>
+          <a:p>
+            <a:pPr indent="0" marL="0">
+              <a:buNone/>
+            </a:pPr>
+            <a:r>
+              <a:rPr lang="en-US" sz="1800" dirty="0">
+                <a:solidFill>
+                  <a:srgbClr val="2A1408"/>
+                </a:solidFill>
+                <a:latin typeface="Calibri" pitchFamily="34" charset="0"/>
+                <a:ea typeface="Calibri" pitchFamily="34" charset="-122"/>
+                <a:cs typeface="Calibri" pitchFamily="34" charset="-120"/>
+              </a:rPr>
+              <a:t>Weak runs traced to our simulator check and fixed. On fresh, untuned games the final harness beats the one-shot baseline 36–0–12 and 48–0–0.</a:t>
+            </a:r>
+            <a:endParaRPr lang="en-US" sz="1800" dirty="0"/>
           </a:p>
         </p:txBody>
       </p:sp>
@@ -6082,7 +5874,7 @@
             <a:lvl1pPr>
               <a:defRPr sz="1100">
                 <a:solidFill>
-                  <a:srgbClr val="6B7380"/>
+                  <a:srgbClr val="3A2010"/>
                 </a:solidFill>
                 <a:latin typeface="Consolas"/>
                 <a:ea typeface="Consolas"/>
@@ -6152,501 +5944,6 @@
             <a:r>
               <a:rPr lang="en-US" sz="1200" b="1" spc="300" kern="0" dirty="0">
                 <a:solidFill>
-                  <a:srgbClr val="3A2010"/>
-                </a:solidFill>
-                <a:latin typeface="Consolas" pitchFamily="34" charset="0"/>
-                <a:ea typeface="Consolas" pitchFamily="34" charset="-122"/>
-                <a:cs typeface="Consolas" pitchFamily="34" charset="-120"/>
-              </a:rPr>
-              <a:t>THE EXAM</a:t>
-            </a:r>
-            <a:endParaRPr lang="en-US" sz="1200" dirty="0"/>
-          </a:p>
-        </p:txBody>
-      </p:sp>
-      <p:sp>
-        <p:nvSpPr>
-          <p:cNvPr id="3" name="Text 0"/>
-          <p:cNvSpPr/>
-          <p:nvPr>
-            <p:ph idx="100" type="title" hasCustomPrompt="1"/>
-          </p:nvPr>
-        </p:nvSpPr>
-        <p:spPr>
-          <a:xfrm>
-            <a:off x="548640" y="713232"/>
-            <a:ext cx="11094415" cy="822960"/>
-          </a:xfrm>
-          <a:prstGeom prst="rect">
-            <a:avLst/>
-          </a:prstGeom>
-          <a:noFill/>
-          <a:ln/>
-        </p:spPr>
-        <p:txBody>
-          <a:bodyPr wrap="square" lIns="0" tIns="0" rIns="0" bIns="0" rtlCol="0" anchor="t"/>
-          <a:lstStyle/>
-          <a:p>
-            <a:pPr algn="l" indent="0" marL="0">
-              <a:buNone/>
-            </a:pPr>
-            <a:r>
-              <a:rPr lang="en-US" sz="3400" b="1" dirty="0">
-                <a:solidFill>
-                  <a:srgbClr val="0F1218"/>
-                </a:solidFill>
-                <a:latin typeface="Century Gothic" pitchFamily="34" charset="0"/>
-                <a:ea typeface="Century Gothic" pitchFamily="34" charset="-122"/>
-                <a:cs typeface="Century Gothic" pitchFamily="34" charset="-120"/>
-              </a:rPr>
-              <a:t>It transfers to games it was never tuned on</a:t>
-            </a:r>
-            <a:endParaRPr lang="en-US" sz="3400" dirty="0"/>
-          </a:p>
-        </p:txBody>
-      </p:sp>
-      <p:sp>
-        <p:nvSpPr>
-          <p:cNvPr id="4" name="Text 2"/>
-          <p:cNvSpPr txBox="1"/>
-          <p:nvPr/>
-        </p:nvSpPr>
-        <p:spPr>
-          <a:xfrm>
-            <a:off x="548640" y="1600200"/>
-            <a:ext cx="10515600" cy="411480"/>
-          </a:xfrm>
-          <a:prstGeom prst="rect">
-            <a:avLst/>
-          </a:prstGeom>
-          <a:noFill/>
-          <a:ln/>
-        </p:spPr>
-        <p:txBody>
-          <a:bodyPr wrap="square" lIns="0" tIns="0" rIns="0" bIns="0" rtlCol="0" anchor="ctr"/>
-          <a:lstStyle/>
-          <a:p>
-            <a:pPr indent="0" marL="0">
-              <a:buNone/>
-            </a:pPr>
-            <a:r>
-              <a:rPr lang="en-US" sz="2000" dirty="0">
-                <a:solidFill>
-                  <a:srgbClr val="2A1408"/>
-                </a:solidFill>
-                <a:latin typeface="Calibri" pitchFamily="34" charset="0"/>
-                <a:ea typeface="Calibri" pitchFamily="34" charset="-122"/>
-                <a:cs typeface="Calibri" pitchFamily="34" charset="-120"/>
-              </a:rPr>
-              <a:t>Wins – draws – losses against the one-shot baseline, on 2 games never used for tuning</a:t>
-            </a:r>
-            <a:endParaRPr lang="en-US" sz="2000" dirty="0"/>
-          </a:p>
-        </p:txBody>
-      </p:sp>
-      <p:sp>
-        <p:nvSpPr>
-          <p:cNvPr id="5" name="Text 3"/>
-          <p:cNvSpPr txBox="1"/>
-          <p:nvPr/>
-        </p:nvSpPr>
-        <p:spPr>
-          <a:xfrm>
-            <a:off x="548640" y="2743200"/>
-            <a:ext cx="3520440" cy="1097280"/>
-          </a:xfrm>
-          <a:prstGeom prst="rect">
-            <a:avLst/>
-          </a:prstGeom>
-          <a:noFill/>
-          <a:ln/>
-        </p:spPr>
-        <p:txBody>
-          <a:bodyPr wrap="square" lIns="0" tIns="0" rIns="0" bIns="0" rtlCol="0" anchor="ctr"/>
-          <a:lstStyle/>
-          <a:p>
-            <a:pPr indent="0" marL="0">
-              <a:buNone/>
-            </a:pPr>
-            <a:r>
-              <a:rPr lang="en-US" sz="5600" b="1" dirty="0">
-                <a:solidFill>
-                  <a:srgbClr val="0F1218"/>
-                </a:solidFill>
-                <a:latin typeface="Century Gothic" pitchFamily="34" charset="0"/>
-                <a:ea typeface="Century Gothic" pitchFamily="34" charset="-122"/>
-                <a:cs typeface="Century Gothic" pitchFamily="34" charset="-120"/>
-              </a:rPr>
-              <a:t>44–1–3</a:t>
-            </a:r>
-            <a:endParaRPr lang="en-US" sz="5600" dirty="0"/>
-          </a:p>
-        </p:txBody>
-      </p:sp>
-      <p:sp>
-        <p:nvSpPr>
-          <p:cNvPr id="6" name="Shape 4"/>
-          <p:cNvSpPr/>
-          <p:nvPr/>
-        </p:nvSpPr>
-        <p:spPr>
-          <a:xfrm>
-            <a:off x="548640" y="4023360"/>
-            <a:ext cx="1097280" cy="0"/>
-          </a:xfrm>
-          <a:prstGeom prst="line">
-            <a:avLst/>
-          </a:prstGeom>
-          <a:noFill/>
-          <a:ln w="25400">
-            <a:solidFill>
-              <a:srgbClr val="0F1218"/>
-            </a:solidFill>
-            <a:prstDash val="solid"/>
-          </a:ln>
-        </p:spPr>
-      </p:sp>
-      <p:sp>
-        <p:nvSpPr>
-          <p:cNvPr id="7" name="Text 5"/>
-          <p:cNvSpPr txBox="1"/>
-          <p:nvPr/>
-        </p:nvSpPr>
-        <p:spPr>
-          <a:xfrm>
-            <a:off x="548640" y="4251960"/>
-            <a:ext cx="3337560" cy="548640"/>
-          </a:xfrm>
-          <a:prstGeom prst="rect">
-            <a:avLst/>
-          </a:prstGeom>
-          <a:noFill/>
-          <a:ln/>
-        </p:spPr>
-        <p:txBody>
-          <a:bodyPr wrap="square" lIns="0" tIns="0" rIns="0" bIns="0" rtlCol="0" anchor="t"/>
-          <a:lstStyle/>
-          <a:p>
-            <a:pPr indent="0" marL="0">
-              <a:buNone/>
-            </a:pPr>
-            <a:r>
-              <a:rPr lang="en-US" sz="2200" dirty="0">
-                <a:solidFill>
-                  <a:srgbClr val="2A1408"/>
-                </a:solidFill>
-                <a:latin typeface="Calibri" pitchFamily="34" charset="0"/>
-                <a:ea typeface="Calibri" pitchFamily="34" charset="-122"/>
-                <a:cs typeface="Calibri" pitchFamily="34" charset="-120"/>
-              </a:rPr>
-              <a:t>held-out game 1</a:t>
-            </a:r>
-            <a:endParaRPr lang="en-US" sz="2200" dirty="0"/>
-          </a:p>
-        </p:txBody>
-      </p:sp>
-      <p:sp>
-        <p:nvSpPr>
-          <p:cNvPr id="8" name="Text 6"/>
-          <p:cNvSpPr txBox="1"/>
-          <p:nvPr/>
-        </p:nvSpPr>
-        <p:spPr>
-          <a:xfrm>
-            <a:off x="4343400" y="2743200"/>
-            <a:ext cx="3520440" cy="1097280"/>
-          </a:xfrm>
-          <a:prstGeom prst="rect">
-            <a:avLst/>
-          </a:prstGeom>
-          <a:noFill/>
-          <a:ln/>
-        </p:spPr>
-        <p:txBody>
-          <a:bodyPr wrap="square" lIns="0" tIns="0" rIns="0" bIns="0" rtlCol="0" anchor="ctr"/>
-          <a:lstStyle/>
-          <a:p>
-            <a:pPr indent="0" marL="0">
-              <a:buNone/>
-            </a:pPr>
-            <a:r>
-              <a:rPr lang="en-US" sz="5600" b="1" dirty="0">
-                <a:solidFill>
-                  <a:srgbClr val="0F1218"/>
-                </a:solidFill>
-                <a:latin typeface="Century Gothic" pitchFamily="34" charset="0"/>
-                <a:ea typeface="Century Gothic" pitchFamily="34" charset="-122"/>
-                <a:cs typeface="Century Gothic" pitchFamily="34" charset="-120"/>
-              </a:rPr>
-              <a:t>32–0–16</a:t>
-            </a:r>
-            <a:endParaRPr lang="en-US" sz="5600" dirty="0"/>
-          </a:p>
-        </p:txBody>
-      </p:sp>
-      <p:sp>
-        <p:nvSpPr>
-          <p:cNvPr id="9" name="Shape 7"/>
-          <p:cNvSpPr/>
-          <p:nvPr/>
-        </p:nvSpPr>
-        <p:spPr>
-          <a:xfrm>
-            <a:off x="4343400" y="4023360"/>
-            <a:ext cx="1097280" cy="0"/>
-          </a:xfrm>
-          <a:prstGeom prst="line">
-            <a:avLst/>
-          </a:prstGeom>
-          <a:noFill/>
-          <a:ln w="25400">
-            <a:solidFill>
-              <a:srgbClr val="0F1218"/>
-            </a:solidFill>
-            <a:prstDash val="solid"/>
-          </a:ln>
-        </p:spPr>
-      </p:sp>
-      <p:sp>
-        <p:nvSpPr>
-          <p:cNvPr id="10" name="Text 8"/>
-          <p:cNvSpPr txBox="1"/>
-          <p:nvPr/>
-        </p:nvSpPr>
-        <p:spPr>
-          <a:xfrm>
-            <a:off x="4343400" y="4251960"/>
-            <a:ext cx="3337560" cy="548640"/>
-          </a:xfrm>
-          <a:prstGeom prst="rect">
-            <a:avLst/>
-          </a:prstGeom>
-          <a:noFill/>
-          <a:ln/>
-        </p:spPr>
-        <p:txBody>
-          <a:bodyPr wrap="square" lIns="0" tIns="0" rIns="0" bIns="0" rtlCol="0" anchor="t"/>
-          <a:lstStyle/>
-          <a:p>
-            <a:pPr indent="0" marL="0">
-              <a:buNone/>
-            </a:pPr>
-            <a:r>
-              <a:rPr lang="en-US" sz="2200" dirty="0">
-                <a:solidFill>
-                  <a:srgbClr val="2A1408"/>
-                </a:solidFill>
-                <a:latin typeface="Calibri" pitchFamily="34" charset="0"/>
-                <a:ea typeface="Calibri" pitchFamily="34" charset="-122"/>
-                <a:cs typeface="Calibri" pitchFamily="34" charset="-120"/>
-              </a:rPr>
-              <a:t>held-out game 2</a:t>
-            </a:r>
-            <a:endParaRPr lang="en-US" sz="2200" dirty="0"/>
-          </a:p>
-        </p:txBody>
-      </p:sp>
-      <p:sp>
-        <p:nvSpPr>
-          <p:cNvPr id="11" name="Text 9"/>
-          <p:cNvSpPr txBox="1"/>
-          <p:nvPr/>
-        </p:nvSpPr>
-        <p:spPr>
-          <a:xfrm>
-            <a:off x="8138160" y="2743200"/>
-            <a:ext cx="3520440" cy="1097280"/>
-          </a:xfrm>
-          <a:prstGeom prst="rect">
-            <a:avLst/>
-          </a:prstGeom>
-          <a:noFill/>
-          <a:ln/>
-        </p:spPr>
-        <p:txBody>
-          <a:bodyPr wrap="square" lIns="0" tIns="0" rIns="0" bIns="0" rtlCol="0" anchor="ctr"/>
-          <a:lstStyle/>
-          <a:p>
-            <a:pPr indent="0" marL="0">
-              <a:buNone/>
-            </a:pPr>
-            <a:r>
-              <a:rPr lang="en-US" sz="5600" b="1" dirty="0">
-                <a:solidFill>
-                  <a:srgbClr val="0F1218"/>
-                </a:solidFill>
-                <a:latin typeface="Century Gothic" pitchFamily="34" charset="0"/>
-                <a:ea typeface="Century Gothic" pitchFamily="34" charset="-122"/>
-                <a:cs typeface="Century Gothic" pitchFamily="34" charset="-120"/>
-              </a:rPr>
-              <a:t>53 / 53</a:t>
-            </a:r>
-            <a:endParaRPr lang="en-US" sz="5600" dirty="0"/>
-          </a:p>
-        </p:txBody>
-      </p:sp>
-      <p:sp>
-        <p:nvSpPr>
-          <p:cNvPr id="12" name="Shape 10"/>
-          <p:cNvSpPr/>
-          <p:nvPr/>
-        </p:nvSpPr>
-        <p:spPr>
-          <a:xfrm>
-            <a:off x="8138160" y="4023360"/>
-            <a:ext cx="1097280" cy="0"/>
-          </a:xfrm>
-          <a:prstGeom prst="line">
-            <a:avLst/>
-          </a:prstGeom>
-          <a:noFill/>
-          <a:ln w="25400">
-            <a:solidFill>
-              <a:srgbClr val="0F1218"/>
-            </a:solidFill>
-            <a:prstDash val="solid"/>
-          </a:ln>
-        </p:spPr>
-      </p:sp>
-      <p:sp>
-        <p:nvSpPr>
-          <p:cNvPr id="13" name="Text 11"/>
-          <p:cNvSpPr txBox="1"/>
-          <p:nvPr/>
-        </p:nvSpPr>
-        <p:spPr>
-          <a:xfrm>
-            <a:off x="8138160" y="4251960"/>
-            <a:ext cx="3337560" cy="548640"/>
-          </a:xfrm>
-          <a:prstGeom prst="rect">
-            <a:avLst/>
-          </a:prstGeom>
-          <a:noFill/>
-          <a:ln/>
-        </p:spPr>
-        <p:txBody>
-          <a:bodyPr wrap="square" lIns="0" tIns="0" rIns="0" bIns="0" rtlCol="0" anchor="t"/>
-          <a:lstStyle/>
-          <a:p>
-            <a:pPr indent="0" marL="0">
-              <a:buNone/>
-            </a:pPr>
-            <a:r>
-              <a:rPr lang="en-US" sz="2200" dirty="0">
-                <a:solidFill>
-                  <a:srgbClr val="2A1408"/>
-                </a:solidFill>
-                <a:latin typeface="Calibri" pitchFamily="34" charset="0"/>
-                <a:ea typeface="Calibri" pitchFamily="34" charset="-122"/>
-                <a:cs typeface="Calibri" pitchFamily="34" charset="-120"/>
-              </a:rPr>
-              <a:t>strategies passed, zero forfeits</a:t>
-            </a:r>
-            <a:endParaRPr lang="en-US" sz="2200" dirty="0"/>
-          </a:p>
-        </p:txBody>
-      </p:sp>
-      <p:sp>
-        <p:nvSpPr>
-          <p:cNvPr id="25" name="Slide Number Placeholder 0"/>
-          <p:cNvSpPr>
-            <a:spLocks noGrp="1"/>
-          </p:cNvSpPr>
-          <p:nvPr>
-            <p:ph type="sldNum" sz="quarter" idx="4294967295"/>
-          </p:nvPr>
-        </p:nvSpPr>
-        <p:spPr>
-          <a:xfrm>
-            <a:off x="11094415" y="6355080"/>
-            <a:ext cx="548640" cy="274320"/>
-          </a:xfrm>
-          <a:prstGeom prst="rect">
-            <a:avLst/>
-          </a:prstGeom>
-          <a:extLst>
-            <a:ext uri="{C572A759-6A51-4108-AA02-DFA0A04FC94B}">
-              <ma14:wrappingTextBoxFlag xmlns:ma14="http://schemas.microsoft.com/office/mac/drawingml/2011/main" val="0"/>
-            </a:ext>
-          </a:extLst>
-        </p:spPr>
-        <p:txBody>
-          <a:bodyPr/>
-          <a:lstStyle>
-            <a:lvl1pPr>
-              <a:defRPr sz="1100">
-                <a:solidFill>
-                  <a:srgbClr val="3A2010"/>
-                </a:solidFill>
-                <a:latin typeface="Consolas"/>
-                <a:ea typeface="Consolas"/>
-                <a:cs typeface="Consolas"/>
-              </a:defRPr>
-            </a:lvl1pPr>
-          </a:lstStyle>
-          <a:p>
-            <a:pPr algn="r"/>
-            <a:fld id="{F7021451-1387-4CA6-816F-3879F97B5CBC}" type="slidenum">
-              <a:rPr b="0" lang="en-US"/>
-              <a:t>6</a:t>
-            </a:fld>
-            <a:endParaRPr lang="en-US"/>
-          </a:p>
-        </p:txBody>
-      </p:sp>
-    </p:spTree>
-  </p:cSld>
-  <p:clrMapOvr>
-    <a:masterClrMapping/>
-  </p:clrMapOvr>
-</p:sld>
-</file>
-
-<file path=ppt/slides/slide7.xml><?xml version="1.0" encoding="utf-8"?>
-<p:sld xmlns:a="http://schemas.openxmlformats.org/drawingml/2006/main" xmlns:r="http://schemas.openxmlformats.org/officeDocument/2006/relationships" xmlns:p="http://schemas.openxmlformats.org/presentationml/2006/main">
-  <p:cSld name="Slide 7">
-    <p:spTree>
-      <p:nvGrpSpPr>
-        <p:cNvPr id="1" name=""/>
-        <p:cNvGrpSpPr/>
-        <p:nvPr/>
-      </p:nvGrpSpPr>
-      <p:grpSpPr>
-        <a:xfrm>
-          <a:off x="0" y="0"/>
-          <a:ext cx="0" cy="0"/>
-          <a:chOff x="0" y="0"/>
-          <a:chExt cx="0" cy="0"/>
-        </a:xfrm>
-      </p:grpSpPr>
-      <p:sp>
-        <p:nvSpPr>
-          <p:cNvPr id="2" name="eyebrow"/>
-          <p:cNvSpPr txBox="1"/>
-          <p:nvPr/>
-        </p:nvSpPr>
-        <p:spPr>
-          <a:xfrm>
-            <a:off x="548640" y="384048"/>
-            <a:ext cx="7315200" cy="274320"/>
-          </a:xfrm>
-          <a:prstGeom prst="rect">
-            <a:avLst/>
-          </a:prstGeom>
-          <a:noFill/>
-          <a:ln/>
-        </p:spPr>
-        <p:txBody>
-          <a:bodyPr wrap="square" lIns="0" tIns="0" rIns="0" bIns="0" rtlCol="0" anchor="ctr"/>
-          <a:lstStyle/>
-          <a:p>
-            <a:pPr indent="0" marL="0">
-              <a:buNone/>
-            </a:pPr>
-            <a:r>
-              <a:rPr lang="en-US" sz="1200" b="1" spc="300" kern="0" dirty="0">
-                <a:solidFill>
                   <a:srgbClr val="FF7A33"/>
                 </a:solidFill>
                 <a:latin typeface="Consolas" pitchFamily="34" charset="0"/>
@@ -7531,7 +6828,7 @@
             <a:pPr algn="r"/>
             <a:fld id="{F7021451-1387-4CA6-816F-3879F97B5CBC}" type="slidenum">
               <a:rPr b="0" lang="en-US"/>
-              <a:t>7</a:t>
+              <a:t>6</a:t>
             </a:fld>
             <a:endParaRPr lang="en-US"/>
           </a:p>

</xml_diff>

<commit_message>
pitch: 5 slides (midpoint slide dropped), notes re-timed for 3:00
Co-Authored-By: Claude Opus 5.5 (1M context) <noreply@anthropic.com>
</commit_message>
<xml_diff>
--- a/docs/presentation/pitch.pptx
+++ b/docs/presentation/pitch.pptx
@@ -10,10 +10,9 @@
     <p:sldId id="258" r:id="rId4"/>
     <p:sldId id="259" r:id="rId5"/>
     <p:sldId id="260" r:id="rId6"/>
-    <p:sldId id="261" r:id="rId7"/>
   </p:sldIdLst>
   <p:notesMasterIdLst>
-    <p:notesMasterId r:id="rId8"/>
+    <p:notesMasterId r:id="rId7"/>
   </p:notesMasterIdLst>
   <p:sldSz cx="12192000" cy="6858000"/>
   <p:notesSz cx="6858000" cy="12192000"/>
@@ -112,22 +111,21 @@
   <p:extLst>
     <p:ext uri="{521415D9-36F7-43E2-AB2F-B90AF26B5E84}">
       <p14:sectionLst xmlns:p14="http://schemas.microsoft.com/office/powerpoint/2010/main">
-        <p14:section name="Why" id="{5f3eb38d-ef0c-7841-1ca6-405cfc8d5649}">
+        <p14:section name="Why" id="{aa290296-0f52-cf2d-b7a0-506b6e58559e}">
           <p14:sldIdLst>
             <p14:sldId id="256"/>
             <p14:sldId id="257"/>
           </p14:sldIdLst>
         </p14:section>
-        <p14:section name="How" id="{77a9d6fd-a493-1b2d-d131-ca8aef5e91e3}">
+        <p14:section name="How" id="{7cb23ae1-854e-40b6-54b7-f82de9c0c523}">
           <p14:sldIdLst>
             <p14:sldId id="258"/>
             <p14:sldId id="259"/>
           </p14:sldIdLst>
         </p14:section>
-        <p14:section name="Proof" id="{740777e5-093f-14b2-95f8-007a0fcc4ea9}">
+        <p14:section name="Demo" id="{4326fe49-dc81-a575-2a64-40c55197c637}">
           <p14:sldIdLst>
             <p14:sldId id="260"/>
-            <p14:sldId id="261"/>
           </p14:sldIdLst>
         </p14:section>
       </p14:sectionLst>
@@ -622,7 +620,7 @@
           <a:p>
             <a:r>
               <a:rPr lang="en-US" dirty="0"/>
-              <a:t>(0:15–0:40) The task: a written game spec in, a strategy file out, unattended, on three budgets from three cents and three minutes up to ten dollars and thirty minutes. Only wins count. We started with research: Google DeepMind’s Code World Models: an LLM that writes a simulator plus search code matches or beats Gemini 2.5 Pro playing directly in 9 of 10 games. So our insight: the LLM is the programmer, not the player, and nothing it writes is trusted before it is verified.</a:t>
+              <a:t>(0:15–0:45) The task: a written game spec in, a strategy file out, unattended, on three budgets from three cents and three minutes up to ten dollars and thirty minutes. Only wins count. We started with research: Google DeepMind’s Code World Models: an LLM that writes a simulator plus search code matches or beats Gemini 2.5 Pro playing directly in 9 of 10 games. So our insight: the LLM is the programmer, not the player, and nothing it writes is trusted before it is verified.</a:t>
             </a:r>
             <a:endParaRPr lang="en-US" dirty="0"/>
           </a:p>
@@ -710,7 +708,7 @@
           <a:p>
             <a:r>
               <a:rPr lang="en-US" dirty="0"/>
-              <a:t>(0:40–1:15) The pipeline. It writes several strategy drafts with different strategic personas and, in parallel, a simulator of the game. Nothing is trusted: the simulator must reproduce the spec’s worked examples, every draft is probed and repaired from its tracebacks. The survivors play a round robin on the simulator, both seats, many seeds, under the tournament’s real time limits. Then the strongest model writes challengers against the champion’s weak spots, and we repeat while time and money last. Around all of it, a guard: hard timer, fallback strategy, output check, so a forfeit is impossible by construction. Budget and deadline are enforced per call.</a:t>
+              <a:t>(0:45–1:30) The pipeline. It writes several strategy drafts with different strategic personas and, in parallel, a simulator of the game. Nothing is trusted: the simulator must reproduce the spec’s worked examples, every draft is probed and repaired from its tracebacks. The survivors play a round robin on the simulator, both seats, many seeds, under the tournament’s real time limits. Then the strongest model writes challengers against the champion’s weak spots, and we repeat while time and money last. Around all of it, a guard: hard timer, fallback strategy, output check, so a forfeit is impossible by construction. Budget and deadline are enforced per call.</a:t>
             </a:r>
             <a:endParaRPr lang="en-US" dirty="0"/>
           </a:p>
@@ -798,7 +796,7 @@
           <a:p>
             <a:r>
               <a:rPr lang="en-US" dirty="0"/>
-              <a:t>(1:15–1:45) We built the harness the way it works itself. Claude Code was our engineering team: parallel agents wrote and reviewed every module, held to 416 tests. Then we ran loops. Besides the two dev games we built eight games of our own with new mechanics, and kept four of them out of all tuning, as an honest exam. Each epoch: switch features off one at a time, measure, keep only what wins. More than 120 measured runs, about 45 dollars in total.</a:t>
+              <a:t>(1:30–2:15) We built the harness the way it works itself. Claude Code was our engineering team: parallel agents wrote and reviewed every module, held to 416 tests. Then we ran loops. Besides the two dev games we built eight games of our own with new mechanics, and kept four of them out of all tuning, as an honest exam. Each epoch: switch features off one at a time, measure, keep only what wins. More than 120 measured runs, about 45 dollars in total.</a:t>
             </a:r>
             <a:endParaRPr lang="en-US" dirty="0"/>
           </a:p>
@@ -886,7 +884,8 @@
           <a:p>
             <a:r>
               <a:rPr lang="en-US" dirty="0"/>
-              <a:t>(1:45–2:30) Real evidence from outside: the organisers’ midpoint evaluation, task B, four teams, five runs each, on beta and a hidden game. On the hidden game our best strategy was number one of all twenty, winning 94.8% of its matches; overall we placed second of four. Not one of our strategies ever forfeited: 112 delivered strategies, all pass the official conformance check. Two of our five runs were weak, and we traced that to our own simulator check, which rejected correct simulators of games with hidden information; it is fixed. And on two brand-new games nobody tuned on, the final harness beats the one-shot baseline 36 to 0 to 12 and 48 to 0 to 0. (Wins–draws–losses; one-shot = one LLM draft, what a typical harness ships.)</a:t>
+              <a:t>(2:15–3:00) Finally, one real run, recorded in the evaluation’s Docker container on the task-A budget. After 24 seconds the first valid draft leads. At 35 seconds the simulator fails a worked example from the spec, at 68 it is repaired and passes. Self-play ranks the drafts, an improvement round adds a challenger, and at 141 seconds the champion is delivered, for 1.8 cents. Spec in, strategy out, never a forfeit. Thank you.
+LIVE DEMO OPTION: start `./run.sh tasks/beta-A` on a second screen when the pitch begins (about 2.5 minutes, about $0.02); on this slide show its last lines (exit code 0) and `arena check ... PASSED`. If anything goes wrong, this slide is the recorded run.</a:t>
             </a:r>
             <a:endParaRPr lang="en-US" dirty="0"/>
           </a:p>
@@ -910,95 +909,6 @@
             <a:fld id="{F7021451-1387-4CA6-816F-3879F97B5CBC}" type="slidenum">
               <a:rPr lang="en-US"/>
               <a:t>5</a:t>
-            </a:fld>
-            <a:endParaRPr lang="en-US"/>
-          </a:p>
-        </p:txBody>
-      </p:sp>
-    </p:spTree>
-    <p:extLst>
-      <p:ext uri="{BB962C8B-B14F-4D97-AF65-F5344CB8AC3E}">
-        <p14:creationId xmlns:p14="http://schemas.microsoft.com/office/powerpoint/2010/main" val="1024086991"/>
-      </p:ext>
-    </p:extLst>
-  </p:cSld>
-  <p:clrMapOvr>
-    <a:masterClrMapping/>
-  </p:clrMapOvr>
-</p:notes>
-</file>
-
-<file path=ppt/notesSlides/notesSlide6.xml><?xml version="1.0" encoding="utf-8"?>
-<p:notes xmlns:a="http://schemas.openxmlformats.org/drawingml/2006/main" xmlns:r="http://schemas.openxmlformats.org/officeDocument/2006/relationships" xmlns:p="http://schemas.openxmlformats.org/presentationml/2006/main">
-  <p:cSld>
-    <p:spTree>
-      <p:nvGrpSpPr>
-        <p:cNvPr id="1" name=""/>
-        <p:cNvGrpSpPr/>
-        <p:nvPr/>
-      </p:nvGrpSpPr>
-      <p:grpSpPr>
-        <a:xfrm>
-          <a:off x="0" y="0"/>
-          <a:ext cx="0" cy="0"/>
-          <a:chOff x="0" y="0"/>
-          <a:chExt cx="0" cy="0"/>
-        </a:xfrm>
-      </p:grpSpPr>
-      <p:sp>
-        <p:nvSpPr>
-          <p:cNvPr id="2" name="Slide Image Placeholder 1"/>
-          <p:cNvSpPr>
-            <a:spLocks noGrp="1" noRot="1" noChangeAspect="1"/>
-          </p:cNvSpPr>
-          <p:nvPr>
-            <p:ph type="sldImg"/>
-          </p:nvPr>
-        </p:nvSpPr>
-        <p:spPr/>
-      </p:sp>
-      <p:sp>
-        <p:nvSpPr>
-          <p:cNvPr id="3" name="Notes Placeholder 2"/>
-          <p:cNvSpPr>
-            <a:spLocks noGrp="1"/>
-          </p:cNvSpPr>
-          <p:nvPr>
-            <p:ph type="body" idx="1"/>
-          </p:nvPr>
-        </p:nvSpPr>
-        <p:spPr/>
-        <p:txBody>
-          <a:bodyPr/>
-          <a:lstStyle/>
-          <a:p>
-            <a:r>
-              <a:rPr lang="en-US" dirty="0"/>
-              <a:t>(2:30–3:00) Finally, one real run, recorded in the evaluation’s Docker container on the task-A budget. After 24 seconds the first valid draft leads. At 35 seconds the simulator fails a worked example from the spec, at 68 it is repaired and passes. Self-play ranks the drafts, an improvement round adds a challenger, and at 141 seconds the champion is delivered, for 1.8 cents. Spec in, strategy out, never a forfeit. Thank you.
-LIVE DEMO OPTION: start `./run.sh tasks/beta-A` on a second screen when the pitch begins (about 2.5 minutes, about $0.02); on this slide show its last lines (exit code 0) and `arena check ... PASSED`. If anything goes wrong, this slide is the recorded run.</a:t>
-            </a:r>
-            <a:endParaRPr lang="en-US" dirty="0"/>
-          </a:p>
-        </p:txBody>
-      </p:sp>
-      <p:sp>
-        <p:nvSpPr>
-          <p:cNvPr id="4" name="Slide Number Placeholder 3"/>
-          <p:cNvSpPr>
-            <a:spLocks noGrp="1"/>
-          </p:cNvSpPr>
-          <p:nvPr>
-            <p:ph type="sldNum" sz="quarter" idx="10"/>
-          </p:nvPr>
-        </p:nvSpPr>
-        <p:spPr/>
-        <p:txBody>
-          <a:bodyPr/>
-          <a:lstStyle/>
-          <a:p>
-            <a:fld id="{F7021451-1387-4CA6-816F-3879F97B5CBC}" type="slidenum">
-              <a:rPr lang="en-US"/>
-              <a:t>6</a:t>
             </a:fld>
             <a:endParaRPr lang="en-US"/>
           </a:p>
@@ -5449,501 +5359,6 @@
             <a:r>
               <a:rPr lang="en-US" sz="1200" b="1" spc="300" kern="0" dirty="0">
                 <a:solidFill>
-                  <a:srgbClr val="3A2010"/>
-                </a:solidFill>
-                <a:latin typeface="Consolas" pitchFamily="34" charset="0"/>
-                <a:ea typeface="Consolas" pitchFamily="34" charset="-122"/>
-                <a:cs typeface="Consolas" pitchFamily="34" charset="-120"/>
-              </a:rPr>
-              <a:t>THE ORGANISERS’ MIDPOINT EVALUATION</a:t>
-            </a:r>
-            <a:endParaRPr lang="en-US" sz="1200" dirty="0"/>
-          </a:p>
-        </p:txBody>
-      </p:sp>
-      <p:sp>
-        <p:nvSpPr>
-          <p:cNvPr id="3" name="Text 0"/>
-          <p:cNvSpPr/>
-          <p:nvPr>
-            <p:ph idx="100" type="title" hasCustomPrompt="1"/>
-          </p:nvPr>
-        </p:nvSpPr>
-        <p:spPr>
-          <a:xfrm>
-            <a:off x="548640" y="713232"/>
-            <a:ext cx="11094415" cy="822960"/>
-          </a:xfrm>
-          <a:prstGeom prst="rect">
-            <a:avLst/>
-          </a:prstGeom>
-          <a:noFill/>
-          <a:ln/>
-        </p:spPr>
-        <p:txBody>
-          <a:bodyPr wrap="square" lIns="0" tIns="0" rIns="0" bIns="0" rtlCol="0" anchor="t"/>
-          <a:lstStyle/>
-          <a:p>
-            <a:pPr algn="l" indent="0" marL="0">
-              <a:buNone/>
-            </a:pPr>
-            <a:r>
-              <a:rPr lang="en-US" sz="3400" b="1" dirty="0">
-                <a:solidFill>
-                  <a:srgbClr val="0F1218"/>
-                </a:solidFill>
-                <a:latin typeface="Century Gothic" pitchFamily="34" charset="0"/>
-                <a:ea typeface="Century Gothic" pitchFamily="34" charset="-122"/>
-                <a:cs typeface="Century Gothic" pitchFamily="34" charset="-120"/>
-              </a:rPr>
-              <a:t>Our best strategy topped the hidden game</a:t>
-            </a:r>
-            <a:endParaRPr lang="en-US" sz="3400" dirty="0"/>
-          </a:p>
-        </p:txBody>
-      </p:sp>
-      <p:sp>
-        <p:nvSpPr>
-          <p:cNvPr id="4" name="Text 2"/>
-          <p:cNvSpPr txBox="1"/>
-          <p:nvPr/>
-        </p:nvSpPr>
-        <p:spPr>
-          <a:xfrm>
-            <a:off x="548640" y="2377440"/>
-            <a:ext cx="3520440" cy="1097280"/>
-          </a:xfrm>
-          <a:prstGeom prst="rect">
-            <a:avLst/>
-          </a:prstGeom>
-          <a:noFill/>
-          <a:ln/>
-        </p:spPr>
-        <p:txBody>
-          <a:bodyPr wrap="square" lIns="0" tIns="0" rIns="0" bIns="0" rtlCol="0" anchor="ctr"/>
-          <a:lstStyle/>
-          <a:p>
-            <a:pPr indent="0" marL="0">
-              <a:buNone/>
-            </a:pPr>
-            <a:r>
-              <a:rPr lang="en-US" sz="5600" b="1" dirty="0">
-                <a:solidFill>
-                  <a:srgbClr val="0F1218"/>
-                </a:solidFill>
-                <a:latin typeface="Century Gothic" pitchFamily="34" charset="0"/>
-                <a:ea typeface="Century Gothic" pitchFamily="34" charset="-122"/>
-                <a:cs typeface="Century Gothic" pitchFamily="34" charset="-120"/>
-              </a:rPr>
-              <a:t>#1 of 20</a:t>
-            </a:r>
-            <a:endParaRPr lang="en-US" sz="5600" dirty="0"/>
-          </a:p>
-        </p:txBody>
-      </p:sp>
-      <p:sp>
-        <p:nvSpPr>
-          <p:cNvPr id="5" name="Shape 3"/>
-          <p:cNvSpPr/>
-          <p:nvPr/>
-        </p:nvSpPr>
-        <p:spPr>
-          <a:xfrm>
-            <a:off x="548640" y="3657600"/>
-            <a:ext cx="1097280" cy="0"/>
-          </a:xfrm>
-          <a:prstGeom prst="line">
-            <a:avLst/>
-          </a:prstGeom>
-          <a:noFill/>
-          <a:ln w="25400">
-            <a:solidFill>
-              <a:srgbClr val="0F1218"/>
-            </a:solidFill>
-            <a:prstDash val="solid"/>
-          </a:ln>
-        </p:spPr>
-      </p:sp>
-      <p:sp>
-        <p:nvSpPr>
-          <p:cNvPr id="6" name="Text 4"/>
-          <p:cNvSpPr txBox="1"/>
-          <p:nvPr/>
-        </p:nvSpPr>
-        <p:spPr>
-          <a:xfrm>
-            <a:off x="548640" y="3886200"/>
-            <a:ext cx="3337560" cy="822960"/>
-          </a:xfrm>
-          <a:prstGeom prst="rect">
-            <a:avLst/>
-          </a:prstGeom>
-          <a:noFill/>
-          <a:ln/>
-        </p:spPr>
-        <p:txBody>
-          <a:bodyPr wrap="square" lIns="0" tIns="0" rIns="0" bIns="0" rtlCol="0" anchor="t"/>
-          <a:lstStyle/>
-          <a:p>
-            <a:pPr indent="0" marL="0">
-              <a:buNone/>
-            </a:pPr>
-            <a:r>
-              <a:rPr lang="en-US" sz="2000" dirty="0">
-                <a:solidFill>
-                  <a:srgbClr val="2A1408"/>
-                </a:solidFill>
-                <a:latin typeface="Calibri" pitchFamily="34" charset="0"/>
-                <a:ea typeface="Calibri" pitchFamily="34" charset="-122"/>
-                <a:cs typeface="Calibri" pitchFamily="34" charset="-120"/>
-              </a:rPr>
-              <a:t>strategies on the hidden game (94.8% won)</a:t>
-            </a:r>
-            <a:endParaRPr lang="en-US" sz="2000" dirty="0"/>
-          </a:p>
-        </p:txBody>
-      </p:sp>
-      <p:sp>
-        <p:nvSpPr>
-          <p:cNvPr id="7" name="Text 5"/>
-          <p:cNvSpPr txBox="1"/>
-          <p:nvPr/>
-        </p:nvSpPr>
-        <p:spPr>
-          <a:xfrm>
-            <a:off x="4343400" y="2377440"/>
-            <a:ext cx="3520440" cy="1097280"/>
-          </a:xfrm>
-          <a:prstGeom prst="rect">
-            <a:avLst/>
-          </a:prstGeom>
-          <a:noFill/>
-          <a:ln/>
-        </p:spPr>
-        <p:txBody>
-          <a:bodyPr wrap="square" lIns="0" tIns="0" rIns="0" bIns="0" rtlCol="0" anchor="ctr"/>
-          <a:lstStyle/>
-          <a:p>
-            <a:pPr indent="0" marL="0">
-              <a:buNone/>
-            </a:pPr>
-            <a:r>
-              <a:rPr lang="en-US" sz="5600" b="1" dirty="0">
-                <a:solidFill>
-                  <a:srgbClr val="0F1218"/>
-                </a:solidFill>
-                <a:latin typeface="Century Gothic" pitchFamily="34" charset="0"/>
-                <a:ea typeface="Century Gothic" pitchFamily="34" charset="-122"/>
-                <a:cs typeface="Century Gothic" pitchFamily="34" charset="-120"/>
-              </a:rPr>
-              <a:t>2nd of 4</a:t>
-            </a:r>
-            <a:endParaRPr lang="en-US" sz="5600" dirty="0"/>
-          </a:p>
-        </p:txBody>
-      </p:sp>
-      <p:sp>
-        <p:nvSpPr>
-          <p:cNvPr id="8" name="Shape 6"/>
-          <p:cNvSpPr/>
-          <p:nvPr/>
-        </p:nvSpPr>
-        <p:spPr>
-          <a:xfrm>
-            <a:off x="4343400" y="3657600"/>
-            <a:ext cx="1097280" cy="0"/>
-          </a:xfrm>
-          <a:prstGeom prst="line">
-            <a:avLst/>
-          </a:prstGeom>
-          <a:noFill/>
-          <a:ln w="25400">
-            <a:solidFill>
-              <a:srgbClr val="0F1218"/>
-            </a:solidFill>
-            <a:prstDash val="solid"/>
-          </a:ln>
-        </p:spPr>
-      </p:sp>
-      <p:sp>
-        <p:nvSpPr>
-          <p:cNvPr id="9" name="Text 7"/>
-          <p:cNvSpPr txBox="1"/>
-          <p:nvPr/>
-        </p:nvSpPr>
-        <p:spPr>
-          <a:xfrm>
-            <a:off x="4343400" y="3886200"/>
-            <a:ext cx="3337560" cy="822960"/>
-          </a:xfrm>
-          <a:prstGeom prst="rect">
-            <a:avLst/>
-          </a:prstGeom>
-          <a:noFill/>
-          <a:ln/>
-        </p:spPr>
-        <p:txBody>
-          <a:bodyPr wrap="square" lIns="0" tIns="0" rIns="0" bIns="0" rtlCol="0" anchor="t"/>
-          <a:lstStyle/>
-          <a:p>
-            <a:pPr indent="0" marL="0">
-              <a:buNone/>
-            </a:pPr>
-            <a:r>
-              <a:rPr lang="en-US" sz="2000" dirty="0">
-                <a:solidFill>
-                  <a:srgbClr val="2A1408"/>
-                </a:solidFill>
-                <a:latin typeface="Calibri" pitchFamily="34" charset="0"/>
-                <a:ea typeface="Calibri" pitchFamily="34" charset="-122"/>
-                <a:cs typeface="Calibri" pitchFamily="34" charset="-120"/>
-              </a:rPr>
-              <a:t>teams overall, task B</a:t>
-            </a:r>
-            <a:endParaRPr lang="en-US" sz="2000" dirty="0"/>
-          </a:p>
-        </p:txBody>
-      </p:sp>
-      <p:sp>
-        <p:nvSpPr>
-          <p:cNvPr id="10" name="Text 8"/>
-          <p:cNvSpPr txBox="1"/>
-          <p:nvPr/>
-        </p:nvSpPr>
-        <p:spPr>
-          <a:xfrm>
-            <a:off x="8138160" y="2377440"/>
-            <a:ext cx="3520440" cy="1097280"/>
-          </a:xfrm>
-          <a:prstGeom prst="rect">
-            <a:avLst/>
-          </a:prstGeom>
-          <a:noFill/>
-          <a:ln/>
-        </p:spPr>
-        <p:txBody>
-          <a:bodyPr wrap="square" lIns="0" tIns="0" rIns="0" bIns="0" rtlCol="0" anchor="ctr"/>
-          <a:lstStyle/>
-          <a:p>
-            <a:pPr indent="0" marL="0">
-              <a:buNone/>
-            </a:pPr>
-            <a:r>
-              <a:rPr lang="en-US" sz="5600" b="1" dirty="0">
-                <a:solidFill>
-                  <a:srgbClr val="0F1218"/>
-                </a:solidFill>
-                <a:latin typeface="Century Gothic" pitchFamily="34" charset="0"/>
-                <a:ea typeface="Century Gothic" pitchFamily="34" charset="-122"/>
-                <a:cs typeface="Century Gothic" pitchFamily="34" charset="-120"/>
-              </a:rPr>
-              <a:t>0</a:t>
-            </a:r>
-            <a:endParaRPr lang="en-US" sz="5600" dirty="0"/>
-          </a:p>
-        </p:txBody>
-      </p:sp>
-      <p:sp>
-        <p:nvSpPr>
-          <p:cNvPr id="11" name="Shape 9"/>
-          <p:cNvSpPr/>
-          <p:nvPr/>
-        </p:nvSpPr>
-        <p:spPr>
-          <a:xfrm>
-            <a:off x="8138160" y="3657600"/>
-            <a:ext cx="1097280" cy="0"/>
-          </a:xfrm>
-          <a:prstGeom prst="line">
-            <a:avLst/>
-          </a:prstGeom>
-          <a:noFill/>
-          <a:ln w="25400">
-            <a:solidFill>
-              <a:srgbClr val="0F1218"/>
-            </a:solidFill>
-            <a:prstDash val="solid"/>
-          </a:ln>
-        </p:spPr>
-      </p:sp>
-      <p:sp>
-        <p:nvSpPr>
-          <p:cNvPr id="12" name="Text 10"/>
-          <p:cNvSpPr txBox="1"/>
-          <p:nvPr/>
-        </p:nvSpPr>
-        <p:spPr>
-          <a:xfrm>
-            <a:off x="8138160" y="3886200"/>
-            <a:ext cx="3337560" cy="822960"/>
-          </a:xfrm>
-          <a:prstGeom prst="rect">
-            <a:avLst/>
-          </a:prstGeom>
-          <a:noFill/>
-          <a:ln/>
-        </p:spPr>
-        <p:txBody>
-          <a:bodyPr wrap="square" lIns="0" tIns="0" rIns="0" bIns="0" rtlCol="0" anchor="t"/>
-          <a:lstStyle/>
-          <a:p>
-            <a:pPr indent="0" marL="0">
-              <a:buNone/>
-            </a:pPr>
-            <a:r>
-              <a:rPr lang="en-US" sz="2000" dirty="0">
-                <a:solidFill>
-                  <a:srgbClr val="2A1408"/>
-                </a:solidFill>
-                <a:latin typeface="Calibri" pitchFamily="34" charset="0"/>
-                <a:ea typeface="Calibri" pitchFamily="34" charset="-122"/>
-                <a:cs typeface="Calibri" pitchFamily="34" charset="-120"/>
-              </a:rPr>
-              <a:t>forfeits in 112 delivered strategies</a:t>
-            </a:r>
-            <a:endParaRPr lang="en-US" sz="2000" dirty="0"/>
-          </a:p>
-        </p:txBody>
-      </p:sp>
-      <p:sp>
-        <p:nvSpPr>
-          <p:cNvPr id="13" name="Text 11"/>
-          <p:cNvSpPr txBox="1"/>
-          <p:nvPr/>
-        </p:nvSpPr>
-        <p:spPr>
-          <a:xfrm>
-            <a:off x="548640" y="5349240"/>
-            <a:ext cx="10881360" cy="685800"/>
-          </a:xfrm>
-          <a:prstGeom prst="rect">
-            <a:avLst/>
-          </a:prstGeom>
-          <a:noFill/>
-          <a:ln/>
-        </p:spPr>
-        <p:txBody>
-          <a:bodyPr wrap="square" lIns="0" tIns="0" rIns="0" bIns="0" rtlCol="0" anchor="t"/>
-          <a:lstStyle/>
-          <a:p>
-            <a:pPr indent="0" marL="0">
-              <a:buNone/>
-            </a:pPr>
-            <a:r>
-              <a:rPr lang="en-US" sz="1800" dirty="0">
-                <a:solidFill>
-                  <a:srgbClr val="2A1408"/>
-                </a:solidFill>
-                <a:latin typeface="Calibri" pitchFamily="34" charset="0"/>
-                <a:ea typeface="Calibri" pitchFamily="34" charset="-122"/>
-                <a:cs typeface="Calibri" pitchFamily="34" charset="-120"/>
-              </a:rPr>
-              <a:t>Weak runs traced to our simulator check and fixed. On fresh, untuned games the final harness beats the one-shot baseline 36–0–12 and 48–0–0.</a:t>
-            </a:r>
-            <a:endParaRPr lang="en-US" sz="1800" dirty="0"/>
-          </a:p>
-        </p:txBody>
-      </p:sp>
-      <p:sp>
-        <p:nvSpPr>
-          <p:cNvPr id="25" name="Slide Number Placeholder 0"/>
-          <p:cNvSpPr>
-            <a:spLocks noGrp="1"/>
-          </p:cNvSpPr>
-          <p:nvPr>
-            <p:ph type="sldNum" sz="quarter" idx="4294967295"/>
-          </p:nvPr>
-        </p:nvSpPr>
-        <p:spPr>
-          <a:xfrm>
-            <a:off x="11094415" y="6355080"/>
-            <a:ext cx="548640" cy="274320"/>
-          </a:xfrm>
-          <a:prstGeom prst="rect">
-            <a:avLst/>
-          </a:prstGeom>
-          <a:extLst>
-            <a:ext uri="{C572A759-6A51-4108-AA02-DFA0A04FC94B}">
-              <ma14:wrappingTextBoxFlag xmlns:ma14="http://schemas.microsoft.com/office/mac/drawingml/2011/main" val="0"/>
-            </a:ext>
-          </a:extLst>
-        </p:spPr>
-        <p:txBody>
-          <a:bodyPr/>
-          <a:lstStyle>
-            <a:lvl1pPr>
-              <a:defRPr sz="1100">
-                <a:solidFill>
-                  <a:srgbClr val="3A2010"/>
-                </a:solidFill>
-                <a:latin typeface="Consolas"/>
-                <a:ea typeface="Consolas"/>
-                <a:cs typeface="Consolas"/>
-              </a:defRPr>
-            </a:lvl1pPr>
-          </a:lstStyle>
-          <a:p>
-            <a:pPr algn="r"/>
-            <a:fld id="{F7021451-1387-4CA6-816F-3879F97B5CBC}" type="slidenum">
-              <a:rPr b="0" lang="en-US"/>
-              <a:t>5</a:t>
-            </a:fld>
-            <a:endParaRPr lang="en-US"/>
-          </a:p>
-        </p:txBody>
-      </p:sp>
-    </p:spTree>
-  </p:cSld>
-  <p:clrMapOvr>
-    <a:masterClrMapping/>
-  </p:clrMapOvr>
-</p:sld>
-</file>
-
-<file path=ppt/slides/slide6.xml><?xml version="1.0" encoding="utf-8"?>
-<p:sld xmlns:a="http://schemas.openxmlformats.org/drawingml/2006/main" xmlns:r="http://schemas.openxmlformats.org/officeDocument/2006/relationships" xmlns:p="http://schemas.openxmlformats.org/presentationml/2006/main">
-  <p:cSld name="Slide 6">
-    <p:spTree>
-      <p:nvGrpSpPr>
-        <p:cNvPr id="1" name=""/>
-        <p:cNvGrpSpPr/>
-        <p:nvPr/>
-      </p:nvGrpSpPr>
-      <p:grpSpPr>
-        <a:xfrm>
-          <a:off x="0" y="0"/>
-          <a:ext cx="0" cy="0"/>
-          <a:chOff x="0" y="0"/>
-          <a:chExt cx="0" cy="0"/>
-        </a:xfrm>
-      </p:grpSpPr>
-      <p:sp>
-        <p:nvSpPr>
-          <p:cNvPr id="2" name="eyebrow"/>
-          <p:cNvSpPr txBox="1"/>
-          <p:nvPr/>
-        </p:nvSpPr>
-        <p:spPr>
-          <a:xfrm>
-            <a:off x="548640" y="384048"/>
-            <a:ext cx="7315200" cy="274320"/>
-          </a:xfrm>
-          <a:prstGeom prst="rect">
-            <a:avLst/>
-          </a:prstGeom>
-          <a:noFill/>
-          <a:ln/>
-        </p:spPr>
-        <p:txBody>
-          <a:bodyPr wrap="square" lIns="0" tIns="0" rIns="0" bIns="0" rtlCol="0" anchor="ctr"/>
-          <a:lstStyle/>
-          <a:p>
-            <a:pPr indent="0" marL="0">
-              <a:buNone/>
-            </a:pPr>
-            <a:r>
-              <a:rPr lang="en-US" sz="1200" b="1" spc="300" kern="0" dirty="0">
-                <a:solidFill>
                   <a:srgbClr val="FF7A33"/>
                 </a:solidFill>
                 <a:latin typeface="Consolas" pitchFamily="34" charset="0"/>
@@ -6828,7 +6243,7 @@
             <a:pPr algn="r"/>
             <a:fld id="{F7021451-1387-4CA6-816F-3879F97B5CBC}" type="slidenum">
               <a:rPr b="0" lang="en-US"/>
-              <a:t>6</a:t>
+              <a:t>5</a:t>
             </a:fld>
             <a:endParaRPr lang="en-US"/>
           </a:p>

</xml_diff>

<commit_message>
pitch: slide 2 = why (rules + research), slide 3 = how (the LLM writes, plain code verifies); epoch 3 = the midpoint follow-up experiments
Co-Authored-By: Claude Opus 5.5 (1M context) <noreply@anthropic.com>
</commit_message>
<xml_diff>
--- a/docs/presentation/pitch.pptx
+++ b/docs/presentation/pitch.pptx
@@ -111,19 +111,19 @@
   <p:extLst>
     <p:ext uri="{521415D9-36F7-43E2-AB2F-B90AF26B5E84}">
       <p14:sectionLst xmlns:p14="http://schemas.microsoft.com/office/powerpoint/2010/main">
-        <p14:section name="Why" id="{aa290296-0f52-cf2d-b7a0-506b6e58559e}">
+        <p14:section name="Why" id="{54f3e7b0-0820-f893-e5dd-b6399d1fb674}">
           <p14:sldIdLst>
             <p14:sldId id="256"/>
             <p14:sldId id="257"/>
           </p14:sldIdLst>
         </p14:section>
-        <p14:section name="How" id="{7cb23ae1-854e-40b6-54b7-f82de9c0c523}">
+        <p14:section name="How" id="{849b7058-68b4-7178-a5b5-71b37335ca8f}">
           <p14:sldIdLst>
             <p14:sldId id="258"/>
             <p14:sldId id="259"/>
           </p14:sldIdLst>
         </p14:section>
-        <p14:section name="Demo" id="{4326fe49-dc81-a575-2a64-40c55197c637}">
+        <p14:section name="Demo" id="{e5b143da-2ebd-1d30-5703-116cf67154a5}">
           <p14:sldIdLst>
             <p14:sldId id="260"/>
           </p14:sldIdLst>
@@ -620,7 +620,7 @@
           <a:p>
             <a:r>
               <a:rPr lang="en-US" dirty="0"/>
-              <a:t>(0:15–0:45) The task: a written game spec in, a strategy file out, unattended, on three budgets from three cents and three minutes up to ten dollars and thirty minutes. Only wins count. We started with research: Google DeepMind’s Code World Models: an LLM that writes a simulator plus search code matches or beats Gemini 2.5 Pro playing directly in 9 of 10 games. So our insight: the LLM is the programmer, not the player, and nothing it writes is trusted before it is verified.</a:t>
+              <a:t>(0:15–0:45) The task: a written game spec in, a strategy file out, unattended, on three budgets from three cents and three minutes up to ten dollars and thirty minutes. Only wins count. We started with research: Google DeepMind’s Code World Models: an LLM that writes a simulator plus search code matches or beats Gemini 2.5 Pro playing directly in 9 of 10 games. And our strategy may not call an LLM during the game anyway: stdlib only, no network. So the LLM is the programmer, not the player, and it never checks its own work: plain code runs everything it writes and keeps only what is proven.</a:t>
             </a:r>
             <a:endParaRPr lang="en-US" dirty="0"/>
           </a:p>
@@ -708,7 +708,7 @@
           <a:p>
             <a:r>
               <a:rPr lang="en-US" dirty="0"/>
-              <a:t>(0:45–1:30) The pipeline. It writes several strategy drafts with different strategic personas and, in parallel, a simulator of the game. Nothing is trusted: the simulator must reproduce the spec’s worked examples, every draft is probed and repaired from its tracebacks. The survivors play a round robin on the simulator, both seats, many seeds, under the tournament’s real time limits. Then the strongest model writes challengers against the champion’s weak spots, and we repeat while time and money last. Around all of it, a guard: hard timer, fallback strategy, output check, so a forfeit is impossible by construction. Budget and deadline are enforced per call.</a:t>
+              <a:t>(0:45–1:30) How: the LLM writes, our code verifies. The LLM writes several strategy drafts with different strategic personas and, in parallel, a simulator of the game. Nothing is trusted: the simulator must reproduce the spec’s worked examples, every draft is probed and repaired from its tracebacks. The survivors play a round robin on the simulator, both seats, many seeds, under the tournament’s real time limits. Then the strongest model writes challengers against the champion’s weak spots, and we repeat while time and money last. Around all of it, a guard: hard timer, fallback strategy, output check, so a forfeit is impossible by construction. Budget and deadline are enforced per call.</a:t>
             </a:r>
             <a:endParaRPr lang="en-US" dirty="0"/>
           </a:p>
@@ -796,7 +796,7 @@
           <a:p>
             <a:r>
               <a:rPr lang="en-US" dirty="0"/>
-              <a:t>(1:30–2:15) We built the harness the way it works itself. Claude Code was our engineering team: parallel agents wrote and reviewed every module, held to 416 tests. Then we ran loops. Besides the two dev games we built eight games of our own with new mechanics, and kept four of them out of all tuning, as an honest exam. Each epoch: switch features off one at a time, measure, keep only what wins. More than 120 measured runs, about 45 dollars in total.</a:t>
+              <a:t>(1:30–2:15) We built the harness the way it works itself. Claude Code was our engineering team: parallel agents wrote and reviewed every module, held to 416 tests. Then we ran loops. Besides the two dev games we built eight games of our own with new mechanics, and kept four of them out of all tuning, as an honest exam. Each epoch: switch features off one at a time, measure, keep only what wins. After the organisers' midpoint evaluation, Timo's two experiments rejected two ideas and traced our weak runs to the simulator check, which we fixed. More than 120 measured runs, about 45 dollars in total.</a:t>
             </a:r>
             <a:endParaRPr lang="en-US" dirty="0"/>
           </a:p>
@@ -2609,12 +2609,12 @@
         </p:nvSpPr>
         <p:spPr>
           <a:xfrm>
-            <a:off x="548640" y="2148840"/>
-            <a:ext cx="3520440" cy="3108960"/>
+            <a:off x="548640" y="2103120"/>
+            <a:ext cx="3520440" cy="3429000"/>
           </a:xfrm>
           <a:prstGeom prst="roundRect">
             <a:avLst>
-              <a:gd name="adj" fmla="val 3529"/>
+              <a:gd name="adj" fmla="val 3200"/>
             </a:avLst>
           </a:prstGeom>
           <a:solidFill>
@@ -2643,7 +2643,7 @@
         </p:nvSpPr>
         <p:spPr>
           <a:xfrm>
-            <a:off x="868680" y="2423160"/>
+            <a:off x="868680" y="2377440"/>
             <a:ext cx="2880360" cy="365760"/>
           </a:xfrm>
           <a:prstGeom prst="rect">
@@ -2682,7 +2682,7 @@
         </p:nvSpPr>
         <p:spPr>
           <a:xfrm>
-            <a:off x="868680" y="3108960"/>
+            <a:off x="868680" y="3063240"/>
             <a:ext cx="411480" cy="365760"/>
           </a:xfrm>
           <a:prstGeom prst="rect">
@@ -2721,7 +2721,7 @@
         </p:nvSpPr>
         <p:spPr>
           <a:xfrm>
-            <a:off x="1325880" y="3108960"/>
+            <a:off x="1325880" y="3063240"/>
             <a:ext cx="2423160" cy="411480"/>
           </a:xfrm>
           <a:prstGeom prst="rect">
@@ -2760,7 +2760,7 @@
         </p:nvSpPr>
         <p:spPr>
           <a:xfrm>
-            <a:off x="868680" y="3767328"/>
+            <a:off x="868680" y="3721608"/>
             <a:ext cx="411480" cy="365760"/>
           </a:xfrm>
           <a:prstGeom prst="rect">
@@ -2799,7 +2799,7 @@
         </p:nvSpPr>
         <p:spPr>
           <a:xfrm>
-            <a:off x="1325880" y="3767328"/>
+            <a:off x="1325880" y="3721608"/>
             <a:ext cx="2423160" cy="411480"/>
           </a:xfrm>
           <a:prstGeom prst="rect">
@@ -2838,7 +2838,7 @@
         </p:nvSpPr>
         <p:spPr>
           <a:xfrm>
-            <a:off x="868680" y="4425696"/>
+            <a:off x="868680" y="4379976"/>
             <a:ext cx="411480" cy="365760"/>
           </a:xfrm>
           <a:prstGeom prst="rect">
@@ -2877,7 +2877,7 @@
         </p:nvSpPr>
         <p:spPr>
           <a:xfrm>
-            <a:off x="1325880" y="4425696"/>
+            <a:off x="1325880" y="4379976"/>
             <a:ext cx="2423160" cy="411480"/>
           </a:xfrm>
           <a:prstGeom prst="rect">
@@ -2916,12 +2916,12 @@
         </p:nvSpPr>
         <p:spPr>
           <a:xfrm>
-            <a:off x="4343400" y="2148840"/>
-            <a:ext cx="3520440" cy="3108960"/>
+            <a:off x="4343400" y="2103120"/>
+            <a:ext cx="3520440" cy="3429000"/>
           </a:xfrm>
           <a:prstGeom prst="roundRect">
             <a:avLst>
-              <a:gd name="adj" fmla="val 3529"/>
+              <a:gd name="adj" fmla="val 3200"/>
             </a:avLst>
           </a:prstGeom>
           <a:solidFill>
@@ -2950,7 +2950,7 @@
         </p:nvSpPr>
         <p:spPr>
           <a:xfrm>
-            <a:off x="4663440" y="2423160"/>
+            <a:off x="4663440" y="2377440"/>
             <a:ext cx="2880360" cy="365760"/>
           </a:xfrm>
           <a:prstGeom prst="rect">
@@ -2989,7 +2989,7 @@
         </p:nvSpPr>
         <p:spPr>
           <a:xfrm>
-            <a:off x="4663440" y="3017520"/>
+            <a:off x="4663440" y="2971800"/>
             <a:ext cx="2880360" cy="822960"/>
           </a:xfrm>
           <a:prstGeom prst="rect">
@@ -3042,7 +3042,7 @@
         </p:nvSpPr>
         <p:spPr>
           <a:xfrm>
-            <a:off x="4663440" y="3931920"/>
+            <a:off x="4663440" y="3886200"/>
             <a:ext cx="2880360" cy="685800"/>
           </a:xfrm>
           <a:prstGeom prst="rect">
@@ -3067,7 +3067,7 @@
                 <a:ea typeface="Calibri" pitchFamily="34" charset="-122"/>
                 <a:cs typeface="Calibri" pitchFamily="34" charset="-120"/>
               </a:rPr>
-              <a:t>games where LLM-written code + search matches or beats a top LLM playing directly</a:t>
+              <a:t>games where code written by an LLM matches or beats an LLM picking the moves</a:t>
             </a:r>
             <a:endParaRPr lang="en-US" sz="1600" dirty="0"/>
           </a:p>
@@ -3081,7 +3081,7 @@
         </p:nvSpPr>
         <p:spPr>
           <a:xfrm>
-            <a:off x="4663440" y="4846320"/>
+            <a:off x="4663440" y="4800600"/>
             <a:ext cx="2880360" cy="457200"/>
           </a:xfrm>
           <a:prstGeom prst="rect">
@@ -3120,12 +3120,12 @@
         </p:nvSpPr>
         <p:spPr>
           <a:xfrm>
-            <a:off x="8138160" y="2148840"/>
-            <a:ext cx="3520440" cy="3108960"/>
+            <a:off x="8138160" y="2103120"/>
+            <a:ext cx="3520440" cy="3429000"/>
           </a:xfrm>
           <a:prstGeom prst="roundRect">
             <a:avLst>
-              <a:gd name="adj" fmla="val 3529"/>
+              <a:gd name="adj" fmla="val 3200"/>
             </a:avLst>
           </a:prstGeom>
           <a:solidFill>
@@ -3154,7 +3154,7 @@
         </p:nvSpPr>
         <p:spPr>
           <a:xfrm>
-            <a:off x="8458200" y="2423160"/>
+            <a:off x="8458200" y="2377440"/>
             <a:ext cx="2880360" cy="365760"/>
           </a:xfrm>
           <a:prstGeom prst="rect">
@@ -3193,8 +3193,47 @@
         </p:nvSpPr>
         <p:spPr>
           <a:xfrm>
-            <a:off x="8458200" y="3017520"/>
-            <a:ext cx="2880360" cy="2194560"/>
+            <a:off x="8458200" y="4572000"/>
+            <a:ext cx="2880360" cy="731520"/>
+          </a:xfrm>
+          <a:prstGeom prst="rect">
+            <a:avLst/>
+          </a:prstGeom>
+          <a:noFill/>
+          <a:ln/>
+        </p:spPr>
+        <p:txBody>
+          <a:bodyPr wrap="square" lIns="0" tIns="0" rIns="0" bIns="0" rtlCol="0" anchor="t"/>
+          <a:lstStyle/>
+          <a:p>
+            <a:pPr indent="0" marL="0">
+              <a:buNone/>
+            </a:pPr>
+            <a:r>
+              <a:rPr lang="en-US" sz="1800" dirty="0">
+                <a:solidFill>
+                  <a:srgbClr val="AEB6C2"/>
+                </a:solidFill>
+                <a:latin typeface="Calibri" pitchFamily="34" charset="0"/>
+                <a:ea typeface="Calibri" pitchFamily="34" charset="-122"/>
+                <a:cs typeface="Calibri" pitchFamily="34" charset="-120"/>
+              </a:rPr>
+              <a:t>Plain code, not the LLM, checks everything it writes.</a:t>
+            </a:r>
+            <a:endParaRPr lang="en-US" sz="1800" dirty="0"/>
+          </a:p>
+        </p:txBody>
+      </p:sp>
+      <p:sp>
+        <p:nvSpPr>
+          <p:cNvPr id="20" name="Text 18"/>
+          <p:cNvSpPr txBox="1"/>
+          <p:nvPr/>
+        </p:nvSpPr>
+        <p:spPr>
+          <a:xfrm>
+            <a:off x="8458200" y="2971800"/>
+            <a:ext cx="2880360" cy="1325880"/>
           </a:xfrm>
           <a:prstGeom prst="rect">
             <a:avLst/>
@@ -3226,7 +3265,7 @@
       </p:sp>
       <p:sp>
         <p:nvSpPr>
-          <p:cNvPr id="20" name="Text 18"/>
+          <p:cNvPr id="21" name="Text 19"/>
           <p:cNvSpPr txBox="1"/>
           <p:nvPr/>
         </p:nvSpPr>
@@ -3410,7 +3449,7 @@
                 <a:ea typeface="Century Gothic" pitchFamily="34" charset="-122"/>
                 <a:cs typeface="Century Gothic" pitchFamily="34" charset="-120"/>
               </a:rPr>
-              <a:t>Many drafts, one verified simulator, one champion</a:t>
+              <a:t>The LLM writes, our code verifies</a:t>
             </a:r>
             <a:endParaRPr lang="en-US" sz="3400" dirty="0"/>
           </a:p>
@@ -5214,7 +5253,7 @@
                 <a:ea typeface="Century Gothic" pitchFamily="34" charset="-122"/>
                 <a:cs typeface="Century Gothic" pitchFamily="34" charset="-120"/>
               </a:rPr>
-              <a:t>Midpoint feedback</a:t>
+              <a:t>Midpoint feedback · 2 experiments</a:t>
             </a:r>
             <a:endParaRPr lang="en-US" sz="1800" dirty="0"/>
           </a:p>
@@ -5253,7 +5292,7 @@
                 <a:ea typeface="Calibri" pitchFamily="34" charset="-122"/>
                 <a:cs typeface="Calibri" pitchFamily="34" charset="-120"/>
               </a:rPr>
-              <a:t>weak runs traced and fixed</a:t>
+              <a:t>2 ideas rejected, weak runs traced and fixed</a:t>
             </a:r>
             <a:endParaRPr lang="en-US" sz="1400" dirty="0"/>
           </a:p>

</xml_diff>

<commit_message>
pitch: closing slide (Spec in. Strategy out. Never a forfeit. Thank you!) with the real-run timeline and a one-line explanation; no live demo
Co-Authored-By: Claude Opus 5.5 (1M context) <noreply@anthropic.com>
</commit_message>
<xml_diff>
--- a/docs/presentation/pitch.pptx
+++ b/docs/presentation/pitch.pptx
@@ -111,19 +111,19 @@
   <p:extLst>
     <p:ext uri="{521415D9-36F7-43E2-AB2F-B90AF26B5E84}">
       <p14:sectionLst xmlns:p14="http://schemas.microsoft.com/office/powerpoint/2010/main">
-        <p14:section name="Why" id="{54f3e7b0-0820-f893-e5dd-b6399d1fb674}">
+        <p14:section name="Why" id="{f85089ea-264a-3109-bb17-6894e7afe29c}">
           <p14:sldIdLst>
             <p14:sldId id="256"/>
             <p14:sldId id="257"/>
           </p14:sldIdLst>
         </p14:section>
-        <p14:section name="How" id="{849b7058-68b4-7178-a5b5-71b37335ca8f}">
+        <p14:section name="How" id="{609ec389-1869-694f-34c6-4912f0023d94}">
           <p14:sldIdLst>
             <p14:sldId id="258"/>
             <p14:sldId id="259"/>
           </p14:sldIdLst>
         </p14:section>
-        <p14:section name="Demo" id="{e5b143da-2ebd-1d30-5703-116cf67154a5}">
+        <p14:section name="Close" id="{8c712ab8-9c7f-5751-547f-8cac3d7cdb1d}">
           <p14:sldIdLst>
             <p14:sldId id="260"/>
           </p14:sldIdLst>
@@ -884,8 +884,7 @@
           <a:p>
             <a:r>
               <a:rPr lang="en-US" dirty="0"/>
-              <a:t>(2:15–3:00) Finally, one real run, recorded in the evaluation’s Docker container on the task-A budget. After 24 seconds the first valid draft leads. At 35 seconds the simulator fails a worked example from the spec, at 68 it is repaired and passes. Self-play ranks the drafts, an improvement round adds a challenger, and at 141 seconds the champion is delivered, for 1.8 cents. Spec in, strategy out, never a forfeit. Thank you.
-LIVE DEMO OPTION: start `./run.sh tasks/beta-A` on a second screen when the pitch begins (about 2.5 minutes, about $0.02); on this slide show its last lines (exit code 0) and `arena check ... PASSED`. If anything goes wrong, this slide is the recorded run.</a:t>
+              <a:t>(2:15–3:00) To close, this is what one real run looks like, recorded in the evaluation’s Docker container on the task-A budget. After 24 seconds the first valid draft leads. At 35 seconds the simulator fails a worked example from the spec, so it is not trusted; at 68 it is repaired and passes. Then the drafts play each other and get ranked, an improvement round adds a challenger, and at 141 of 180 seconds the champion is delivered, for 1.8 of 3 cents. Every step is checked by plain code, and the file on disk is a valid strategy at every second. Spec in, strategy out, never a forfeit. Thank you for listening!</a:t>
             </a:r>
             <a:endParaRPr lang="en-US" dirty="0"/>
           </a:p>
@@ -5404,7 +5403,7 @@
                 <a:ea typeface="Consolas" pitchFamily="34" charset="-122"/>
                 <a:cs typeface="Consolas" pitchFamily="34" charset="-120"/>
               </a:rPr>
-              <a:t>DEMO · ONE REAL RUN, FROM SPEC TO STRATEGY.PY</a:t>
+              <a:t>ONE REAL RUN, FROM SPEC TO STRATEGY.PY</a:t>
             </a:r>
             <a:endParaRPr lang="en-US" sz="1200" dirty="0"/>
           </a:p>
@@ -5445,7 +5444,7 @@
                 <a:ea typeface="Century Gothic" pitchFamily="34" charset="-122"/>
                 <a:cs typeface="Century Gothic" pitchFamily="34" charset="-120"/>
               </a:rPr>
-              <a:t>141 seconds, 1.8 cents, one champion</a:t>
+              <a:t>Spec in. Strategy out. Never a forfeit.</a:t>
             </a:r>
             <a:endParaRPr lang="en-US" sz="3400" dirty="0"/>
           </a:p>
@@ -5453,13 +5452,52 @@
       </p:sp>
       <p:sp>
         <p:nvSpPr>
-          <p:cNvPr id="4" name="axis"/>
+          <p:cNvPr id="4" name="Text 2"/>
+          <p:cNvSpPr txBox="1"/>
+          <p:nvPr/>
+        </p:nvSpPr>
+        <p:spPr>
+          <a:xfrm>
+            <a:off x="548640" y="1481328"/>
+            <a:ext cx="8229600" cy="502920"/>
+          </a:xfrm>
+          <a:prstGeom prst="rect">
+            <a:avLst/>
+          </a:prstGeom>
+          <a:noFill/>
+          <a:ln/>
+        </p:spPr>
+        <p:txBody>
+          <a:bodyPr wrap="square" lIns="0" tIns="0" rIns="0" bIns="0" rtlCol="0" anchor="ctr"/>
+          <a:lstStyle/>
+          <a:p>
+            <a:pPr indent="0" marL="0">
+              <a:buNone/>
+            </a:pPr>
+            <a:r>
+              <a:rPr lang="en-US" sz="2600" b="1" dirty="0">
+                <a:solidFill>
+                  <a:srgbClr val="FF7A33"/>
+                </a:solidFill>
+                <a:latin typeface="Century Gothic" pitchFamily="34" charset="0"/>
+                <a:ea typeface="Century Gothic" pitchFamily="34" charset="-122"/>
+                <a:cs typeface="Century Gothic" pitchFamily="34" charset="-120"/>
+              </a:rPr>
+              <a:t>Thank you for listening!</a:t>
+            </a:r>
+            <a:endParaRPr lang="en-US" sz="2600" dirty="0"/>
+          </a:p>
+        </p:txBody>
+      </p:sp>
+      <p:sp>
+        <p:nvSpPr>
+          <p:cNvPr id="5" name="axis"/>
           <p:cNvSpPr/>
           <p:nvPr/>
         </p:nvSpPr>
         <p:spPr>
           <a:xfrm>
-            <a:off x="822960" y="3337560"/>
+            <a:off x="822960" y="3611880"/>
             <a:ext cx="10515600" cy="91440"/>
           </a:xfrm>
           <a:prstGeom prst="roundRect">
@@ -5480,13 +5518,13 @@
       </p:sp>
       <p:sp>
         <p:nvSpPr>
-          <p:cNvPr id="5" name="progress"/>
+          <p:cNvPr id="6" name="progress"/>
           <p:cNvSpPr/>
           <p:nvPr/>
         </p:nvSpPr>
         <p:spPr>
           <a:xfrm>
-            <a:off x="822960" y="3337560"/>
+            <a:off x="822960" y="3611880"/>
             <a:ext cx="8237220" cy="91440"/>
           </a:xfrm>
           <a:prstGeom prst="roundRect">
@@ -5507,13 +5545,13 @@
       </p:sp>
       <p:sp>
         <p:nvSpPr>
-          <p:cNvPr id="6" name="Text 4"/>
-          <p:cNvSpPr txBox="1"/>
-          <p:nvPr/>
-        </p:nvSpPr>
-        <p:spPr>
-          <a:xfrm>
-            <a:off x="548640" y="3566160"/>
+          <p:cNvPr id="7" name="Text 5"/>
+          <p:cNvSpPr txBox="1"/>
+          <p:nvPr/>
+        </p:nvSpPr>
+        <p:spPr>
+          <a:xfrm>
+            <a:off x="548640" y="3840480"/>
             <a:ext cx="548640" cy="274320"/>
           </a:xfrm>
           <a:prstGeom prst="rect">
@@ -5546,13 +5584,13 @@
       </p:sp>
       <p:sp>
         <p:nvSpPr>
-          <p:cNvPr id="7" name="Text 5"/>
-          <p:cNvSpPr txBox="1"/>
-          <p:nvPr/>
-        </p:nvSpPr>
-        <p:spPr>
-          <a:xfrm>
-            <a:off x="9692640" y="3566160"/>
+          <p:cNvPr id="8" name="Text 6"/>
+          <p:cNvSpPr txBox="1"/>
+          <p:nvPr/>
+        </p:nvSpPr>
+        <p:spPr>
+          <a:xfrm>
+            <a:off x="9692640" y="3840480"/>
             <a:ext cx="1645920" cy="274320"/>
           </a:xfrm>
           <a:prstGeom prst="rect">
@@ -5585,13 +5623,13 @@
       </p:sp>
       <p:sp>
         <p:nvSpPr>
-          <p:cNvPr id="8" name="event 24"/>
+          <p:cNvPr id="9" name="event 24"/>
           <p:cNvSpPr/>
           <p:nvPr/>
         </p:nvSpPr>
         <p:spPr>
           <a:xfrm>
-            <a:off x="2124456" y="3282696"/>
+            <a:off x="2124456" y="3557016"/>
             <a:ext cx="201168" cy="201168"/>
           </a:xfrm>
           <a:prstGeom prst="ellipse">
@@ -5610,13 +5648,13 @@
       </p:sp>
       <p:sp>
         <p:nvSpPr>
-          <p:cNvPr id="9" name="Text 7"/>
-          <p:cNvSpPr txBox="1"/>
-          <p:nvPr/>
-        </p:nvSpPr>
-        <p:spPr>
-          <a:xfrm>
-            <a:off x="2124456" y="2240280"/>
+          <p:cNvPr id="10" name="Text 8"/>
+          <p:cNvSpPr txBox="1"/>
+          <p:nvPr/>
+        </p:nvSpPr>
+        <p:spPr>
+          <a:xfrm>
+            <a:off x="2124456" y="2514600"/>
             <a:ext cx="1097280" cy="292608"/>
           </a:xfrm>
           <a:prstGeom prst="rect">
@@ -5649,13 +5687,13 @@
       </p:sp>
       <p:sp>
         <p:nvSpPr>
-          <p:cNvPr id="10" name="Text 8"/>
-          <p:cNvSpPr txBox="1"/>
-          <p:nvPr/>
-        </p:nvSpPr>
-        <p:spPr>
-          <a:xfrm>
-            <a:off x="2124456" y="2551176"/>
+          <p:cNvPr id="11" name="Text 9"/>
+          <p:cNvSpPr txBox="1"/>
+          <p:nvPr/>
+        </p:nvSpPr>
+        <p:spPr>
+          <a:xfrm>
+            <a:off x="2124456" y="2825496"/>
             <a:ext cx="2148840" cy="548640"/>
           </a:xfrm>
           <a:prstGeom prst="rect">
@@ -5688,13 +5726,13 @@
       </p:sp>
       <p:sp>
         <p:nvSpPr>
-          <p:cNvPr id="11" name="event 35"/>
+          <p:cNvPr id="12" name="event 35"/>
           <p:cNvSpPr/>
           <p:nvPr/>
         </p:nvSpPr>
         <p:spPr>
           <a:xfrm>
-            <a:off x="2767076" y="3282696"/>
+            <a:off x="2767076" y="3557016"/>
             <a:ext cx="201168" cy="201168"/>
           </a:xfrm>
           <a:prstGeom prst="ellipse">
@@ -5713,13 +5751,13 @@
       </p:sp>
       <p:sp>
         <p:nvSpPr>
-          <p:cNvPr id="12" name="Text 10"/>
-          <p:cNvSpPr txBox="1"/>
-          <p:nvPr/>
-        </p:nvSpPr>
-        <p:spPr>
-          <a:xfrm>
-            <a:off x="2767076" y="3886200"/>
+          <p:cNvPr id="13" name="Text 11"/>
+          <p:cNvSpPr txBox="1"/>
+          <p:nvPr/>
+        </p:nvSpPr>
+        <p:spPr>
+          <a:xfrm>
+            <a:off x="2767076" y="4160520"/>
             <a:ext cx="1097280" cy="292608"/>
           </a:xfrm>
           <a:prstGeom prst="rect">
@@ -5752,13 +5790,13 @@
       </p:sp>
       <p:sp>
         <p:nvSpPr>
-          <p:cNvPr id="13" name="Text 11"/>
-          <p:cNvSpPr txBox="1"/>
-          <p:nvPr/>
-        </p:nvSpPr>
-        <p:spPr>
-          <a:xfrm>
-            <a:off x="2767076" y="4197096"/>
+          <p:cNvPr id="14" name="Text 12"/>
+          <p:cNvSpPr txBox="1"/>
+          <p:nvPr/>
+        </p:nvSpPr>
+        <p:spPr>
+          <a:xfrm>
+            <a:off x="2767076" y="4471416"/>
             <a:ext cx="2148840" cy="548640"/>
           </a:xfrm>
           <a:prstGeom prst="rect">
@@ -5791,13 +5829,13 @@
       </p:sp>
       <p:sp>
         <p:nvSpPr>
-          <p:cNvPr id="14" name="event 68"/>
+          <p:cNvPr id="15" name="event 68"/>
           <p:cNvSpPr/>
           <p:nvPr/>
         </p:nvSpPr>
         <p:spPr>
           <a:xfrm>
-            <a:off x="4694936" y="3282696"/>
+            <a:off x="4694936" y="3557016"/>
             <a:ext cx="201168" cy="201168"/>
           </a:xfrm>
           <a:prstGeom prst="ellipse">
@@ -5816,13 +5854,13 @@
       </p:sp>
       <p:sp>
         <p:nvSpPr>
-          <p:cNvPr id="15" name="Text 13"/>
-          <p:cNvSpPr txBox="1"/>
-          <p:nvPr/>
-        </p:nvSpPr>
-        <p:spPr>
-          <a:xfrm>
-            <a:off x="4694936" y="2240280"/>
+          <p:cNvPr id="16" name="Text 14"/>
+          <p:cNvSpPr txBox="1"/>
+          <p:nvPr/>
+        </p:nvSpPr>
+        <p:spPr>
+          <a:xfrm>
+            <a:off x="4694936" y="2514600"/>
             <a:ext cx="1097280" cy="292608"/>
           </a:xfrm>
           <a:prstGeom prst="rect">
@@ -5855,13 +5893,13 @@
       </p:sp>
       <p:sp>
         <p:nvSpPr>
-          <p:cNvPr id="16" name="Text 14"/>
-          <p:cNvSpPr txBox="1"/>
-          <p:nvPr/>
-        </p:nvSpPr>
-        <p:spPr>
-          <a:xfrm>
-            <a:off x="4694936" y="2551176"/>
+          <p:cNvPr id="17" name="Text 15"/>
+          <p:cNvSpPr txBox="1"/>
+          <p:nvPr/>
+        </p:nvSpPr>
+        <p:spPr>
+          <a:xfrm>
+            <a:off x="4694936" y="2825496"/>
             <a:ext cx="2148840" cy="548640"/>
           </a:xfrm>
           <a:prstGeom prst="rect">
@@ -5894,13 +5932,13 @@
       </p:sp>
       <p:sp>
         <p:nvSpPr>
-          <p:cNvPr id="17" name="event 98"/>
+          <p:cNvPr id="18" name="event 98"/>
           <p:cNvSpPr/>
           <p:nvPr/>
         </p:nvSpPr>
         <p:spPr>
           <a:xfrm>
-            <a:off x="6447536" y="3282696"/>
+            <a:off x="6447536" y="3557016"/>
             <a:ext cx="201168" cy="201168"/>
           </a:xfrm>
           <a:prstGeom prst="ellipse">
@@ -5919,13 +5957,13 @@
       </p:sp>
       <p:sp>
         <p:nvSpPr>
-          <p:cNvPr id="18" name="Text 16"/>
-          <p:cNvSpPr txBox="1"/>
-          <p:nvPr/>
-        </p:nvSpPr>
-        <p:spPr>
-          <a:xfrm>
-            <a:off x="6447536" y="3886200"/>
+          <p:cNvPr id="19" name="Text 17"/>
+          <p:cNvSpPr txBox="1"/>
+          <p:nvPr/>
+        </p:nvSpPr>
+        <p:spPr>
+          <a:xfrm>
+            <a:off x="6447536" y="4160520"/>
             <a:ext cx="1097280" cy="292608"/>
           </a:xfrm>
           <a:prstGeom prst="rect">
@@ -5958,13 +5996,13 @@
       </p:sp>
       <p:sp>
         <p:nvSpPr>
-          <p:cNvPr id="19" name="Text 17"/>
-          <p:cNvSpPr txBox="1"/>
-          <p:nvPr/>
-        </p:nvSpPr>
-        <p:spPr>
-          <a:xfrm>
-            <a:off x="6447536" y="4197096"/>
+          <p:cNvPr id="20" name="Text 18"/>
+          <p:cNvSpPr txBox="1"/>
+          <p:nvPr/>
+        </p:nvSpPr>
+        <p:spPr>
+          <a:xfrm>
+            <a:off x="6447536" y="4471416"/>
             <a:ext cx="2148840" cy="548640"/>
           </a:xfrm>
           <a:prstGeom prst="rect">
@@ -5997,13 +6035,13 @@
       </p:sp>
       <p:sp>
         <p:nvSpPr>
-          <p:cNvPr id="20" name="event 133"/>
+          <p:cNvPr id="21" name="event 133"/>
           <p:cNvSpPr/>
           <p:nvPr/>
         </p:nvSpPr>
         <p:spPr>
           <a:xfrm>
-            <a:off x="8492236" y="3282696"/>
+            <a:off x="8492236" y="3557016"/>
             <a:ext cx="201168" cy="201168"/>
           </a:xfrm>
           <a:prstGeom prst="ellipse">
@@ -6022,13 +6060,13 @@
       </p:sp>
       <p:sp>
         <p:nvSpPr>
-          <p:cNvPr id="21" name="Text 19"/>
-          <p:cNvSpPr txBox="1"/>
-          <p:nvPr/>
-        </p:nvSpPr>
-        <p:spPr>
-          <a:xfrm>
-            <a:off x="8492236" y="2240280"/>
+          <p:cNvPr id="22" name="Text 20"/>
+          <p:cNvSpPr txBox="1"/>
+          <p:nvPr/>
+        </p:nvSpPr>
+        <p:spPr>
+          <a:xfrm>
+            <a:off x="8492236" y="2514600"/>
             <a:ext cx="1097280" cy="292608"/>
           </a:xfrm>
           <a:prstGeom prst="rect">
@@ -6061,13 +6099,13 @@
       </p:sp>
       <p:sp>
         <p:nvSpPr>
-          <p:cNvPr id="22" name="Text 20"/>
-          <p:cNvSpPr txBox="1"/>
-          <p:nvPr/>
-        </p:nvSpPr>
-        <p:spPr>
-          <a:xfrm>
-            <a:off x="8492236" y="2551176"/>
+          <p:cNvPr id="23" name="Text 21"/>
+          <p:cNvSpPr txBox="1"/>
+          <p:nvPr/>
+        </p:nvSpPr>
+        <p:spPr>
+          <a:xfrm>
+            <a:off x="8492236" y="2825496"/>
             <a:ext cx="2148840" cy="548640"/>
           </a:xfrm>
           <a:prstGeom prst="rect">
@@ -6100,13 +6138,13 @@
       </p:sp>
       <p:sp>
         <p:nvSpPr>
-          <p:cNvPr id="23" name="event 141"/>
+          <p:cNvPr id="24" name="event 141"/>
           <p:cNvSpPr/>
           <p:nvPr/>
         </p:nvSpPr>
         <p:spPr>
           <a:xfrm>
-            <a:off x="8959596" y="3282696"/>
+            <a:off x="8959596" y="3557016"/>
             <a:ext cx="201168" cy="201168"/>
           </a:xfrm>
           <a:prstGeom prst="ellipse">
@@ -6125,13 +6163,13 @@
       </p:sp>
       <p:sp>
         <p:nvSpPr>
-          <p:cNvPr id="24" name="Text 22"/>
-          <p:cNvSpPr txBox="1"/>
-          <p:nvPr/>
-        </p:nvSpPr>
-        <p:spPr>
-          <a:xfrm>
-            <a:off x="8959596" y="3886200"/>
+          <p:cNvPr id="25" name="Text 23"/>
+          <p:cNvSpPr txBox="1"/>
+          <p:nvPr/>
+        </p:nvSpPr>
+        <p:spPr>
+          <a:xfrm>
+            <a:off x="8959596" y="4160520"/>
             <a:ext cx="1097280" cy="292608"/>
           </a:xfrm>
           <a:prstGeom prst="rect">
@@ -6164,13 +6202,13 @@
       </p:sp>
       <p:sp>
         <p:nvSpPr>
-          <p:cNvPr id="25" name="Text 23"/>
-          <p:cNvSpPr txBox="1"/>
-          <p:nvPr/>
-        </p:nvSpPr>
-        <p:spPr>
-          <a:xfrm>
-            <a:off x="8959596" y="4197096"/>
+          <p:cNvPr id="26" name="Text 24"/>
+          <p:cNvSpPr txBox="1"/>
+          <p:nvPr/>
+        </p:nvSpPr>
+        <p:spPr>
+          <a:xfrm>
+            <a:off x="8959596" y="4471416"/>
             <a:ext cx="2148840" cy="548640"/>
           </a:xfrm>
           <a:prstGeom prst="rect">
@@ -6203,40 +6241,54 @@
       </p:sp>
       <p:sp>
         <p:nvSpPr>
-          <p:cNvPr id="26" name="Text 24"/>
-          <p:cNvSpPr txBox="1"/>
-          <p:nvPr/>
-        </p:nvSpPr>
-        <p:spPr>
-          <a:xfrm>
-            <a:off x="548640" y="5532120"/>
-            <a:ext cx="7772400" cy="502920"/>
-          </a:xfrm>
-          <a:prstGeom prst="rect">
-            <a:avLst/>
-          </a:prstGeom>
-          <a:noFill/>
-          <a:ln/>
-        </p:spPr>
-        <p:txBody>
-          <a:bodyPr wrap="square" lIns="0" tIns="0" rIns="0" bIns="0" rtlCol="0" anchor="ctr"/>
-          <a:lstStyle/>
-          <a:p>
-            <a:pPr indent="0" marL="0">
-              <a:buNone/>
-            </a:pPr>
-            <a:r>
-              <a:rPr lang="en-US" sz="2600" b="1" dirty="0">
+          <p:cNvPr id="27" name="Text 25"/>
+          <p:cNvSpPr txBox="1"/>
+          <p:nvPr/>
+        </p:nvSpPr>
+        <p:spPr>
+          <a:xfrm>
+            <a:off x="548640" y="5486400"/>
+            <a:ext cx="11094415" cy="685800"/>
+          </a:xfrm>
+          <a:prstGeom prst="rect">
+            <a:avLst/>
+          </a:prstGeom>
+          <a:noFill/>
+          <a:ln/>
+        </p:spPr>
+        <p:txBody>
+          <a:bodyPr wrap="square" lIns="0" tIns="0" rIns="0" bIns="0" rtlCol="0" anchor="t"/>
+          <a:lstStyle/>
+          <a:p>
+            <a:pPr indent="0" marL="0">
+              <a:buNone/>
+            </a:pPr>
+            <a:r>
+              <a:rPr lang="en-US" sz="1500" b="1" dirty="0">
                 <a:solidFill>
                   <a:srgbClr val="F3F0E8"/>
                 </a:solidFill>
-                <a:latin typeface="Century Gothic" pitchFamily="34" charset="0"/>
-                <a:ea typeface="Century Gothic" pitchFamily="34" charset="-122"/>
-                <a:cs typeface="Century Gothic" pitchFamily="34" charset="-120"/>
-              </a:rPr>
-              <a:t>Spec in. Strategy out. Never a forfeit.</a:t>
-            </a:r>
-            <a:endParaRPr lang="en-US" sz="2600" dirty="0"/>
+                <a:latin typeface="Calibri" pitchFamily="34" charset="0"/>
+                <a:ea typeface="Calibri" pitchFamily="34" charset="-122"/>
+                <a:cs typeface="Calibri" pitchFamily="34" charset="-120"/>
+              </a:rPr>
+              <a:t>141 seconds, 1.8 cents, one champion.  </a:t>
+            </a:r>
+            <a:pPr indent="0" marL="0">
+              <a:buNone/>
+            </a:pPr>
+            <a:r>
+              <a:rPr lang="en-US" sz="1500" dirty="0">
+                <a:solidFill>
+                  <a:srgbClr val="AEB6C2"/>
+                </a:solidFill>
+                <a:latin typeface="Calibri" pitchFamily="34" charset="0"/>
+                <a:ea typeface="Calibri" pitchFamily="34" charset="-122"/>
+                <a:cs typeface="Calibri" pitchFamily="34" charset="-120"/>
+              </a:rPr>
+              <a:t>A real task-A run in the evaluation’s container: drafts written, the simulator checked against the spec and repaired, drafts ranked by self-play, a challenger tried, the champion delivered well before the deadline.</a:t>
+            </a:r>
+            <a:endParaRPr lang="en-US" sz="1500" dirty="0"/>
           </a:p>
         </p:txBody>
       </p:sp>

</xml_diff>

<commit_message>
pitch: separate thank-you slide (cover style) at the end; slide 5 keeps the run timeline
Co-Authored-By: Claude Opus 5.5 (1M context) <noreply@anthropic.com>
</commit_message>
<xml_diff>
--- a/docs/presentation/pitch.pptx
+++ b/docs/presentation/pitch.pptx
@@ -10,9 +10,10 @@
     <p:sldId id="258" r:id="rId4"/>
     <p:sldId id="259" r:id="rId5"/>
     <p:sldId id="260" r:id="rId6"/>
+    <p:sldId id="261" r:id="rId7"/>
   </p:sldIdLst>
   <p:notesMasterIdLst>
-    <p:notesMasterId r:id="rId7"/>
+    <p:notesMasterId r:id="rId8"/>
   </p:notesMasterIdLst>
   <p:sldSz cx="12192000" cy="6858000"/>
   <p:notesSz cx="6858000" cy="12192000"/>
@@ -111,21 +112,22 @@
   <p:extLst>
     <p:ext uri="{521415D9-36F7-43E2-AB2F-B90AF26B5E84}">
       <p14:sectionLst xmlns:p14="http://schemas.microsoft.com/office/powerpoint/2010/main">
-        <p14:section name="Why" id="{f85089ea-264a-3109-bb17-6894e7afe29c}">
+        <p14:section name="Why" id="{b88dafbd-42bd-a562-3788-c26e2fb5fc54}">
           <p14:sldIdLst>
             <p14:sldId id="256"/>
             <p14:sldId id="257"/>
           </p14:sldIdLst>
         </p14:section>
-        <p14:section name="How" id="{609ec389-1869-694f-34c6-4912f0023d94}">
+        <p14:section name="How" id="{a0591469-8cba-75c1-4692-f122dc956f41}">
           <p14:sldIdLst>
             <p14:sldId id="258"/>
             <p14:sldId id="259"/>
           </p14:sldIdLst>
         </p14:section>
-        <p14:section name="Close" id="{8c712ab8-9c7f-5751-547f-8cac3d7cdb1d}">
+        <p14:section name="Close" id="{529280ff-cce2-4c25-6727-0740fd989de3}">
           <p14:sldIdLst>
             <p14:sldId id="260"/>
+            <p14:sldId id="261"/>
           </p14:sldIdLst>
         </p14:section>
       </p14:sectionLst>
@@ -884,7 +886,7 @@
           <a:p>
             <a:r>
               <a:rPr lang="en-US" dirty="0"/>
-              <a:t>(2:15–3:00) To close, this is what one real run looks like, recorded in the evaluation’s Docker container on the task-A budget. After 24 seconds the first valid draft leads. At 35 seconds the simulator fails a worked example from the spec, so it is not trusted; at 68 it is repaired and passes. Then the drafts play each other and get ranked, an improvement round adds a challenger, and at 141 of 180 seconds the champion is delivered, for 1.8 of 3 cents. Every step is checked by plain code, and the file on disk is a valid strategy at every second. Spec in, strategy out, never a forfeit. Thank you for listening!</a:t>
+              <a:t>(2:15–2:55) To close, this is what one real run looks like, recorded in the evaluation’s Docker container on the task-A budget. After 24 seconds the first valid draft leads. At 35 seconds the simulator fails a worked example from the spec, so it is not trusted; at 68 it is repaired and passes. Then the drafts play each other and get ranked, an improvement round adds a challenger, and at 141 of 180 seconds the champion is delivered, for 1.8 of 3 cents. Every step is checked by plain code, and the file on disk is a valid strategy at every second. Spec in, strategy out, never a forfeit.</a:t>
             </a:r>
             <a:endParaRPr lang="en-US" dirty="0"/>
           </a:p>
@@ -908,6 +910,94 @@
             <a:fld id="{F7021451-1387-4CA6-816F-3879F97B5CBC}" type="slidenum">
               <a:rPr lang="en-US"/>
               <a:t>5</a:t>
+            </a:fld>
+            <a:endParaRPr lang="en-US"/>
+          </a:p>
+        </p:txBody>
+      </p:sp>
+    </p:spTree>
+    <p:extLst>
+      <p:ext uri="{BB962C8B-B14F-4D97-AF65-F5344CB8AC3E}">
+        <p14:creationId xmlns:p14="http://schemas.microsoft.com/office/powerpoint/2010/main" val="1024086991"/>
+      </p:ext>
+    </p:extLst>
+  </p:cSld>
+  <p:clrMapOvr>
+    <a:masterClrMapping/>
+  </p:clrMapOvr>
+</p:notes>
+</file>
+
+<file path=ppt/notesSlides/notesSlide6.xml><?xml version="1.0" encoding="utf-8"?>
+<p:notes xmlns:a="http://schemas.openxmlformats.org/drawingml/2006/main" xmlns:r="http://schemas.openxmlformats.org/officeDocument/2006/relationships" xmlns:p="http://schemas.openxmlformats.org/presentationml/2006/main">
+  <p:cSld>
+    <p:spTree>
+      <p:nvGrpSpPr>
+        <p:cNvPr id="1" name=""/>
+        <p:cNvGrpSpPr/>
+        <p:nvPr/>
+      </p:nvGrpSpPr>
+      <p:grpSpPr>
+        <a:xfrm>
+          <a:off x="0" y="0"/>
+          <a:ext cx="0" cy="0"/>
+          <a:chOff x="0" y="0"/>
+          <a:chExt cx="0" cy="0"/>
+        </a:xfrm>
+      </p:grpSpPr>
+      <p:sp>
+        <p:nvSpPr>
+          <p:cNvPr id="2" name="Slide Image Placeholder 1"/>
+          <p:cNvSpPr>
+            <a:spLocks noGrp="1" noRot="1" noChangeAspect="1"/>
+          </p:cNvSpPr>
+          <p:nvPr>
+            <p:ph type="sldImg"/>
+          </p:nvPr>
+        </p:nvSpPr>
+        <p:spPr/>
+      </p:sp>
+      <p:sp>
+        <p:nvSpPr>
+          <p:cNvPr id="3" name="Notes Placeholder 2"/>
+          <p:cNvSpPr>
+            <a:spLocks noGrp="1"/>
+          </p:cNvSpPr>
+          <p:nvPr>
+            <p:ph type="body" idx="1"/>
+          </p:nvPr>
+        </p:nvSpPr>
+        <p:spPr/>
+        <p:txBody>
+          <a:bodyPr/>
+          <a:lstStyle/>
+          <a:p>
+            <a:r>
+              <a:rPr lang="en-US" dirty="0"/>
+              <a:t>(2:55–3:00) Thank you for listening! We are happy to take questions.</a:t>
+            </a:r>
+            <a:endParaRPr lang="en-US" dirty="0"/>
+          </a:p>
+        </p:txBody>
+      </p:sp>
+      <p:sp>
+        <p:nvSpPr>
+          <p:cNvPr id="4" name="Slide Number Placeholder 3"/>
+          <p:cNvSpPr>
+            <a:spLocks noGrp="1"/>
+          </p:cNvSpPr>
+          <p:nvPr>
+            <p:ph type="sldNum" sz="quarter" idx="10"/>
+          </p:nvPr>
+        </p:nvSpPr>
+        <p:spPr/>
+        <p:txBody>
+          <a:bodyPr/>
+          <a:lstStyle/>
+          <a:p>
+            <a:fld id="{F7021451-1387-4CA6-816F-3879F97B5CBC}" type="slidenum">
+              <a:rPr lang="en-US"/>
+              <a:t>6</a:t>
             </a:fld>
             <a:endParaRPr lang="en-US"/>
           </a:p>
@@ -5452,52 +5542,13 @@
       </p:sp>
       <p:sp>
         <p:nvSpPr>
-          <p:cNvPr id="4" name="Text 2"/>
-          <p:cNvSpPr txBox="1"/>
-          <p:nvPr/>
-        </p:nvSpPr>
-        <p:spPr>
-          <a:xfrm>
-            <a:off x="548640" y="1481328"/>
-            <a:ext cx="8229600" cy="502920"/>
-          </a:xfrm>
-          <a:prstGeom prst="rect">
-            <a:avLst/>
-          </a:prstGeom>
-          <a:noFill/>
-          <a:ln/>
-        </p:spPr>
-        <p:txBody>
-          <a:bodyPr wrap="square" lIns="0" tIns="0" rIns="0" bIns="0" rtlCol="0" anchor="ctr"/>
-          <a:lstStyle/>
-          <a:p>
-            <a:pPr indent="0" marL="0">
-              <a:buNone/>
-            </a:pPr>
-            <a:r>
-              <a:rPr lang="en-US" sz="2600" b="1" dirty="0">
-                <a:solidFill>
-                  <a:srgbClr val="FF7A33"/>
-                </a:solidFill>
-                <a:latin typeface="Century Gothic" pitchFamily="34" charset="0"/>
-                <a:ea typeface="Century Gothic" pitchFamily="34" charset="-122"/>
-                <a:cs typeface="Century Gothic" pitchFamily="34" charset="-120"/>
-              </a:rPr>
-              <a:t>Thank you for listening!</a:t>
-            </a:r>
-            <a:endParaRPr lang="en-US" sz="2600" dirty="0"/>
-          </a:p>
-        </p:txBody>
-      </p:sp>
-      <p:sp>
-        <p:nvSpPr>
-          <p:cNvPr id="5" name="axis"/>
-          <p:cNvSpPr/>
-          <p:nvPr/>
-        </p:nvSpPr>
-        <p:spPr>
-          <a:xfrm>
-            <a:off x="822960" y="3611880"/>
+          <p:cNvPr id="4" name="axis"/>
+          <p:cNvSpPr/>
+          <p:nvPr/>
+        </p:nvSpPr>
+        <p:spPr>
+          <a:xfrm>
+            <a:off x="822960" y="3429000"/>
             <a:ext cx="10515600" cy="91440"/>
           </a:xfrm>
           <a:prstGeom prst="roundRect">
@@ -5518,13 +5569,13 @@
       </p:sp>
       <p:sp>
         <p:nvSpPr>
-          <p:cNvPr id="6" name="progress"/>
-          <p:cNvSpPr/>
-          <p:nvPr/>
-        </p:nvSpPr>
-        <p:spPr>
-          <a:xfrm>
-            <a:off x="822960" y="3611880"/>
+          <p:cNvPr id="5" name="progress"/>
+          <p:cNvSpPr/>
+          <p:nvPr/>
+        </p:nvSpPr>
+        <p:spPr>
+          <a:xfrm>
+            <a:off x="822960" y="3429000"/>
             <a:ext cx="8237220" cy="91440"/>
           </a:xfrm>
           <a:prstGeom prst="roundRect">
@@ -5545,13 +5596,13 @@
       </p:sp>
       <p:sp>
         <p:nvSpPr>
-          <p:cNvPr id="7" name="Text 5"/>
+          <p:cNvPr id="6" name="Text 4"/>
           <p:cNvSpPr txBox="1"/>
           <p:nvPr/>
         </p:nvSpPr>
         <p:spPr>
           <a:xfrm>
-            <a:off x="548640" y="3840480"/>
+            <a:off x="548640" y="3657600"/>
             <a:ext cx="548640" cy="274320"/>
           </a:xfrm>
           <a:prstGeom prst="rect">
@@ -5584,13 +5635,13 @@
       </p:sp>
       <p:sp>
         <p:nvSpPr>
-          <p:cNvPr id="8" name="Text 6"/>
+          <p:cNvPr id="7" name="Text 5"/>
           <p:cNvSpPr txBox="1"/>
           <p:nvPr/>
         </p:nvSpPr>
         <p:spPr>
           <a:xfrm>
-            <a:off x="9692640" y="3840480"/>
+            <a:off x="9692640" y="3657600"/>
             <a:ext cx="1645920" cy="274320"/>
           </a:xfrm>
           <a:prstGeom prst="rect">
@@ -5623,13 +5674,13 @@
       </p:sp>
       <p:sp>
         <p:nvSpPr>
-          <p:cNvPr id="9" name="event 24"/>
-          <p:cNvSpPr/>
-          <p:nvPr/>
-        </p:nvSpPr>
-        <p:spPr>
-          <a:xfrm>
-            <a:off x="2124456" y="3557016"/>
+          <p:cNvPr id="8" name="event 24"/>
+          <p:cNvSpPr/>
+          <p:nvPr/>
+        </p:nvSpPr>
+        <p:spPr>
+          <a:xfrm>
+            <a:off x="2124456" y="3374136"/>
             <a:ext cx="201168" cy="201168"/>
           </a:xfrm>
           <a:prstGeom prst="ellipse">
@@ -5648,13 +5699,13 @@
       </p:sp>
       <p:sp>
         <p:nvSpPr>
-          <p:cNvPr id="10" name="Text 8"/>
+          <p:cNvPr id="9" name="Text 7"/>
           <p:cNvSpPr txBox="1"/>
           <p:nvPr/>
         </p:nvSpPr>
         <p:spPr>
           <a:xfrm>
-            <a:off x="2124456" y="2514600"/>
+            <a:off x="2124456" y="2331720"/>
             <a:ext cx="1097280" cy="292608"/>
           </a:xfrm>
           <a:prstGeom prst="rect">
@@ -5687,13 +5738,13 @@
       </p:sp>
       <p:sp>
         <p:nvSpPr>
-          <p:cNvPr id="11" name="Text 9"/>
+          <p:cNvPr id="10" name="Text 8"/>
           <p:cNvSpPr txBox="1"/>
           <p:nvPr/>
         </p:nvSpPr>
         <p:spPr>
           <a:xfrm>
-            <a:off x="2124456" y="2825496"/>
+            <a:off x="2124456" y="2642616"/>
             <a:ext cx="2148840" cy="548640"/>
           </a:xfrm>
           <a:prstGeom prst="rect">
@@ -5726,13 +5777,13 @@
       </p:sp>
       <p:sp>
         <p:nvSpPr>
-          <p:cNvPr id="12" name="event 35"/>
-          <p:cNvSpPr/>
-          <p:nvPr/>
-        </p:nvSpPr>
-        <p:spPr>
-          <a:xfrm>
-            <a:off x="2767076" y="3557016"/>
+          <p:cNvPr id="11" name="event 35"/>
+          <p:cNvSpPr/>
+          <p:nvPr/>
+        </p:nvSpPr>
+        <p:spPr>
+          <a:xfrm>
+            <a:off x="2767076" y="3374136"/>
             <a:ext cx="201168" cy="201168"/>
           </a:xfrm>
           <a:prstGeom prst="ellipse">
@@ -5751,13 +5802,13 @@
       </p:sp>
       <p:sp>
         <p:nvSpPr>
-          <p:cNvPr id="13" name="Text 11"/>
+          <p:cNvPr id="12" name="Text 10"/>
           <p:cNvSpPr txBox="1"/>
           <p:nvPr/>
         </p:nvSpPr>
         <p:spPr>
           <a:xfrm>
-            <a:off x="2767076" y="4160520"/>
+            <a:off x="2767076" y="3977640"/>
             <a:ext cx="1097280" cy="292608"/>
           </a:xfrm>
           <a:prstGeom prst="rect">
@@ -5790,13 +5841,13 @@
       </p:sp>
       <p:sp>
         <p:nvSpPr>
-          <p:cNvPr id="14" name="Text 12"/>
+          <p:cNvPr id="13" name="Text 11"/>
           <p:cNvSpPr txBox="1"/>
           <p:nvPr/>
         </p:nvSpPr>
         <p:spPr>
           <a:xfrm>
-            <a:off x="2767076" y="4471416"/>
+            <a:off x="2767076" y="4288536"/>
             <a:ext cx="2148840" cy="548640"/>
           </a:xfrm>
           <a:prstGeom prst="rect">
@@ -5829,13 +5880,13 @@
       </p:sp>
       <p:sp>
         <p:nvSpPr>
-          <p:cNvPr id="15" name="event 68"/>
-          <p:cNvSpPr/>
-          <p:nvPr/>
-        </p:nvSpPr>
-        <p:spPr>
-          <a:xfrm>
-            <a:off x="4694936" y="3557016"/>
+          <p:cNvPr id="14" name="event 68"/>
+          <p:cNvSpPr/>
+          <p:nvPr/>
+        </p:nvSpPr>
+        <p:spPr>
+          <a:xfrm>
+            <a:off x="4694936" y="3374136"/>
             <a:ext cx="201168" cy="201168"/>
           </a:xfrm>
           <a:prstGeom prst="ellipse">
@@ -5854,13 +5905,13 @@
       </p:sp>
       <p:sp>
         <p:nvSpPr>
-          <p:cNvPr id="16" name="Text 14"/>
+          <p:cNvPr id="15" name="Text 13"/>
           <p:cNvSpPr txBox="1"/>
           <p:nvPr/>
         </p:nvSpPr>
         <p:spPr>
           <a:xfrm>
-            <a:off x="4694936" y="2514600"/>
+            <a:off x="4694936" y="2331720"/>
             <a:ext cx="1097280" cy="292608"/>
           </a:xfrm>
           <a:prstGeom prst="rect">
@@ -5893,13 +5944,13 @@
       </p:sp>
       <p:sp>
         <p:nvSpPr>
-          <p:cNvPr id="17" name="Text 15"/>
+          <p:cNvPr id="16" name="Text 14"/>
           <p:cNvSpPr txBox="1"/>
           <p:nvPr/>
         </p:nvSpPr>
         <p:spPr>
           <a:xfrm>
-            <a:off x="4694936" y="2825496"/>
+            <a:off x="4694936" y="2642616"/>
             <a:ext cx="2148840" cy="548640"/>
           </a:xfrm>
           <a:prstGeom prst="rect">
@@ -5932,13 +5983,13 @@
       </p:sp>
       <p:sp>
         <p:nvSpPr>
-          <p:cNvPr id="18" name="event 98"/>
-          <p:cNvSpPr/>
-          <p:nvPr/>
-        </p:nvSpPr>
-        <p:spPr>
-          <a:xfrm>
-            <a:off x="6447536" y="3557016"/>
+          <p:cNvPr id="17" name="event 98"/>
+          <p:cNvSpPr/>
+          <p:nvPr/>
+        </p:nvSpPr>
+        <p:spPr>
+          <a:xfrm>
+            <a:off x="6447536" y="3374136"/>
             <a:ext cx="201168" cy="201168"/>
           </a:xfrm>
           <a:prstGeom prst="ellipse">
@@ -5957,13 +6008,13 @@
       </p:sp>
       <p:sp>
         <p:nvSpPr>
-          <p:cNvPr id="19" name="Text 17"/>
+          <p:cNvPr id="18" name="Text 16"/>
           <p:cNvSpPr txBox="1"/>
           <p:nvPr/>
         </p:nvSpPr>
         <p:spPr>
           <a:xfrm>
-            <a:off x="6447536" y="4160520"/>
+            <a:off x="6447536" y="3977640"/>
             <a:ext cx="1097280" cy="292608"/>
           </a:xfrm>
           <a:prstGeom prst="rect">
@@ -5996,13 +6047,13 @@
       </p:sp>
       <p:sp>
         <p:nvSpPr>
-          <p:cNvPr id="20" name="Text 18"/>
+          <p:cNvPr id="19" name="Text 17"/>
           <p:cNvSpPr txBox="1"/>
           <p:nvPr/>
         </p:nvSpPr>
         <p:spPr>
           <a:xfrm>
-            <a:off x="6447536" y="4471416"/>
+            <a:off x="6447536" y="4288536"/>
             <a:ext cx="2148840" cy="548640"/>
           </a:xfrm>
           <a:prstGeom prst="rect">
@@ -6035,13 +6086,13 @@
       </p:sp>
       <p:sp>
         <p:nvSpPr>
-          <p:cNvPr id="21" name="event 133"/>
-          <p:cNvSpPr/>
-          <p:nvPr/>
-        </p:nvSpPr>
-        <p:spPr>
-          <a:xfrm>
-            <a:off x="8492236" y="3557016"/>
+          <p:cNvPr id="20" name="event 133"/>
+          <p:cNvSpPr/>
+          <p:nvPr/>
+        </p:nvSpPr>
+        <p:spPr>
+          <a:xfrm>
+            <a:off x="8492236" y="3374136"/>
             <a:ext cx="201168" cy="201168"/>
           </a:xfrm>
           <a:prstGeom prst="ellipse">
@@ -6060,13 +6111,13 @@
       </p:sp>
       <p:sp>
         <p:nvSpPr>
-          <p:cNvPr id="22" name="Text 20"/>
+          <p:cNvPr id="21" name="Text 19"/>
           <p:cNvSpPr txBox="1"/>
           <p:nvPr/>
         </p:nvSpPr>
         <p:spPr>
           <a:xfrm>
-            <a:off x="8492236" y="2514600"/>
+            <a:off x="8492236" y="2331720"/>
             <a:ext cx="1097280" cy="292608"/>
           </a:xfrm>
           <a:prstGeom prst="rect">
@@ -6099,13 +6150,13 @@
       </p:sp>
       <p:sp>
         <p:nvSpPr>
-          <p:cNvPr id="23" name="Text 21"/>
+          <p:cNvPr id="22" name="Text 20"/>
           <p:cNvSpPr txBox="1"/>
           <p:nvPr/>
         </p:nvSpPr>
         <p:spPr>
           <a:xfrm>
-            <a:off x="8492236" y="2825496"/>
+            <a:off x="8492236" y="2642616"/>
             <a:ext cx="2148840" cy="548640"/>
           </a:xfrm>
           <a:prstGeom prst="rect">
@@ -6138,13 +6189,13 @@
       </p:sp>
       <p:sp>
         <p:nvSpPr>
-          <p:cNvPr id="24" name="event 141"/>
-          <p:cNvSpPr/>
-          <p:nvPr/>
-        </p:nvSpPr>
-        <p:spPr>
-          <a:xfrm>
-            <a:off x="8959596" y="3557016"/>
+          <p:cNvPr id="23" name="event 141"/>
+          <p:cNvSpPr/>
+          <p:nvPr/>
+        </p:nvSpPr>
+        <p:spPr>
+          <a:xfrm>
+            <a:off x="8959596" y="3374136"/>
             <a:ext cx="201168" cy="201168"/>
           </a:xfrm>
           <a:prstGeom prst="ellipse">
@@ -6163,13 +6214,13 @@
       </p:sp>
       <p:sp>
         <p:nvSpPr>
-          <p:cNvPr id="25" name="Text 23"/>
+          <p:cNvPr id="24" name="Text 22"/>
           <p:cNvSpPr txBox="1"/>
           <p:nvPr/>
         </p:nvSpPr>
         <p:spPr>
           <a:xfrm>
-            <a:off x="8959596" y="4160520"/>
+            <a:off x="8959596" y="3977640"/>
             <a:ext cx="1097280" cy="292608"/>
           </a:xfrm>
           <a:prstGeom prst="rect">
@@ -6202,13 +6253,13 @@
       </p:sp>
       <p:sp>
         <p:nvSpPr>
-          <p:cNvPr id="26" name="Text 24"/>
+          <p:cNvPr id="25" name="Text 23"/>
           <p:cNvSpPr txBox="1"/>
           <p:nvPr/>
         </p:nvSpPr>
         <p:spPr>
           <a:xfrm>
-            <a:off x="8959596" y="4471416"/>
+            <a:off x="8959596" y="4288536"/>
             <a:ext cx="2148840" cy="548640"/>
           </a:xfrm>
           <a:prstGeom prst="rect">
@@ -6241,7 +6292,7 @@
       </p:sp>
       <p:sp>
         <p:nvSpPr>
-          <p:cNvPr id="27" name="Text 25"/>
+          <p:cNvPr id="26" name="Text 24"/>
           <p:cNvSpPr txBox="1"/>
           <p:nvPr/>
         </p:nvSpPr>
@@ -6337,6 +6388,826 @@
               <a:t>5</a:t>
             </a:fld>
             <a:endParaRPr lang="en-US"/>
+          </a:p>
+        </p:txBody>
+      </p:sp>
+    </p:spTree>
+  </p:cSld>
+  <p:clrMapOvr>
+    <a:masterClrMapping/>
+  </p:clrMapOvr>
+</p:sld>
+</file>
+
+<file path=ppt/slides/slide6.xml><?xml version="1.0" encoding="utf-8"?>
+<p:sld xmlns:a="http://schemas.openxmlformats.org/drawingml/2006/main" xmlns:r="http://schemas.openxmlformats.org/officeDocument/2006/relationships" xmlns:p="http://schemas.openxmlformats.org/presentationml/2006/main">
+  <p:cSld name="Slide 6">
+    <p:spTree>
+      <p:nvGrpSpPr>
+        <p:cNvPr id="1" name=""/>
+        <p:cNvGrpSpPr/>
+        <p:nvPr/>
+      </p:nvGrpSpPr>
+      <p:grpSpPr>
+        <a:xfrm>
+          <a:off x="0" y="0"/>
+          <a:ext cx="0" cy="0"/>
+          <a:chOff x="0" y="0"/>
+          <a:chExt cx="0" cy="0"/>
+        </a:xfrm>
+      </p:grpSpPr>
+      <p:sp>
+        <p:nvSpPr>
+          <p:cNvPr id="2" name="Shape 0"/>
+          <p:cNvSpPr/>
+          <p:nvPr/>
+        </p:nvSpPr>
+        <p:spPr>
+          <a:xfrm flipV="1">
+            <a:off x="7825435" y="2459736"/>
+            <a:ext cx="907085" cy="1020470"/>
+          </a:xfrm>
+          <a:prstGeom prst="line">
+            <a:avLst/>
+          </a:prstGeom>
+          <a:noFill/>
+          <a:ln w="19050">
+            <a:solidFill>
+              <a:srgbClr val="2A313C"/>
+            </a:solidFill>
+            <a:prstDash val="solid"/>
+          </a:ln>
+        </p:spPr>
+      </p:sp>
+      <p:sp>
+        <p:nvSpPr>
+          <p:cNvPr id="3" name="Shape 1"/>
+          <p:cNvSpPr/>
+          <p:nvPr/>
+        </p:nvSpPr>
+        <p:spPr>
+          <a:xfrm>
+            <a:off x="7825435" y="3480206"/>
+            <a:ext cx="907085" cy="1020470"/>
+          </a:xfrm>
+          <a:prstGeom prst="line">
+            <a:avLst/>
+          </a:prstGeom>
+          <a:noFill/>
+          <a:ln w="19050">
+            <a:solidFill>
+              <a:srgbClr val="2A313C"/>
+            </a:solidFill>
+            <a:prstDash val="solid"/>
+          </a:ln>
+        </p:spPr>
+      </p:sp>
+      <p:sp>
+        <p:nvSpPr>
+          <p:cNvPr id="4" name="Shape 2"/>
+          <p:cNvSpPr/>
+          <p:nvPr/>
+        </p:nvSpPr>
+        <p:spPr>
+          <a:xfrm flipV="1">
+            <a:off x="8732520" y="1949501"/>
+            <a:ext cx="963778" cy="510235"/>
+          </a:xfrm>
+          <a:prstGeom prst="line">
+            <a:avLst/>
+          </a:prstGeom>
+          <a:noFill/>
+          <a:ln w="19050">
+            <a:solidFill>
+              <a:srgbClr val="2A313C"/>
+            </a:solidFill>
+            <a:prstDash val="solid"/>
+          </a:ln>
+        </p:spPr>
+      </p:sp>
+      <p:sp>
+        <p:nvSpPr>
+          <p:cNvPr id="5" name="Shape 3"/>
+          <p:cNvSpPr/>
+          <p:nvPr/>
+        </p:nvSpPr>
+        <p:spPr>
+          <a:xfrm>
+            <a:off x="8732520" y="2459736"/>
+            <a:ext cx="963778" cy="1020470"/>
+          </a:xfrm>
+          <a:prstGeom prst="line">
+            <a:avLst/>
+          </a:prstGeom>
+          <a:noFill/>
+          <a:ln w="19050">
+            <a:solidFill>
+              <a:srgbClr val="2A313C"/>
+            </a:solidFill>
+            <a:prstDash val="solid"/>
+          </a:ln>
+        </p:spPr>
+      </p:sp>
+      <p:sp>
+        <p:nvSpPr>
+          <p:cNvPr id="6" name="Shape 4"/>
+          <p:cNvSpPr/>
+          <p:nvPr/>
+        </p:nvSpPr>
+        <p:spPr>
+          <a:xfrm flipV="1">
+            <a:off x="8732520" y="3480206"/>
+            <a:ext cx="963778" cy="1020470"/>
+          </a:xfrm>
+          <a:prstGeom prst="line">
+            <a:avLst/>
+          </a:prstGeom>
+          <a:noFill/>
+          <a:ln w="19050">
+            <a:solidFill>
+              <a:srgbClr val="2A313C"/>
+            </a:solidFill>
+            <a:prstDash val="solid"/>
+          </a:ln>
+        </p:spPr>
+      </p:sp>
+      <p:sp>
+        <p:nvSpPr>
+          <p:cNvPr id="7" name="Shape 5"/>
+          <p:cNvSpPr/>
+          <p:nvPr/>
+        </p:nvSpPr>
+        <p:spPr>
+          <a:xfrm>
+            <a:off x="8732520" y="4500677"/>
+            <a:ext cx="963778" cy="510235"/>
+          </a:xfrm>
+          <a:prstGeom prst="line">
+            <a:avLst/>
+          </a:prstGeom>
+          <a:noFill/>
+          <a:ln w="19050">
+            <a:solidFill>
+              <a:srgbClr val="2A313C"/>
+            </a:solidFill>
+            <a:prstDash val="solid"/>
+          </a:ln>
+        </p:spPr>
+      </p:sp>
+      <p:sp>
+        <p:nvSpPr>
+          <p:cNvPr id="8" name="Shape 6"/>
+          <p:cNvSpPr/>
+          <p:nvPr/>
+        </p:nvSpPr>
+        <p:spPr>
+          <a:xfrm>
+            <a:off x="9696298" y="1949501"/>
+            <a:ext cx="963778" cy="737006"/>
+          </a:xfrm>
+          <a:prstGeom prst="line">
+            <a:avLst/>
+          </a:prstGeom>
+          <a:noFill/>
+          <a:ln w="19050">
+            <a:solidFill>
+              <a:srgbClr val="2A313C"/>
+            </a:solidFill>
+            <a:prstDash val="solid"/>
+          </a:ln>
+        </p:spPr>
+      </p:sp>
+      <p:sp>
+        <p:nvSpPr>
+          <p:cNvPr id="9" name="Shape 7"/>
+          <p:cNvSpPr/>
+          <p:nvPr/>
+        </p:nvSpPr>
+        <p:spPr>
+          <a:xfrm flipV="1">
+            <a:off x="9696298" y="2686507"/>
+            <a:ext cx="963778" cy="793699"/>
+          </a:xfrm>
+          <a:prstGeom prst="line">
+            <a:avLst/>
+          </a:prstGeom>
+          <a:noFill/>
+          <a:ln w="19050">
+            <a:solidFill>
+              <a:srgbClr val="2A313C"/>
+            </a:solidFill>
+            <a:prstDash val="solid"/>
+          </a:ln>
+        </p:spPr>
+      </p:sp>
+      <p:sp>
+        <p:nvSpPr>
+          <p:cNvPr id="10" name="Shape 8"/>
+          <p:cNvSpPr/>
+          <p:nvPr/>
+        </p:nvSpPr>
+        <p:spPr>
+          <a:xfrm>
+            <a:off x="9696298" y="3480206"/>
+            <a:ext cx="963778" cy="793699"/>
+          </a:xfrm>
+          <a:prstGeom prst="line">
+            <a:avLst/>
+          </a:prstGeom>
+          <a:noFill/>
+          <a:ln w="19050">
+            <a:solidFill>
+              <a:srgbClr val="2A313C"/>
+            </a:solidFill>
+            <a:prstDash val="solid"/>
+          </a:ln>
+        </p:spPr>
+      </p:sp>
+      <p:sp>
+        <p:nvSpPr>
+          <p:cNvPr id="11" name="Shape 9"/>
+          <p:cNvSpPr/>
+          <p:nvPr/>
+        </p:nvSpPr>
+        <p:spPr>
+          <a:xfrm flipV="1">
+            <a:off x="9696298" y="4273906"/>
+            <a:ext cx="963778" cy="737006"/>
+          </a:xfrm>
+          <a:prstGeom prst="line">
+            <a:avLst/>
+          </a:prstGeom>
+          <a:noFill/>
+          <a:ln w="19050">
+            <a:solidFill>
+              <a:srgbClr val="2A313C"/>
+            </a:solidFill>
+            <a:prstDash val="solid"/>
+          </a:ln>
+        </p:spPr>
+      </p:sp>
+      <p:sp>
+        <p:nvSpPr>
+          <p:cNvPr id="12" name="Shape 10"/>
+          <p:cNvSpPr/>
+          <p:nvPr/>
+        </p:nvSpPr>
+        <p:spPr>
+          <a:xfrm>
+            <a:off x="10660075" y="2686507"/>
+            <a:ext cx="566928" cy="793699"/>
+          </a:xfrm>
+          <a:prstGeom prst="line">
+            <a:avLst/>
+          </a:prstGeom>
+          <a:noFill/>
+          <a:ln w="19050">
+            <a:solidFill>
+              <a:srgbClr val="2A313C"/>
+            </a:solidFill>
+            <a:prstDash val="solid"/>
+          </a:ln>
+        </p:spPr>
+      </p:sp>
+      <p:sp>
+        <p:nvSpPr>
+          <p:cNvPr id="13" name="Shape 11"/>
+          <p:cNvSpPr/>
+          <p:nvPr/>
+        </p:nvSpPr>
+        <p:spPr>
+          <a:xfrm flipV="1">
+            <a:off x="10660075" y="3480206"/>
+            <a:ext cx="566928" cy="793699"/>
+          </a:xfrm>
+          <a:prstGeom prst="line">
+            <a:avLst/>
+          </a:prstGeom>
+          <a:noFill/>
+          <a:ln w="19050">
+            <a:solidFill>
+              <a:srgbClr val="2A313C"/>
+            </a:solidFill>
+            <a:prstDash val="solid"/>
+          </a:ln>
+        </p:spPr>
+      </p:sp>
+      <p:sp>
+        <p:nvSpPr>
+          <p:cNvPr id="14" name="Shape 12"/>
+          <p:cNvSpPr/>
+          <p:nvPr/>
+        </p:nvSpPr>
+        <p:spPr>
+          <a:xfrm>
+            <a:off x="9696298" y="1949501"/>
+            <a:ext cx="914" cy="1530706"/>
+          </a:xfrm>
+          <a:prstGeom prst="line">
+            <a:avLst/>
+          </a:prstGeom>
+          <a:noFill/>
+          <a:ln w="19050">
+            <a:solidFill>
+              <a:srgbClr val="2A313C"/>
+            </a:solidFill>
+            <a:prstDash val="solid"/>
+          </a:ln>
+        </p:spPr>
+      </p:sp>
+      <p:sp>
+        <p:nvSpPr>
+          <p:cNvPr id="15" name="Shape 13"/>
+          <p:cNvSpPr/>
+          <p:nvPr/>
+        </p:nvSpPr>
+        <p:spPr>
+          <a:xfrm flipV="1">
+            <a:off x="7825435" y="2459736"/>
+            <a:ext cx="907085" cy="1020470"/>
+          </a:xfrm>
+          <a:prstGeom prst="line">
+            <a:avLst/>
+          </a:prstGeom>
+          <a:noFill/>
+          <a:ln w="44450">
+            <a:solidFill>
+              <a:srgbClr val="FF7A33"/>
+            </a:solidFill>
+            <a:prstDash val="solid"/>
+          </a:ln>
+        </p:spPr>
+      </p:sp>
+      <p:sp>
+        <p:nvSpPr>
+          <p:cNvPr id="16" name="Shape 14"/>
+          <p:cNvSpPr/>
+          <p:nvPr/>
+        </p:nvSpPr>
+        <p:spPr>
+          <a:xfrm>
+            <a:off x="8732520" y="2459736"/>
+            <a:ext cx="963778" cy="1020470"/>
+          </a:xfrm>
+          <a:prstGeom prst="line">
+            <a:avLst/>
+          </a:prstGeom>
+          <a:noFill/>
+          <a:ln w="44450">
+            <a:solidFill>
+              <a:srgbClr val="FF7A33"/>
+            </a:solidFill>
+            <a:prstDash val="solid"/>
+          </a:ln>
+        </p:spPr>
+      </p:sp>
+      <p:sp>
+        <p:nvSpPr>
+          <p:cNvPr id="17" name="Shape 15"/>
+          <p:cNvSpPr/>
+          <p:nvPr/>
+        </p:nvSpPr>
+        <p:spPr>
+          <a:xfrm>
+            <a:off x="9696298" y="3480206"/>
+            <a:ext cx="963778" cy="793699"/>
+          </a:xfrm>
+          <a:prstGeom prst="line">
+            <a:avLst/>
+          </a:prstGeom>
+          <a:noFill/>
+          <a:ln w="44450">
+            <a:solidFill>
+              <a:srgbClr val="FF7A33"/>
+            </a:solidFill>
+            <a:prstDash val="solid"/>
+          </a:ln>
+        </p:spPr>
+      </p:sp>
+      <p:sp>
+        <p:nvSpPr>
+          <p:cNvPr id="18" name="Shape 16"/>
+          <p:cNvSpPr/>
+          <p:nvPr/>
+        </p:nvSpPr>
+        <p:spPr>
+          <a:xfrm flipV="1">
+            <a:off x="10660075" y="3480206"/>
+            <a:ext cx="566928" cy="793699"/>
+          </a:xfrm>
+          <a:prstGeom prst="line">
+            <a:avLst/>
+          </a:prstGeom>
+          <a:noFill/>
+          <a:ln w="44450">
+            <a:solidFill>
+              <a:srgbClr val="FF7A33"/>
+            </a:solidFill>
+            <a:prstDash val="solid"/>
+          </a:ln>
+        </p:spPr>
+      </p:sp>
+      <p:sp>
+        <p:nvSpPr>
+          <p:cNvPr id="19" name="node A"/>
+          <p:cNvSpPr/>
+          <p:nvPr/>
+        </p:nvSpPr>
+        <p:spPr>
+          <a:xfrm>
+            <a:off x="7669987" y="3324758"/>
+            <a:ext cx="310896" cy="310896"/>
+          </a:xfrm>
+          <a:prstGeom prst="ellipse">
+            <a:avLst/>
+          </a:prstGeom>
+          <a:solidFill>
+            <a:srgbClr val="0F1218"/>
+          </a:solidFill>
+          <a:ln w="38100">
+            <a:solidFill>
+              <a:srgbClr val="FF7A33"/>
+            </a:solidFill>
+            <a:prstDash val="solid"/>
+          </a:ln>
+        </p:spPr>
+      </p:sp>
+      <p:sp>
+        <p:nvSpPr>
+          <p:cNvPr id="20" name="node B"/>
+          <p:cNvSpPr/>
+          <p:nvPr/>
+        </p:nvSpPr>
+        <p:spPr>
+          <a:xfrm>
+            <a:off x="8641080" y="2368296"/>
+            <a:ext cx="182880" cy="182880"/>
+          </a:xfrm>
+          <a:prstGeom prst="ellipse">
+            <a:avLst/>
+          </a:prstGeom>
+          <a:solidFill>
+            <a:srgbClr val="FF7A33"/>
+          </a:solidFill>
+          <a:ln w="19050">
+            <a:solidFill>
+              <a:srgbClr val="FF7A33"/>
+            </a:solidFill>
+            <a:prstDash val="solid"/>
+          </a:ln>
+        </p:spPr>
+      </p:sp>
+      <p:sp>
+        <p:nvSpPr>
+          <p:cNvPr id="21" name="node C"/>
+          <p:cNvSpPr/>
+          <p:nvPr/>
+        </p:nvSpPr>
+        <p:spPr>
+          <a:xfrm>
+            <a:off x="8641080" y="4409237"/>
+            <a:ext cx="182880" cy="182880"/>
+          </a:xfrm>
+          <a:prstGeom prst="ellipse">
+            <a:avLst/>
+          </a:prstGeom>
+          <a:solidFill>
+            <a:srgbClr val="1B2029"/>
+          </a:solidFill>
+          <a:ln w="19050">
+            <a:solidFill>
+              <a:srgbClr val="3A4350"/>
+            </a:solidFill>
+            <a:prstDash val="solid"/>
+          </a:ln>
+        </p:spPr>
+      </p:sp>
+      <p:sp>
+        <p:nvSpPr>
+          <p:cNvPr id="22" name="node D"/>
+          <p:cNvSpPr/>
+          <p:nvPr/>
+        </p:nvSpPr>
+        <p:spPr>
+          <a:xfrm>
+            <a:off x="9604858" y="1858061"/>
+            <a:ext cx="182880" cy="182880"/>
+          </a:xfrm>
+          <a:prstGeom prst="ellipse">
+            <a:avLst/>
+          </a:prstGeom>
+          <a:solidFill>
+            <a:srgbClr val="1B2029"/>
+          </a:solidFill>
+          <a:ln w="19050">
+            <a:solidFill>
+              <a:srgbClr val="3A4350"/>
+            </a:solidFill>
+            <a:prstDash val="solid"/>
+          </a:ln>
+        </p:spPr>
+      </p:sp>
+      <p:sp>
+        <p:nvSpPr>
+          <p:cNvPr id="23" name="node E"/>
+          <p:cNvSpPr/>
+          <p:nvPr/>
+        </p:nvSpPr>
+        <p:spPr>
+          <a:xfrm>
+            <a:off x="9604858" y="3388766"/>
+            <a:ext cx="182880" cy="182880"/>
+          </a:xfrm>
+          <a:prstGeom prst="ellipse">
+            <a:avLst/>
+          </a:prstGeom>
+          <a:solidFill>
+            <a:srgbClr val="FF7A33"/>
+          </a:solidFill>
+          <a:ln w="19050">
+            <a:solidFill>
+              <a:srgbClr val="FF7A33"/>
+            </a:solidFill>
+            <a:prstDash val="solid"/>
+          </a:ln>
+        </p:spPr>
+      </p:sp>
+      <p:sp>
+        <p:nvSpPr>
+          <p:cNvPr id="24" name="node F"/>
+          <p:cNvSpPr/>
+          <p:nvPr/>
+        </p:nvSpPr>
+        <p:spPr>
+          <a:xfrm>
+            <a:off x="9604858" y="4919472"/>
+            <a:ext cx="182880" cy="182880"/>
+          </a:xfrm>
+          <a:prstGeom prst="ellipse">
+            <a:avLst/>
+          </a:prstGeom>
+          <a:solidFill>
+            <a:srgbClr val="1B2029"/>
+          </a:solidFill>
+          <a:ln w="19050">
+            <a:solidFill>
+              <a:srgbClr val="3A4350"/>
+            </a:solidFill>
+            <a:prstDash val="solid"/>
+          </a:ln>
+        </p:spPr>
+      </p:sp>
+      <p:sp>
+        <p:nvSpPr>
+          <p:cNvPr id="25" name="node G"/>
+          <p:cNvSpPr/>
+          <p:nvPr/>
+        </p:nvSpPr>
+        <p:spPr>
+          <a:xfrm>
+            <a:off x="10568635" y="2595067"/>
+            <a:ext cx="182880" cy="182880"/>
+          </a:xfrm>
+          <a:prstGeom prst="ellipse">
+            <a:avLst/>
+          </a:prstGeom>
+          <a:solidFill>
+            <a:srgbClr val="1B2029"/>
+          </a:solidFill>
+          <a:ln w="19050">
+            <a:solidFill>
+              <a:srgbClr val="3A4350"/>
+            </a:solidFill>
+            <a:prstDash val="solid"/>
+          </a:ln>
+        </p:spPr>
+      </p:sp>
+      <p:sp>
+        <p:nvSpPr>
+          <p:cNvPr id="26" name="node H"/>
+          <p:cNvSpPr/>
+          <p:nvPr/>
+        </p:nvSpPr>
+        <p:spPr>
+          <a:xfrm>
+            <a:off x="10568635" y="4182466"/>
+            <a:ext cx="182880" cy="182880"/>
+          </a:xfrm>
+          <a:prstGeom prst="ellipse">
+            <a:avLst/>
+          </a:prstGeom>
+          <a:solidFill>
+            <a:srgbClr val="FF7A33"/>
+          </a:solidFill>
+          <a:ln w="19050">
+            <a:solidFill>
+              <a:srgbClr val="FF7A33"/>
+            </a:solidFill>
+            <a:prstDash val="solid"/>
+          </a:ln>
+        </p:spPr>
+      </p:sp>
+      <p:sp>
+        <p:nvSpPr>
+          <p:cNvPr id="27" name="node I"/>
+          <p:cNvSpPr/>
+          <p:nvPr/>
+        </p:nvSpPr>
+        <p:spPr>
+          <a:xfrm>
+            <a:off x="11071555" y="3324758"/>
+            <a:ext cx="310896" cy="310896"/>
+          </a:xfrm>
+          <a:prstGeom prst="ellipse">
+            <a:avLst/>
+          </a:prstGeom>
+          <a:solidFill>
+            <a:srgbClr val="0F1218"/>
+          </a:solidFill>
+          <a:ln w="38100">
+            <a:solidFill>
+              <a:srgbClr val="7FAEFF"/>
+            </a:solidFill>
+            <a:prstDash val="solid"/>
+          </a:ln>
+        </p:spPr>
+      </p:sp>
+      <p:sp>
+        <p:nvSpPr>
+          <p:cNvPr id="28" name="Text 26"/>
+          <p:cNvSpPr txBox="1"/>
+          <p:nvPr/>
+        </p:nvSpPr>
+        <p:spPr>
+          <a:xfrm>
+            <a:off x="548640" y="640080"/>
+            <a:ext cx="6400800" cy="320040"/>
+          </a:xfrm>
+          <a:prstGeom prst="rect">
+            <a:avLst/>
+          </a:prstGeom>
+          <a:noFill/>
+          <a:ln/>
+        </p:spPr>
+        <p:txBody>
+          <a:bodyPr wrap="square" lIns="0" tIns="0" rIns="0" bIns="0" rtlCol="0" anchor="ctr"/>
+          <a:lstStyle/>
+          <a:p>
+            <a:pPr indent="0" marL="0">
+              <a:buNone/>
+            </a:pPr>
+            <a:r>
+              <a:rPr lang="en-US" sz="1300" b="1" spc="300" kern="0" dirty="0">
+                <a:solidFill>
+                  <a:srgbClr val="FF7A33"/>
+                </a:solidFill>
+                <a:latin typeface="Consolas" pitchFamily="34" charset="0"/>
+                <a:ea typeface="Consolas" pitchFamily="34" charset="-122"/>
+                <a:cs typeface="Consolas" pitchFamily="34" charset="-120"/>
+              </a:rPr>
+              <a:t>ZENTRAL HACK 2026 · AGENT HARNESS</a:t>
+            </a:r>
+            <a:endParaRPr lang="en-US" sz="1300" dirty="0"/>
+          </a:p>
+        </p:txBody>
+      </p:sp>
+      <p:sp>
+        <p:nvSpPr>
+          <p:cNvPr id="29" name="title"/>
+          <p:cNvSpPr txBox="1"/>
+          <p:nvPr/>
+        </p:nvSpPr>
+        <p:spPr>
+          <a:xfrm>
+            <a:off x="548640" y="1828800"/>
+            <a:ext cx="6583680" cy="2194560"/>
+          </a:xfrm>
+          <a:prstGeom prst="rect">
+            <a:avLst/>
+          </a:prstGeom>
+          <a:noFill/>
+          <a:ln/>
+        </p:spPr>
+        <p:txBody>
+          <a:bodyPr wrap="square" lIns="0" tIns="0" rIns="0" bIns="0" rtlCol="0" anchor="t"/>
+          <a:lstStyle/>
+          <a:p>
+            <a:pPr indent="0" marL="0">
+              <a:lnSpc>
+                <a:spcPct val="95000"/>
+              </a:lnSpc>
+              <a:buNone/>
+            </a:pPr>
+            <a:r>
+              <a:rPr lang="en-US" sz="6000" b="1" dirty="0">
+                <a:solidFill>
+                  <a:srgbClr val="F3F0E8"/>
+                </a:solidFill>
+                <a:latin typeface="Century Gothic" pitchFamily="34" charset="0"/>
+                <a:ea typeface="Century Gothic" pitchFamily="34" charset="-122"/>
+                <a:cs typeface="Century Gothic" pitchFamily="34" charset="-120"/>
+              </a:rPr>
+              <a:t>Thank you</a:t>
+            </a:r>
+            <a:endParaRPr lang="en-US" sz="6000" dirty="0"/>
+          </a:p>
+          <a:p>
+            <a:pPr indent="0" marL="0">
+              <a:lnSpc>
+                <a:spcPct val="95000"/>
+              </a:lnSpc>
+              <a:buNone/>
+            </a:pPr>
+            <a:r>
+              <a:rPr lang="en-US" sz="6000" b="1" dirty="0">
+                <a:solidFill>
+                  <a:srgbClr val="F3F0E8"/>
+                </a:solidFill>
+                <a:latin typeface="Century Gothic" pitchFamily="34" charset="0"/>
+                <a:ea typeface="Century Gothic" pitchFamily="34" charset="-122"/>
+                <a:cs typeface="Century Gothic" pitchFamily="34" charset="-120"/>
+              </a:rPr>
+              <a:t>for listening!</a:t>
+            </a:r>
+            <a:endParaRPr lang="en-US" sz="6000" dirty="0"/>
+          </a:p>
+        </p:txBody>
+      </p:sp>
+      <p:sp>
+        <p:nvSpPr>
+          <p:cNvPr id="30" name="Text 28"/>
+          <p:cNvSpPr txBox="1"/>
+          <p:nvPr/>
+        </p:nvSpPr>
+        <p:spPr>
+          <a:xfrm>
+            <a:off x="548640" y="4160520"/>
+            <a:ext cx="6035040" cy="548640"/>
+          </a:xfrm>
+          <a:prstGeom prst="rect">
+            <a:avLst/>
+          </a:prstGeom>
+          <a:noFill/>
+          <a:ln/>
+        </p:spPr>
+        <p:txBody>
+          <a:bodyPr wrap="square" lIns="0" tIns="0" rIns="0" bIns="0" rtlCol="0" anchor="t"/>
+          <a:lstStyle/>
+          <a:p>
+            <a:pPr indent="0" marL="0">
+              <a:buNone/>
+            </a:pPr>
+            <a:r>
+              <a:rPr lang="en-US" sz="2000" dirty="0">
+                <a:solidFill>
+                  <a:srgbClr val="AEB6C2"/>
+                </a:solidFill>
+                <a:latin typeface="Calibri" pitchFamily="34" charset="0"/>
+                <a:ea typeface="Calibri" pitchFamily="34" charset="-122"/>
+                <a:cs typeface="Calibri" pitchFamily="34" charset="-120"/>
+              </a:rPr>
+              <a:t>Spec in. Strategy out. Never a forfeit.</a:t>
+            </a:r>
+            <a:endParaRPr lang="en-US" sz="2000" dirty="0"/>
+          </a:p>
+        </p:txBody>
+      </p:sp>
+      <p:sp>
+        <p:nvSpPr>
+          <p:cNvPr id="31" name="Text 29"/>
+          <p:cNvSpPr txBox="1"/>
+          <p:nvPr/>
+        </p:nvSpPr>
+        <p:spPr>
+          <a:xfrm>
+            <a:off x="548640" y="6035040"/>
+            <a:ext cx="5486400" cy="411480"/>
+          </a:xfrm>
+          <a:prstGeom prst="rect">
+            <a:avLst/>
+          </a:prstGeom>
+          <a:noFill/>
+          <a:ln/>
+        </p:spPr>
+        <p:txBody>
+          <a:bodyPr wrap="square" lIns="0" tIns="0" rIns="0" bIns="0" rtlCol="0" anchor="ctr"/>
+          <a:lstStyle/>
+          <a:p>
+            <a:pPr indent="0" marL="0">
+              <a:buNone/>
+            </a:pPr>
+            <a:r>
+              <a:rPr lang="en-US" sz="1800" b="1" dirty="0">
+                <a:solidFill>
+                  <a:srgbClr val="AEB6C2"/>
+                </a:solidFill>
+                <a:latin typeface="Century Gothic" pitchFamily="34" charset="0"/>
+                <a:ea typeface="Century Gothic" pitchFamily="34" charset="-122"/>
+                <a:cs typeface="Century Gothic" pitchFamily="34" charset="-120"/>
+              </a:rPr>
+              <a:t>Elias  ·  Isaak  ·  Timo</a:t>
+            </a:r>
+            <a:endParaRPr lang="en-US" sz="1800" dirty="0"/>
           </a:p>
         </p:txBody>
       </p:sp>

</xml_diff>

<commit_message>
pitch: insight line in plain words (everything the LLM writes is tested by running it); research number verified against the paper's abstract
Co-Authored-By: Claude Opus 5.5 (1M context) <noreply@anthropic.com>
</commit_message>
<xml_diff>
--- a/docs/presentation/pitch.pptx
+++ b/docs/presentation/pitch.pptx
@@ -112,19 +112,19 @@
   <p:extLst>
     <p:ext uri="{521415D9-36F7-43E2-AB2F-B90AF26B5E84}">
       <p14:sectionLst xmlns:p14="http://schemas.microsoft.com/office/powerpoint/2010/main">
-        <p14:section name="Why" id="{b88dafbd-42bd-a562-3788-c26e2fb5fc54}">
+        <p14:section name="Why" id="{a33a8060-a771-50cc-5879-97695addfd17}">
           <p14:sldIdLst>
             <p14:sldId id="256"/>
             <p14:sldId id="257"/>
           </p14:sldIdLst>
         </p14:section>
-        <p14:section name="How" id="{a0591469-8cba-75c1-4692-f122dc956f41}">
+        <p14:section name="How" id="{86bbaa3b-0b2a-8bd6-2539-6edfcbf000b4}">
           <p14:sldIdLst>
             <p14:sldId id="258"/>
             <p14:sldId id="259"/>
           </p14:sldIdLst>
         </p14:section>
-        <p14:section name="Close" id="{529280ff-cce2-4c25-6727-0740fd989de3}">
+        <p14:section name="Close" id="{81273153-1188-74d8-c521-ff6294541517}">
           <p14:sldIdLst>
             <p14:sldId id="260"/>
             <p14:sldId id="261"/>
@@ -622,7 +622,7 @@
           <a:p>
             <a:r>
               <a:rPr lang="en-US" dirty="0"/>
-              <a:t>(0:15–0:45) The task: a written game spec in, a strategy file out, unattended, on three budgets from three cents and three minutes up to ten dollars and thirty minutes. Only wins count. We started with research: Google DeepMind’s Code World Models: an LLM that writes a simulator plus search code matches or beats Gemini 2.5 Pro playing directly in 9 of 10 games. And our strategy may not call an LLM during the game anyway: stdlib only, no network. So the LLM is the programmer, not the player, and it never checks its own work: plain code runs everything it writes and keeps only what is proven.</a:t>
+              <a:t>(0:15–0:45) The task: a written game spec in, a strategy file out, unattended, on three budgets from three cents and three minutes up to ten dollars and thirty minutes. Only wins count. We started with research: Google DeepMind’s Code World Models: an LLM that writes a simulator plus search code matches or beats Gemini 2.5 Pro playing directly in 9 of 10 games. And our strategy may not call an LLM during the game anyway: stdlib only, no network. So the LLM is the programmer, not the player, and we never just ask it whether its code is good: our harness runs everything it writes, in real matches and against the spec’s examples, and keeps only what is proven.</a:t>
             </a:r>
             <a:endParaRPr lang="en-US" dirty="0"/>
           </a:p>
@@ -3307,7 +3307,7 @@
                 <a:ea typeface="Calibri" pitchFamily="34" charset="-122"/>
                 <a:cs typeface="Calibri" pitchFamily="34" charset="-120"/>
               </a:rPr>
-              <a:t>Plain code, not the LLM, checks everything it writes.</a:t>
+              <a:t>Everything it writes gets tested by actually running it.</a:t>
             </a:r>
             <a:endParaRPr lang="en-US" sz="1800" dirty="0"/>
           </a:p>

</xml_diff>

<commit_message>
pitch: final 5 slides (run timeline removed), notes timed to 3:00
Co-Authored-By: Claude Opus 5.5 (1M context) <noreply@anthropic.com>
</commit_message>
<xml_diff>
--- a/docs/presentation/pitch.pptx
+++ b/docs/presentation/pitch.pptx
@@ -10,10 +10,9 @@
     <p:sldId id="258" r:id="rId4"/>
     <p:sldId id="259" r:id="rId5"/>
     <p:sldId id="260" r:id="rId6"/>
-    <p:sldId id="261" r:id="rId7"/>
   </p:sldIdLst>
   <p:notesMasterIdLst>
-    <p:notesMasterId r:id="rId8"/>
+    <p:notesMasterId r:id="rId7"/>
   </p:notesMasterIdLst>
   <p:sldSz cx="12192000" cy="6858000"/>
   <p:notesSz cx="6858000" cy="12192000"/>
@@ -112,22 +111,21 @@
   <p:extLst>
     <p:ext uri="{521415D9-36F7-43E2-AB2F-B90AF26B5E84}">
       <p14:sectionLst xmlns:p14="http://schemas.microsoft.com/office/powerpoint/2010/main">
-        <p14:section name="Why" id="{a33a8060-a771-50cc-5879-97695addfd17}">
+        <p14:section name="Why" id="{fad444fd-6a84-c6da-bc78-453c70bbd2a2}">
           <p14:sldIdLst>
             <p14:sldId id="256"/>
             <p14:sldId id="257"/>
           </p14:sldIdLst>
         </p14:section>
-        <p14:section name="How" id="{86bbaa3b-0b2a-8bd6-2539-6edfcbf000b4}">
+        <p14:section name="How" id="{2763ecd0-1c8e-85ae-19cf-43f1d0a98c6c}">
           <p14:sldIdLst>
             <p14:sldId id="258"/>
             <p14:sldId id="259"/>
           </p14:sldIdLst>
         </p14:section>
-        <p14:section name="Close" id="{81273153-1188-74d8-c521-ff6294541517}">
+        <p14:section name="Close" id="{67b2863b-5ce1-367f-b18c-ab33618b20a2}">
           <p14:sldIdLst>
             <p14:sldId id="260"/>
-            <p14:sldId id="261"/>
           </p14:sldIdLst>
         </p14:section>
       </p14:sectionLst>
@@ -622,7 +620,7 @@
           <a:p>
             <a:r>
               <a:rPr lang="en-US" dirty="0"/>
-              <a:t>(0:15–0:45) The task: a written game spec in, a strategy file out, unattended, on three budgets from three cents and three minutes up to ten dollars and thirty minutes. Only wins count. We started with research: Google DeepMind’s Code World Models: an LLM that writes a simulator plus search code matches or beats Gemini 2.5 Pro playing directly in 9 of 10 games. And our strategy may not call an LLM during the game anyway: stdlib only, no network. So the LLM is the programmer, not the player, and we never just ask it whether its code is good: our harness runs everything it writes, in real matches and against the spec’s examples, and keeps only what is proven.</a:t>
+              <a:t>(0:15–0:50) The task: a written game spec in, a strategy file out, unattended, on three budgets from three cents and three minutes up to ten dollars and thirty minutes. Only wins count. We started with research: Google DeepMind’s Code World Models: an LLM that writes a simulator plus search code matches or beats Gemini 2.5 Pro playing directly in 9 of 10 games. And our strategy may not call an LLM during the game anyway: stdlib only, no network. So the LLM is the programmer, not the player, and we never just ask it whether its code is good: our harness runs everything it writes, in real matches and against the spec’s examples, and keeps only what is proven.</a:t>
             </a:r>
             <a:endParaRPr lang="en-US" dirty="0"/>
           </a:p>
@@ -710,7 +708,7 @@
           <a:p>
             <a:r>
               <a:rPr lang="en-US" dirty="0"/>
-              <a:t>(0:45–1:30) How: the LLM writes, our code verifies. The LLM writes several strategy drafts with different strategic personas and, in parallel, a simulator of the game. Nothing is trusted: the simulator must reproduce the spec’s worked examples, every draft is probed and repaired from its tracebacks. The survivors play a round robin on the simulator, both seats, many seeds, under the tournament’s real time limits. Then the strongest model writes challengers against the champion’s weak spots, and we repeat while time and money last. Around all of it, a guard: hard timer, fallback strategy, output check, so a forfeit is impossible by construction. Budget and deadline are enforced per call.</a:t>
+              <a:t>(0:50–1:45) How: the LLM writes, our code verifies. The LLM writes several strategy drafts with different strategic personas and, in parallel, a simulator of the game. Nothing is trusted: the simulator must reproduce the spec’s worked examples, every draft is probed and repaired from its tracebacks. The survivors play a round robin on the simulator, both seats, many seeds, under the tournament’s real time limits. Then the strongest model writes challengers against the champion’s weak spots, and we repeat while time and money last. Around all of it, a guard: hard timer, fallback strategy, output check, so a forfeit is impossible by construction. Budget and deadline are enforced per call.</a:t>
             </a:r>
             <a:endParaRPr lang="en-US" dirty="0"/>
           </a:p>
@@ -798,7 +796,7 @@
           <a:p>
             <a:r>
               <a:rPr lang="en-US" dirty="0"/>
-              <a:t>(1:30–2:15) We built the harness the way it works itself. Claude Code was our engineering team: parallel agents wrote and reviewed every module, held to 416 tests. Then we ran loops. Besides the two dev games we built eight games of our own with new mechanics, and kept four of them out of all tuning, as an honest exam. Each epoch: switch features off one at a time, measure, keep only what wins. After the organisers' midpoint evaluation, Timo's two experiments rejected two ideas and traced our weak runs to the simulator check, which we fixed. More than 120 measured runs, about 45 dollars in total.</a:t>
+              <a:t>(1:45–2:50) We built the harness the way it works itself. Claude Code was our engineering team: parallel agents wrote and reviewed every module, held to 416 tests. Then we ran loops. Besides the two dev games we built eight games of our own with new mechanics, and kept four of them out of all tuning, as an honest exam. Each epoch: switch features off one at a time, measure, keep only what wins. After the organisers' midpoint evaluation, Timo's two experiments rejected two ideas and traced our weak runs to the simulator check, which we fixed. More than 120 measured runs, about 45 dollars in total.</a:t>
             </a:r>
             <a:endParaRPr lang="en-US" dirty="0"/>
           </a:p>
@@ -886,7 +884,7 @@
           <a:p>
             <a:r>
               <a:rPr lang="en-US" dirty="0"/>
-              <a:t>(2:15–2:55) To close, this is what one real run looks like, recorded in the evaluation’s Docker container on the task-A budget. After 24 seconds the first valid draft leads. At 35 seconds the simulator fails a worked example from the spec, so it is not trusted; at 68 it is repaired and passes. Then the drafts play each other and get ranked, an improvement round adds a challenger, and at 141 of 180 seconds the champion is delivered, for 1.8 of 3 cents. Every step is checked by plain code, and the file on disk is a valid strategy at every second. Spec in, strategy out, never a forfeit.</a:t>
+              <a:t>(2:50–3:00) Spec in, strategy out, never a forfeit. Thank you for listening! We are happy to take questions.</a:t>
             </a:r>
             <a:endParaRPr lang="en-US" dirty="0"/>
           </a:p>
@@ -910,94 +908,6 @@
             <a:fld id="{F7021451-1387-4CA6-816F-3879F97B5CBC}" type="slidenum">
               <a:rPr lang="en-US"/>
               <a:t>5</a:t>
-            </a:fld>
-            <a:endParaRPr lang="en-US"/>
-          </a:p>
-        </p:txBody>
-      </p:sp>
-    </p:spTree>
-    <p:extLst>
-      <p:ext uri="{BB962C8B-B14F-4D97-AF65-F5344CB8AC3E}">
-        <p14:creationId xmlns:p14="http://schemas.microsoft.com/office/powerpoint/2010/main" val="1024086991"/>
-      </p:ext>
-    </p:extLst>
-  </p:cSld>
-  <p:clrMapOvr>
-    <a:masterClrMapping/>
-  </p:clrMapOvr>
-</p:notes>
-</file>
-
-<file path=ppt/notesSlides/notesSlide6.xml><?xml version="1.0" encoding="utf-8"?>
-<p:notes xmlns:a="http://schemas.openxmlformats.org/drawingml/2006/main" xmlns:r="http://schemas.openxmlformats.org/officeDocument/2006/relationships" xmlns:p="http://schemas.openxmlformats.org/presentationml/2006/main">
-  <p:cSld>
-    <p:spTree>
-      <p:nvGrpSpPr>
-        <p:cNvPr id="1" name=""/>
-        <p:cNvGrpSpPr/>
-        <p:nvPr/>
-      </p:nvGrpSpPr>
-      <p:grpSpPr>
-        <a:xfrm>
-          <a:off x="0" y="0"/>
-          <a:ext cx="0" cy="0"/>
-          <a:chOff x="0" y="0"/>
-          <a:chExt cx="0" cy="0"/>
-        </a:xfrm>
-      </p:grpSpPr>
-      <p:sp>
-        <p:nvSpPr>
-          <p:cNvPr id="2" name="Slide Image Placeholder 1"/>
-          <p:cNvSpPr>
-            <a:spLocks noGrp="1" noRot="1" noChangeAspect="1"/>
-          </p:cNvSpPr>
-          <p:nvPr>
-            <p:ph type="sldImg"/>
-          </p:nvPr>
-        </p:nvSpPr>
-        <p:spPr/>
-      </p:sp>
-      <p:sp>
-        <p:nvSpPr>
-          <p:cNvPr id="3" name="Notes Placeholder 2"/>
-          <p:cNvSpPr>
-            <a:spLocks noGrp="1"/>
-          </p:cNvSpPr>
-          <p:nvPr>
-            <p:ph type="body" idx="1"/>
-          </p:nvPr>
-        </p:nvSpPr>
-        <p:spPr/>
-        <p:txBody>
-          <a:bodyPr/>
-          <a:lstStyle/>
-          <a:p>
-            <a:r>
-              <a:rPr lang="en-US" dirty="0"/>
-              <a:t>(2:55–3:00) Thank you for listening! We are happy to take questions.</a:t>
-            </a:r>
-            <a:endParaRPr lang="en-US" dirty="0"/>
-          </a:p>
-        </p:txBody>
-      </p:sp>
-      <p:sp>
-        <p:nvSpPr>
-          <p:cNvPr id="4" name="Slide Number Placeholder 3"/>
-          <p:cNvSpPr>
-            <a:spLocks noGrp="1"/>
-          </p:cNvSpPr>
-          <p:nvPr>
-            <p:ph type="sldNum" sz="quarter" idx="10"/>
-          </p:nvPr>
-        </p:nvSpPr>
-        <p:spPr/>
-        <p:txBody>
-          <a:bodyPr/>
-          <a:lstStyle/>
-          <a:p>
-            <a:fld id="{F7021451-1387-4CA6-816F-3879F97B5CBC}" type="slidenum">
-              <a:rPr lang="en-US"/>
-              <a:t>6</a:t>
             </a:fld>
             <a:endParaRPr lang="en-US"/>
           </a:p>
@@ -5446,962 +5356,6 @@
 <file path=ppt/slides/slide5.xml><?xml version="1.0" encoding="utf-8"?>
 <p:sld xmlns:a="http://schemas.openxmlformats.org/drawingml/2006/main" xmlns:r="http://schemas.openxmlformats.org/officeDocument/2006/relationships" xmlns:p="http://schemas.openxmlformats.org/presentationml/2006/main">
   <p:cSld name="Slide 5">
-    <p:spTree>
-      <p:nvGrpSpPr>
-        <p:cNvPr id="1" name=""/>
-        <p:cNvGrpSpPr/>
-        <p:nvPr/>
-      </p:nvGrpSpPr>
-      <p:grpSpPr>
-        <a:xfrm>
-          <a:off x="0" y="0"/>
-          <a:ext cx="0" cy="0"/>
-          <a:chOff x="0" y="0"/>
-          <a:chExt cx="0" cy="0"/>
-        </a:xfrm>
-      </p:grpSpPr>
-      <p:sp>
-        <p:nvSpPr>
-          <p:cNvPr id="2" name="eyebrow"/>
-          <p:cNvSpPr txBox="1"/>
-          <p:nvPr/>
-        </p:nvSpPr>
-        <p:spPr>
-          <a:xfrm>
-            <a:off x="548640" y="384048"/>
-            <a:ext cx="7315200" cy="274320"/>
-          </a:xfrm>
-          <a:prstGeom prst="rect">
-            <a:avLst/>
-          </a:prstGeom>
-          <a:noFill/>
-          <a:ln/>
-        </p:spPr>
-        <p:txBody>
-          <a:bodyPr wrap="square" lIns="0" tIns="0" rIns="0" bIns="0" rtlCol="0" anchor="ctr"/>
-          <a:lstStyle/>
-          <a:p>
-            <a:pPr indent="0" marL="0">
-              <a:buNone/>
-            </a:pPr>
-            <a:r>
-              <a:rPr lang="en-US" sz="1200" b="1" spc="300" kern="0" dirty="0">
-                <a:solidFill>
-                  <a:srgbClr val="FF7A33"/>
-                </a:solidFill>
-                <a:latin typeface="Consolas" pitchFamily="34" charset="0"/>
-                <a:ea typeface="Consolas" pitchFamily="34" charset="-122"/>
-                <a:cs typeface="Consolas" pitchFamily="34" charset="-120"/>
-              </a:rPr>
-              <a:t>ONE REAL RUN, FROM SPEC TO STRATEGY.PY</a:t>
-            </a:r>
-            <a:endParaRPr lang="en-US" sz="1200" dirty="0"/>
-          </a:p>
-        </p:txBody>
-      </p:sp>
-      <p:sp>
-        <p:nvSpPr>
-          <p:cNvPr id="3" name="Text 0"/>
-          <p:cNvSpPr/>
-          <p:nvPr>
-            <p:ph idx="100" type="title" hasCustomPrompt="1"/>
-          </p:nvPr>
-        </p:nvSpPr>
-        <p:spPr>
-          <a:xfrm>
-            <a:off x="548640" y="713232"/>
-            <a:ext cx="11094415" cy="822960"/>
-          </a:xfrm>
-          <a:prstGeom prst="rect">
-            <a:avLst/>
-          </a:prstGeom>
-          <a:noFill/>
-          <a:ln/>
-        </p:spPr>
-        <p:txBody>
-          <a:bodyPr wrap="square" lIns="0" tIns="0" rIns="0" bIns="0" rtlCol="0" anchor="t"/>
-          <a:lstStyle/>
-          <a:p>
-            <a:pPr algn="l" indent="0" marL="0">
-              <a:buNone/>
-            </a:pPr>
-            <a:r>
-              <a:rPr lang="en-US" sz="3400" b="1" dirty="0">
-                <a:solidFill>
-                  <a:srgbClr val="F3F0E8"/>
-                </a:solidFill>
-                <a:latin typeface="Century Gothic" pitchFamily="34" charset="0"/>
-                <a:ea typeface="Century Gothic" pitchFamily="34" charset="-122"/>
-                <a:cs typeface="Century Gothic" pitchFamily="34" charset="-120"/>
-              </a:rPr>
-              <a:t>Spec in. Strategy out. Never a forfeit.</a:t>
-            </a:r>
-            <a:endParaRPr lang="en-US" sz="3400" dirty="0"/>
-          </a:p>
-        </p:txBody>
-      </p:sp>
-      <p:sp>
-        <p:nvSpPr>
-          <p:cNvPr id="4" name="axis"/>
-          <p:cNvSpPr/>
-          <p:nvPr/>
-        </p:nvSpPr>
-        <p:spPr>
-          <a:xfrm>
-            <a:off x="822960" y="3429000"/>
-            <a:ext cx="10515600" cy="91440"/>
-          </a:xfrm>
-          <a:prstGeom prst="roundRect">
-            <a:avLst>
-              <a:gd name="adj" fmla="val 50000"/>
-            </a:avLst>
-          </a:prstGeom>
-          <a:solidFill>
-            <a:srgbClr val="2A313C"/>
-          </a:solidFill>
-          <a:ln w="12700">
-            <a:solidFill>
-              <a:srgbClr val="2A313C"/>
-            </a:solidFill>
-            <a:prstDash val="solid"/>
-          </a:ln>
-        </p:spPr>
-      </p:sp>
-      <p:sp>
-        <p:nvSpPr>
-          <p:cNvPr id="5" name="progress"/>
-          <p:cNvSpPr/>
-          <p:nvPr/>
-        </p:nvSpPr>
-        <p:spPr>
-          <a:xfrm>
-            <a:off x="822960" y="3429000"/>
-            <a:ext cx="8237220" cy="91440"/>
-          </a:xfrm>
-          <a:prstGeom prst="roundRect">
-            <a:avLst>
-              <a:gd name="adj" fmla="val 50000"/>
-            </a:avLst>
-          </a:prstGeom>
-          <a:solidFill>
-            <a:srgbClr val="FF7A33"/>
-          </a:solidFill>
-          <a:ln w="12700">
-            <a:solidFill>
-              <a:srgbClr val="FF7A33"/>
-            </a:solidFill>
-            <a:prstDash val="solid"/>
-          </a:ln>
-        </p:spPr>
-      </p:sp>
-      <p:sp>
-        <p:nvSpPr>
-          <p:cNvPr id="6" name="Text 4"/>
-          <p:cNvSpPr txBox="1"/>
-          <p:nvPr/>
-        </p:nvSpPr>
-        <p:spPr>
-          <a:xfrm>
-            <a:off x="548640" y="3657600"/>
-            <a:ext cx="548640" cy="274320"/>
-          </a:xfrm>
-          <a:prstGeom prst="rect">
-            <a:avLst/>
-          </a:prstGeom>
-          <a:noFill/>
-          <a:ln/>
-        </p:spPr>
-        <p:txBody>
-          <a:bodyPr wrap="square" lIns="0" tIns="0" rIns="0" bIns="0" rtlCol="0" anchor="ctr"/>
-          <a:lstStyle/>
-          <a:p>
-            <a:pPr algn="ctr" indent="0" marL="0">
-              <a:buNone/>
-            </a:pPr>
-            <a:r>
-              <a:rPr lang="en-US" sz="1200" dirty="0">
-                <a:solidFill>
-                  <a:srgbClr val="7D8694"/>
-                </a:solidFill>
-                <a:latin typeface="Consolas" pitchFamily="34" charset="0"/>
-                <a:ea typeface="Consolas" pitchFamily="34" charset="-122"/>
-                <a:cs typeface="Consolas" pitchFamily="34" charset="-120"/>
-              </a:rPr>
-              <a:t>0 s</a:t>
-            </a:r>
-            <a:endParaRPr lang="en-US" sz="1200" dirty="0"/>
-          </a:p>
-        </p:txBody>
-      </p:sp>
-      <p:sp>
-        <p:nvSpPr>
-          <p:cNvPr id="7" name="Text 5"/>
-          <p:cNvSpPr txBox="1"/>
-          <p:nvPr/>
-        </p:nvSpPr>
-        <p:spPr>
-          <a:xfrm>
-            <a:off x="9692640" y="3657600"/>
-            <a:ext cx="1645920" cy="274320"/>
-          </a:xfrm>
-          <a:prstGeom prst="rect">
-            <a:avLst/>
-          </a:prstGeom>
-          <a:noFill/>
-          <a:ln/>
-        </p:spPr>
-        <p:txBody>
-          <a:bodyPr wrap="square" lIns="0" tIns="0" rIns="0" bIns="0" rtlCol="0" anchor="ctr"/>
-          <a:lstStyle/>
-          <a:p>
-            <a:pPr algn="r" indent="0" marL="0">
-              <a:buNone/>
-            </a:pPr>
-            <a:r>
-              <a:rPr lang="en-US" sz="1200" dirty="0">
-                <a:solidFill>
-                  <a:srgbClr val="7D8694"/>
-                </a:solidFill>
-                <a:latin typeface="Consolas" pitchFamily="34" charset="0"/>
-                <a:ea typeface="Consolas" pitchFamily="34" charset="-122"/>
-                <a:cs typeface="Consolas" pitchFamily="34" charset="-120"/>
-              </a:rPr>
-              <a:t>deadline 180 s</a:t>
-            </a:r>
-            <a:endParaRPr lang="en-US" sz="1200" dirty="0"/>
-          </a:p>
-        </p:txBody>
-      </p:sp>
-      <p:sp>
-        <p:nvSpPr>
-          <p:cNvPr id="8" name="event 24"/>
-          <p:cNvSpPr/>
-          <p:nvPr/>
-        </p:nvSpPr>
-        <p:spPr>
-          <a:xfrm>
-            <a:off x="2124456" y="3374136"/>
-            <a:ext cx="201168" cy="201168"/>
-          </a:xfrm>
-          <a:prstGeom prst="ellipse">
-            <a:avLst/>
-          </a:prstGeom>
-          <a:solidFill>
-            <a:srgbClr val="FF7A33"/>
-          </a:solidFill>
-          <a:ln w="25400">
-            <a:solidFill>
-              <a:srgbClr val="FF7A33"/>
-            </a:solidFill>
-            <a:prstDash val="solid"/>
-          </a:ln>
-        </p:spPr>
-      </p:sp>
-      <p:sp>
-        <p:nvSpPr>
-          <p:cNvPr id="9" name="Text 7"/>
-          <p:cNvSpPr txBox="1"/>
-          <p:nvPr/>
-        </p:nvSpPr>
-        <p:spPr>
-          <a:xfrm>
-            <a:off x="2124456" y="2331720"/>
-            <a:ext cx="1097280" cy="292608"/>
-          </a:xfrm>
-          <a:prstGeom prst="rect">
-            <a:avLst/>
-          </a:prstGeom>
-          <a:noFill/>
-          <a:ln/>
-        </p:spPr>
-        <p:txBody>
-          <a:bodyPr wrap="square" lIns="0" tIns="0" rIns="0" bIns="0" rtlCol="0" anchor="ctr"/>
-          <a:lstStyle/>
-          <a:p>
-            <a:pPr indent="0" marL="0">
-              <a:buNone/>
-            </a:pPr>
-            <a:r>
-              <a:rPr lang="en-US" sz="1400" b="1" dirty="0">
-                <a:solidFill>
-                  <a:srgbClr val="FF7A33"/>
-                </a:solidFill>
-                <a:latin typeface="Consolas" pitchFamily="34" charset="0"/>
-                <a:ea typeface="Consolas" pitchFamily="34" charset="-122"/>
-                <a:cs typeface="Consolas" pitchFamily="34" charset="-120"/>
-              </a:rPr>
-              <a:t>24 s</a:t>
-            </a:r>
-            <a:endParaRPr lang="en-US" sz="1400" dirty="0"/>
-          </a:p>
-        </p:txBody>
-      </p:sp>
-      <p:sp>
-        <p:nvSpPr>
-          <p:cNvPr id="10" name="Text 8"/>
-          <p:cNvSpPr txBox="1"/>
-          <p:nvPr/>
-        </p:nvSpPr>
-        <p:spPr>
-          <a:xfrm>
-            <a:off x="2124456" y="2642616"/>
-            <a:ext cx="2148840" cy="548640"/>
-          </a:xfrm>
-          <a:prstGeom prst="rect">
-            <a:avLst/>
-          </a:prstGeom>
-          <a:noFill/>
-          <a:ln/>
-        </p:spPr>
-        <p:txBody>
-          <a:bodyPr wrap="square" lIns="0" tIns="0" rIns="0" bIns="0" rtlCol="0" anchor="t"/>
-          <a:lstStyle/>
-          <a:p>
-            <a:pPr indent="0" marL="0">
-              <a:buNone/>
-            </a:pPr>
-            <a:r>
-              <a:rPr lang="en-US" sz="1400" dirty="0">
-                <a:solidFill>
-                  <a:srgbClr val="F3F0E8"/>
-                </a:solidFill>
-                <a:latin typeface="Calibri" pitchFamily="34" charset="0"/>
-                <a:ea typeface="Calibri" pitchFamily="34" charset="-122"/>
-                <a:cs typeface="Calibri" pitchFamily="34" charset="-120"/>
-              </a:rPr>
-              <a:t>first draft leads</a:t>
-            </a:r>
-            <a:endParaRPr lang="en-US" sz="1400" dirty="0"/>
-          </a:p>
-        </p:txBody>
-      </p:sp>
-      <p:sp>
-        <p:nvSpPr>
-          <p:cNvPr id="11" name="event 35"/>
-          <p:cNvSpPr/>
-          <p:nvPr/>
-        </p:nvSpPr>
-        <p:spPr>
-          <a:xfrm>
-            <a:off x="2767076" y="3374136"/>
-            <a:ext cx="201168" cy="201168"/>
-          </a:xfrm>
-          <a:prstGeom prst="ellipse">
-            <a:avLst/>
-          </a:prstGeom>
-          <a:solidFill>
-            <a:srgbClr val="0F1218"/>
-          </a:solidFill>
-          <a:ln w="25400">
-            <a:solidFill>
-              <a:srgbClr val="FF7A33"/>
-            </a:solidFill>
-            <a:prstDash val="solid"/>
-          </a:ln>
-        </p:spPr>
-      </p:sp>
-      <p:sp>
-        <p:nvSpPr>
-          <p:cNvPr id="12" name="Text 10"/>
-          <p:cNvSpPr txBox="1"/>
-          <p:nvPr/>
-        </p:nvSpPr>
-        <p:spPr>
-          <a:xfrm>
-            <a:off x="2767076" y="3977640"/>
-            <a:ext cx="1097280" cy="292608"/>
-          </a:xfrm>
-          <a:prstGeom prst="rect">
-            <a:avLst/>
-          </a:prstGeom>
-          <a:noFill/>
-          <a:ln/>
-        </p:spPr>
-        <p:txBody>
-          <a:bodyPr wrap="square" lIns="0" tIns="0" rIns="0" bIns="0" rtlCol="0" anchor="ctr"/>
-          <a:lstStyle/>
-          <a:p>
-            <a:pPr indent="0" marL="0">
-              <a:buNone/>
-            </a:pPr>
-            <a:r>
-              <a:rPr lang="en-US" sz="1400" b="1" dirty="0">
-                <a:solidFill>
-                  <a:srgbClr val="FF7A33"/>
-                </a:solidFill>
-                <a:latin typeface="Consolas" pitchFamily="34" charset="0"/>
-                <a:ea typeface="Consolas" pitchFamily="34" charset="-122"/>
-                <a:cs typeface="Consolas" pitchFamily="34" charset="-120"/>
-              </a:rPr>
-              <a:t>35 s</a:t>
-            </a:r>
-            <a:endParaRPr lang="en-US" sz="1400" dirty="0"/>
-          </a:p>
-        </p:txBody>
-      </p:sp>
-      <p:sp>
-        <p:nvSpPr>
-          <p:cNvPr id="13" name="Text 11"/>
-          <p:cNvSpPr txBox="1"/>
-          <p:nvPr/>
-        </p:nvSpPr>
-        <p:spPr>
-          <a:xfrm>
-            <a:off x="2767076" y="4288536"/>
-            <a:ext cx="2148840" cy="548640"/>
-          </a:xfrm>
-          <a:prstGeom prst="rect">
-            <a:avLst/>
-          </a:prstGeom>
-          <a:noFill/>
-          <a:ln/>
-        </p:spPr>
-        <p:txBody>
-          <a:bodyPr wrap="square" lIns="0" tIns="0" rIns="0" bIns="0" rtlCol="0" anchor="t"/>
-          <a:lstStyle/>
-          <a:p>
-            <a:pPr indent="0" marL="0">
-              <a:buNone/>
-            </a:pPr>
-            <a:r>
-              <a:rPr lang="en-US" sz="1400" dirty="0">
-                <a:solidFill>
-                  <a:srgbClr val="F3F0E8"/>
-                </a:solidFill>
-                <a:latin typeface="Calibri" pitchFamily="34" charset="0"/>
-                <a:ea typeface="Calibri" pitchFamily="34" charset="-122"/>
-                <a:cs typeface="Calibri" pitchFamily="34" charset="-120"/>
-              </a:rPr>
-              <a:t>simulator fails a check</a:t>
-            </a:r>
-            <a:endParaRPr lang="en-US" sz="1400" dirty="0"/>
-          </a:p>
-        </p:txBody>
-      </p:sp>
-      <p:sp>
-        <p:nvSpPr>
-          <p:cNvPr id="14" name="event 68"/>
-          <p:cNvSpPr/>
-          <p:nvPr/>
-        </p:nvSpPr>
-        <p:spPr>
-          <a:xfrm>
-            <a:off x="4694936" y="3374136"/>
-            <a:ext cx="201168" cy="201168"/>
-          </a:xfrm>
-          <a:prstGeom prst="ellipse">
-            <a:avLst/>
-          </a:prstGeom>
-          <a:solidFill>
-            <a:srgbClr val="FF7A33"/>
-          </a:solidFill>
-          <a:ln w="25400">
-            <a:solidFill>
-              <a:srgbClr val="FF7A33"/>
-            </a:solidFill>
-            <a:prstDash val="solid"/>
-          </a:ln>
-        </p:spPr>
-      </p:sp>
-      <p:sp>
-        <p:nvSpPr>
-          <p:cNvPr id="15" name="Text 13"/>
-          <p:cNvSpPr txBox="1"/>
-          <p:nvPr/>
-        </p:nvSpPr>
-        <p:spPr>
-          <a:xfrm>
-            <a:off x="4694936" y="2331720"/>
-            <a:ext cx="1097280" cy="292608"/>
-          </a:xfrm>
-          <a:prstGeom prst="rect">
-            <a:avLst/>
-          </a:prstGeom>
-          <a:noFill/>
-          <a:ln/>
-        </p:spPr>
-        <p:txBody>
-          <a:bodyPr wrap="square" lIns="0" tIns="0" rIns="0" bIns="0" rtlCol="0" anchor="ctr"/>
-          <a:lstStyle/>
-          <a:p>
-            <a:pPr indent="0" marL="0">
-              <a:buNone/>
-            </a:pPr>
-            <a:r>
-              <a:rPr lang="en-US" sz="1400" b="1" dirty="0">
-                <a:solidFill>
-                  <a:srgbClr val="FF7A33"/>
-                </a:solidFill>
-                <a:latin typeface="Consolas" pitchFamily="34" charset="0"/>
-                <a:ea typeface="Consolas" pitchFamily="34" charset="-122"/>
-                <a:cs typeface="Consolas" pitchFamily="34" charset="-120"/>
-              </a:rPr>
-              <a:t>68 s</a:t>
-            </a:r>
-            <a:endParaRPr lang="en-US" sz="1400" dirty="0"/>
-          </a:p>
-        </p:txBody>
-      </p:sp>
-      <p:sp>
-        <p:nvSpPr>
-          <p:cNvPr id="16" name="Text 14"/>
-          <p:cNvSpPr txBox="1"/>
-          <p:nvPr/>
-        </p:nvSpPr>
-        <p:spPr>
-          <a:xfrm>
-            <a:off x="4694936" y="2642616"/>
-            <a:ext cx="2148840" cy="548640"/>
-          </a:xfrm>
-          <a:prstGeom prst="rect">
-            <a:avLst/>
-          </a:prstGeom>
-          <a:noFill/>
-          <a:ln/>
-        </p:spPr>
-        <p:txBody>
-          <a:bodyPr wrap="square" lIns="0" tIns="0" rIns="0" bIns="0" rtlCol="0" anchor="t"/>
-          <a:lstStyle/>
-          <a:p>
-            <a:pPr indent="0" marL="0">
-              <a:buNone/>
-            </a:pPr>
-            <a:r>
-              <a:rPr lang="en-US" sz="1400" dirty="0">
-                <a:solidFill>
-                  <a:srgbClr val="F3F0E8"/>
-                </a:solidFill>
-                <a:latin typeface="Calibri" pitchFamily="34" charset="0"/>
-                <a:ea typeface="Calibri" pitchFamily="34" charset="-122"/>
-                <a:cs typeface="Calibri" pitchFamily="34" charset="-120"/>
-              </a:rPr>
-              <a:t>simulator repaired</a:t>
-            </a:r>
-            <a:endParaRPr lang="en-US" sz="1400" dirty="0"/>
-          </a:p>
-        </p:txBody>
-      </p:sp>
-      <p:sp>
-        <p:nvSpPr>
-          <p:cNvPr id="17" name="event 98"/>
-          <p:cNvSpPr/>
-          <p:nvPr/>
-        </p:nvSpPr>
-        <p:spPr>
-          <a:xfrm>
-            <a:off x="6447536" y="3374136"/>
-            <a:ext cx="201168" cy="201168"/>
-          </a:xfrm>
-          <a:prstGeom prst="ellipse">
-            <a:avLst/>
-          </a:prstGeom>
-          <a:solidFill>
-            <a:srgbClr val="FF7A33"/>
-          </a:solidFill>
-          <a:ln w="25400">
-            <a:solidFill>
-              <a:srgbClr val="FF7A33"/>
-            </a:solidFill>
-            <a:prstDash val="solid"/>
-          </a:ln>
-        </p:spPr>
-      </p:sp>
-      <p:sp>
-        <p:nvSpPr>
-          <p:cNvPr id="18" name="Text 16"/>
-          <p:cNvSpPr txBox="1"/>
-          <p:nvPr/>
-        </p:nvSpPr>
-        <p:spPr>
-          <a:xfrm>
-            <a:off x="6447536" y="3977640"/>
-            <a:ext cx="1097280" cy="292608"/>
-          </a:xfrm>
-          <a:prstGeom prst="rect">
-            <a:avLst/>
-          </a:prstGeom>
-          <a:noFill/>
-          <a:ln/>
-        </p:spPr>
-        <p:txBody>
-          <a:bodyPr wrap="square" lIns="0" tIns="0" rIns="0" bIns="0" rtlCol="0" anchor="ctr"/>
-          <a:lstStyle/>
-          <a:p>
-            <a:pPr indent="0" marL="0">
-              <a:buNone/>
-            </a:pPr>
-            <a:r>
-              <a:rPr lang="en-US" sz="1400" b="1" dirty="0">
-                <a:solidFill>
-                  <a:srgbClr val="FF7A33"/>
-                </a:solidFill>
-                <a:latin typeface="Consolas" pitchFamily="34" charset="0"/>
-                <a:ea typeface="Consolas" pitchFamily="34" charset="-122"/>
-                <a:cs typeface="Consolas" pitchFamily="34" charset="-120"/>
-              </a:rPr>
-              <a:t>98 s</a:t>
-            </a:r>
-            <a:endParaRPr lang="en-US" sz="1400" dirty="0"/>
-          </a:p>
-        </p:txBody>
-      </p:sp>
-      <p:sp>
-        <p:nvSpPr>
-          <p:cNvPr id="19" name="Text 17"/>
-          <p:cNvSpPr txBox="1"/>
-          <p:nvPr/>
-        </p:nvSpPr>
-        <p:spPr>
-          <a:xfrm>
-            <a:off x="6447536" y="4288536"/>
-            <a:ext cx="2148840" cy="548640"/>
-          </a:xfrm>
-          <a:prstGeom prst="rect">
-            <a:avLst/>
-          </a:prstGeom>
-          <a:noFill/>
-          <a:ln/>
-        </p:spPr>
-        <p:txBody>
-          <a:bodyPr wrap="square" lIns="0" tIns="0" rIns="0" bIns="0" rtlCol="0" anchor="t"/>
-          <a:lstStyle/>
-          <a:p>
-            <a:pPr indent="0" marL="0">
-              <a:buNone/>
-            </a:pPr>
-            <a:r>
-              <a:rPr lang="en-US" sz="1400" dirty="0">
-                <a:solidFill>
-                  <a:srgbClr val="F3F0E8"/>
-                </a:solidFill>
-                <a:latin typeface="Calibri" pitchFamily="34" charset="0"/>
-                <a:ea typeface="Calibri" pitchFamily="34" charset="-122"/>
-                <a:cs typeface="Calibri" pitchFamily="34" charset="-120"/>
-              </a:rPr>
-              <a:t>self-play ranking</a:t>
-            </a:r>
-            <a:endParaRPr lang="en-US" sz="1400" dirty="0"/>
-          </a:p>
-        </p:txBody>
-      </p:sp>
-      <p:sp>
-        <p:nvSpPr>
-          <p:cNvPr id="20" name="event 133"/>
-          <p:cNvSpPr/>
-          <p:nvPr/>
-        </p:nvSpPr>
-        <p:spPr>
-          <a:xfrm>
-            <a:off x="8492236" y="3374136"/>
-            <a:ext cx="201168" cy="201168"/>
-          </a:xfrm>
-          <a:prstGeom prst="ellipse">
-            <a:avLst/>
-          </a:prstGeom>
-          <a:solidFill>
-            <a:srgbClr val="FF7A33"/>
-          </a:solidFill>
-          <a:ln w="25400">
-            <a:solidFill>
-              <a:srgbClr val="FF7A33"/>
-            </a:solidFill>
-            <a:prstDash val="solid"/>
-          </a:ln>
-        </p:spPr>
-      </p:sp>
-      <p:sp>
-        <p:nvSpPr>
-          <p:cNvPr id="21" name="Text 19"/>
-          <p:cNvSpPr txBox="1"/>
-          <p:nvPr/>
-        </p:nvSpPr>
-        <p:spPr>
-          <a:xfrm>
-            <a:off x="8492236" y="2331720"/>
-            <a:ext cx="1097280" cy="292608"/>
-          </a:xfrm>
-          <a:prstGeom prst="rect">
-            <a:avLst/>
-          </a:prstGeom>
-          <a:noFill/>
-          <a:ln/>
-        </p:spPr>
-        <p:txBody>
-          <a:bodyPr wrap="square" lIns="0" tIns="0" rIns="0" bIns="0" rtlCol="0" anchor="ctr"/>
-          <a:lstStyle/>
-          <a:p>
-            <a:pPr indent="0" marL="0">
-              <a:buNone/>
-            </a:pPr>
-            <a:r>
-              <a:rPr lang="en-US" sz="1400" b="1" dirty="0">
-                <a:solidFill>
-                  <a:srgbClr val="FF7A33"/>
-                </a:solidFill>
-                <a:latin typeface="Consolas" pitchFamily="34" charset="0"/>
-                <a:ea typeface="Consolas" pitchFamily="34" charset="-122"/>
-                <a:cs typeface="Consolas" pitchFamily="34" charset="-120"/>
-              </a:rPr>
-              <a:t>133 s</a:t>
-            </a:r>
-            <a:endParaRPr lang="en-US" sz="1400" dirty="0"/>
-          </a:p>
-        </p:txBody>
-      </p:sp>
-      <p:sp>
-        <p:nvSpPr>
-          <p:cNvPr id="22" name="Text 20"/>
-          <p:cNvSpPr txBox="1"/>
-          <p:nvPr/>
-        </p:nvSpPr>
-        <p:spPr>
-          <a:xfrm>
-            <a:off x="8492236" y="2642616"/>
-            <a:ext cx="2148840" cy="548640"/>
-          </a:xfrm>
-          <a:prstGeom prst="rect">
-            <a:avLst/>
-          </a:prstGeom>
-          <a:noFill/>
-          <a:ln/>
-        </p:spPr>
-        <p:txBody>
-          <a:bodyPr wrap="square" lIns="0" tIns="0" rIns="0" bIns="0" rtlCol="0" anchor="t"/>
-          <a:lstStyle/>
-          <a:p>
-            <a:pPr indent="0" marL="0">
-              <a:buNone/>
-            </a:pPr>
-            <a:r>
-              <a:rPr lang="en-US" sz="1400" dirty="0">
-                <a:solidFill>
-                  <a:srgbClr val="F3F0E8"/>
-                </a:solidFill>
-                <a:latin typeface="Calibri" pitchFamily="34" charset="0"/>
-                <a:ea typeface="Calibri" pitchFamily="34" charset="-122"/>
-                <a:cs typeface="Calibri" pitchFamily="34" charset="-120"/>
-              </a:rPr>
-              <a:t>a challenger joins</a:t>
-            </a:r>
-            <a:endParaRPr lang="en-US" sz="1400" dirty="0"/>
-          </a:p>
-        </p:txBody>
-      </p:sp>
-      <p:sp>
-        <p:nvSpPr>
-          <p:cNvPr id="23" name="event 141"/>
-          <p:cNvSpPr/>
-          <p:nvPr/>
-        </p:nvSpPr>
-        <p:spPr>
-          <a:xfrm>
-            <a:off x="8959596" y="3374136"/>
-            <a:ext cx="201168" cy="201168"/>
-          </a:xfrm>
-          <a:prstGeom prst="ellipse">
-            <a:avLst/>
-          </a:prstGeom>
-          <a:solidFill>
-            <a:srgbClr val="FF7A33"/>
-          </a:solidFill>
-          <a:ln w="25400">
-            <a:solidFill>
-              <a:srgbClr val="FF7A33"/>
-            </a:solidFill>
-            <a:prstDash val="solid"/>
-          </a:ln>
-        </p:spPr>
-      </p:sp>
-      <p:sp>
-        <p:nvSpPr>
-          <p:cNvPr id="24" name="Text 22"/>
-          <p:cNvSpPr txBox="1"/>
-          <p:nvPr/>
-        </p:nvSpPr>
-        <p:spPr>
-          <a:xfrm>
-            <a:off x="8959596" y="3977640"/>
-            <a:ext cx="1097280" cy="292608"/>
-          </a:xfrm>
-          <a:prstGeom prst="rect">
-            <a:avLst/>
-          </a:prstGeom>
-          <a:noFill/>
-          <a:ln/>
-        </p:spPr>
-        <p:txBody>
-          <a:bodyPr wrap="square" lIns="0" tIns="0" rIns="0" bIns="0" rtlCol="0" anchor="ctr"/>
-          <a:lstStyle/>
-          <a:p>
-            <a:pPr indent="0" marL="0">
-              <a:buNone/>
-            </a:pPr>
-            <a:r>
-              <a:rPr lang="en-US" sz="1400" b="1" dirty="0">
-                <a:solidFill>
-                  <a:srgbClr val="FF7A33"/>
-                </a:solidFill>
-                <a:latin typeface="Consolas" pitchFamily="34" charset="0"/>
-                <a:ea typeface="Consolas" pitchFamily="34" charset="-122"/>
-                <a:cs typeface="Consolas" pitchFamily="34" charset="-120"/>
-              </a:rPr>
-              <a:t>141 s</a:t>
-            </a:r>
-            <a:endParaRPr lang="en-US" sz="1400" dirty="0"/>
-          </a:p>
-        </p:txBody>
-      </p:sp>
-      <p:sp>
-        <p:nvSpPr>
-          <p:cNvPr id="25" name="Text 23"/>
-          <p:cNvSpPr txBox="1"/>
-          <p:nvPr/>
-        </p:nvSpPr>
-        <p:spPr>
-          <a:xfrm>
-            <a:off x="8959596" y="4288536"/>
-            <a:ext cx="2148840" cy="548640"/>
-          </a:xfrm>
-          <a:prstGeom prst="rect">
-            <a:avLst/>
-          </a:prstGeom>
-          <a:noFill/>
-          <a:ln/>
-        </p:spPr>
-        <p:txBody>
-          <a:bodyPr wrap="square" lIns="0" tIns="0" rIns="0" bIns="0" rtlCol="0" anchor="t"/>
-          <a:lstStyle/>
-          <a:p>
-            <a:pPr indent="0" marL="0">
-              <a:buNone/>
-            </a:pPr>
-            <a:r>
-              <a:rPr lang="en-US" sz="1400" dirty="0">
-                <a:solidFill>
-                  <a:srgbClr val="F3F0E8"/>
-                </a:solidFill>
-                <a:latin typeface="Calibri" pitchFamily="34" charset="0"/>
-                <a:ea typeface="Calibri" pitchFamily="34" charset="-122"/>
-                <a:cs typeface="Calibri" pitchFamily="34" charset="-120"/>
-              </a:rPr>
-              <a:t>strategy delivered</a:t>
-            </a:r>
-            <a:endParaRPr lang="en-US" sz="1400" dirty="0"/>
-          </a:p>
-        </p:txBody>
-      </p:sp>
-      <p:sp>
-        <p:nvSpPr>
-          <p:cNvPr id="26" name="Text 24"/>
-          <p:cNvSpPr txBox="1"/>
-          <p:nvPr/>
-        </p:nvSpPr>
-        <p:spPr>
-          <a:xfrm>
-            <a:off x="548640" y="5486400"/>
-            <a:ext cx="11094415" cy="685800"/>
-          </a:xfrm>
-          <a:prstGeom prst="rect">
-            <a:avLst/>
-          </a:prstGeom>
-          <a:noFill/>
-          <a:ln/>
-        </p:spPr>
-        <p:txBody>
-          <a:bodyPr wrap="square" lIns="0" tIns="0" rIns="0" bIns="0" rtlCol="0" anchor="t"/>
-          <a:lstStyle/>
-          <a:p>
-            <a:pPr indent="0" marL="0">
-              <a:buNone/>
-            </a:pPr>
-            <a:r>
-              <a:rPr lang="en-US" sz="1500" b="1" dirty="0">
-                <a:solidFill>
-                  <a:srgbClr val="F3F0E8"/>
-                </a:solidFill>
-                <a:latin typeface="Calibri" pitchFamily="34" charset="0"/>
-                <a:ea typeface="Calibri" pitchFamily="34" charset="-122"/>
-                <a:cs typeface="Calibri" pitchFamily="34" charset="-120"/>
-              </a:rPr>
-              <a:t>141 seconds, 1.8 cents, one champion.  </a:t>
-            </a:r>
-            <a:pPr indent="0" marL="0">
-              <a:buNone/>
-            </a:pPr>
-            <a:r>
-              <a:rPr lang="en-US" sz="1500" dirty="0">
-                <a:solidFill>
-                  <a:srgbClr val="AEB6C2"/>
-                </a:solidFill>
-                <a:latin typeface="Calibri" pitchFamily="34" charset="0"/>
-                <a:ea typeface="Calibri" pitchFamily="34" charset="-122"/>
-                <a:cs typeface="Calibri" pitchFamily="34" charset="-120"/>
-              </a:rPr>
-              <a:t>A real task-A run in the evaluation’s container: drafts written, the simulator checked against the spec and repaired, drafts ranked by self-play, a challenger tried, the champion delivered well before the deadline.</a:t>
-            </a:r>
-            <a:endParaRPr lang="en-US" sz="1500" dirty="0"/>
-          </a:p>
-        </p:txBody>
-      </p:sp>
-      <p:sp>
-        <p:nvSpPr>
-          <p:cNvPr id="25" name="Slide Number Placeholder 0"/>
-          <p:cNvSpPr>
-            <a:spLocks noGrp="1"/>
-          </p:cNvSpPr>
-          <p:nvPr>
-            <p:ph type="sldNum" sz="quarter" idx="4294967295"/>
-          </p:nvPr>
-        </p:nvSpPr>
-        <p:spPr>
-          <a:xfrm>
-            <a:off x="11094415" y="6355080"/>
-            <a:ext cx="548640" cy="274320"/>
-          </a:xfrm>
-          <a:prstGeom prst="rect">
-            <a:avLst/>
-          </a:prstGeom>
-          <a:extLst>
-            <a:ext uri="{C572A759-6A51-4108-AA02-DFA0A04FC94B}">
-              <ma14:wrappingTextBoxFlag xmlns:ma14="http://schemas.microsoft.com/office/mac/drawingml/2011/main" val="0"/>
-            </a:ext>
-          </a:extLst>
-        </p:spPr>
-        <p:txBody>
-          <a:bodyPr/>
-          <a:lstStyle>
-            <a:lvl1pPr>
-              <a:defRPr sz="1100">
-                <a:solidFill>
-                  <a:srgbClr val="7D8694"/>
-                </a:solidFill>
-                <a:latin typeface="Consolas"/>
-                <a:ea typeface="Consolas"/>
-                <a:cs typeface="Consolas"/>
-              </a:defRPr>
-            </a:lvl1pPr>
-          </a:lstStyle>
-          <a:p>
-            <a:pPr algn="r"/>
-            <a:fld id="{F7021451-1387-4CA6-816F-3879F97B5CBC}" type="slidenum">
-              <a:rPr b="0" lang="en-US"/>
-              <a:t>5</a:t>
-            </a:fld>
-            <a:endParaRPr lang="en-US"/>
-          </a:p>
-        </p:txBody>
-      </p:sp>
-    </p:spTree>
-  </p:cSld>
-  <p:clrMapOvr>
-    <a:masterClrMapping/>
-  </p:clrMapOvr>
-</p:sld>
-</file>
-
-<file path=ppt/slides/slide6.xml><?xml version="1.0" encoding="utf-8"?>
-<p:sld xmlns:a="http://schemas.openxmlformats.org/drawingml/2006/main" xmlns:r="http://schemas.openxmlformats.org/officeDocument/2006/relationships" xmlns:p="http://schemas.openxmlformats.org/presentationml/2006/main">
-  <p:cSld name="Slide 6">
     <p:spTree>
       <p:nvGrpSpPr>
         <p:cNvPr id="1" name=""/>

</xml_diff>